<commit_message>
docs: single connected workflow chart (replaces per-component slides)
Rework the overview deck into one large end-to-end flowchart: users/roles →
login → web app ↔ Supabase (+ tables, daily backups); the in-app actions
(add/import, browse, owner-scoped My colony); and the request → route →
approve (Manager/PI) → notify → Edge Function/Resend email lane. Emphasizes why
different roles see/do different things. Regenerable via make_overview_pptx.py.

Co-Authored-By: Claude Opus 4.8 (1M context) <noreply@anthropic.com>
</commit_message>
<xml_diff>
--- a/docs/Colony_DB_Overview.pptx
+++ b/docs/Colony_DB_Overview.pptx
@@ -7,10 +7,6 @@
   <p:sldIdLst>
     <p:sldId id="256" r:id="rId7"/>
     <p:sldId id="257" r:id="rId8"/>
-    <p:sldId id="258" r:id="rId9"/>
-    <p:sldId id="259" r:id="rId10"/>
-    <p:sldId id="260" r:id="rId11"/>
-    <p:sldId id="261" r:id="rId12"/>
   </p:sldIdLst>
   <p:sldSz cx="12191695" cy="6858000" type="screen4x3"/>
   <p:notesSz cx="6858000" cy="9144000"/>
@@ -3113,6 +3109,7 @@
           <a:ln>
             <a:noFill/>
           </a:ln>
+          <a:effectLst/>
         </p:spPr>
         <p:style>
           <a:lnRef idx="1">
@@ -3144,7 +3141,7 @@
         </p:nvSpPr>
         <p:spPr>
           <a:xfrm>
-            <a:off x="914400" y="2194560"/>
+            <a:off x="914400" y="2377440"/>
             <a:ext cx="10332720" cy="1097280"/>
           </a:xfrm>
           <a:prstGeom prst="rect">
@@ -3179,7 +3176,7 @@
         </p:nvSpPr>
         <p:spPr>
           <a:xfrm>
-            <a:off x="914400" y="3383280"/>
+            <a:off x="914400" y="3566160"/>
             <a:ext cx="10332720" cy="731520"/>
           </a:xfrm>
           <a:prstGeom prst="rect">
@@ -3201,42 +3198,7 @@
                 </a:solidFill>
                 <a:latin typeface="Calibri"/>
               </a:rPr>
-              <a:t>How it works — architecture, multi-user access &amp; email notifications</a:t>
-            </a:r>
-          </a:p>
-        </p:txBody>
-      </p:sp>
-      <p:sp>
-        <p:nvSpPr>
-          <p:cNvPr id="5" name="TextBox 4"/>
-          <p:cNvSpPr txBox="1"/>
-          <p:nvPr/>
-        </p:nvSpPr>
-        <p:spPr>
-          <a:xfrm>
-            <a:off x="914400" y="4754880"/>
-            <a:ext cx="10332720" cy="548640"/>
-          </a:xfrm>
-          <a:prstGeom prst="rect">
-            <a:avLst/>
-          </a:prstGeom>
-          <a:noFill/>
-        </p:spPr>
-        <p:txBody>
-          <a:bodyPr wrap="square" anchor="t">
-            <a:spAutoFit/>
-          </a:bodyPr>
-          <a:lstStyle/>
-          <a:p>
-            <a:pPr algn="ctr"/>
-            <a:r>
-              <a:rPr sz="1400" b="0" i="0">
-                <a:solidFill>
-                  <a:srgbClr val="9FB4E0"/>
-                </a:solidFill>
-                <a:latin typeface="Calibri"/>
-              </a:rPr>
-              <a:t>Single-page web app  +  Supabase (Postgres)  •  hosted free on GitHub Pages  •  daily backups</a:t>
+              <a:t>How it works, end to end — and why different users see different things</a:t>
             </a:r>
           </a:p>
         </p:txBody>
@@ -3268,7 +3230,7 @@
         <p:spPr>
           <a:xfrm>
             <a:off x="0" y="0"/>
-            <a:ext cx="12191695" cy="960120"/>
+            <a:ext cx="12191695" cy="685800"/>
           </a:xfrm>
           <a:prstGeom prst="rect">
             <a:avLst/>
@@ -3279,6 +3241,7 @@
           <a:ln>
             <a:noFill/>
           </a:ln>
+          <a:effectLst/>
         </p:spPr>
         <p:style>
           <a:lnRef idx="1">
@@ -3295,18 +3258,18 @@
           </a:fontRef>
         </p:style>
         <p:txBody>
-          <a:bodyPr rtlCol="0" anchor="ctr" lIns="457200"/>
+          <a:bodyPr rtlCol="0" anchor="ctr" lIns="365760"/>
           <a:lstStyle/>
           <a:p>
             <a:pPr algn="ctr"/>
             <a:r>
-              <a:rPr sz="2600" b="1">
+              <a:rPr sz="2200" b="1">
                 <a:solidFill>
                   <a:srgbClr val="FFFFFF"/>
                 </a:solidFill>
                 <a:latin typeface="Calibri"/>
               </a:rPr>
-              <a:t>The pipeline — how it runs</a:t>
+              <a:t>Lee Lab Colony DB — one connected workflow</a:t>
             </a:r>
           </a:p>
         </p:txBody>
@@ -3319,8 +3282,8 @@
         </p:nvSpPr>
         <p:spPr>
           <a:xfrm>
-            <a:off x="475488" y="1005840"/>
-            <a:ext cx="11338560" cy="365760"/>
+            <a:off x="9281160" y="201168"/>
+            <a:ext cx="731520" cy="292608"/>
           </a:xfrm>
           <a:prstGeom prst="rect">
             <a:avLst/>
@@ -3335,27 +3298,405 @@
           <a:p>
             <a:pPr algn="l"/>
             <a:r>
-              <a:rPr sz="1300" b="0" i="1">
-                <a:solidFill>
-                  <a:srgbClr val="64748B"/>
+              <a:rPr sz="1100" b="1" i="0">
+                <a:solidFill>
+                  <a:srgbClr val="C7D6F5"/>
                 </a:solidFill>
                 <a:latin typeface="Calibri"/>
               </a:rPr>
-              <a:t>No server to maintain: a static web page talks straight to a hosted database.</a:t>
-            </a:r>
-          </a:p>
-        </p:txBody>
-      </p:sp>
-      <p:sp>
-        <p:nvSpPr>
-          <p:cNvPr id="4" name="Rounded Rectangle 3"/>
+              <a:t>Roles:</a:t>
+            </a:r>
+          </a:p>
+        </p:txBody>
+      </p:sp>
+      <p:sp>
+        <p:nvSpPr>
+          <p:cNvPr id="4" name="Rectangle 3"/>
           <p:cNvSpPr/>
           <p:nvPr/>
         </p:nvSpPr>
         <p:spPr>
           <a:xfrm>
-            <a:off x="457200" y="1737360"/>
-            <a:ext cx="2514600" cy="1188720"/>
+            <a:off x="9829800" y="246888"/>
+            <a:ext cx="146304" cy="146304"/>
+          </a:xfrm>
+          <a:prstGeom prst="rect">
+            <a:avLst/>
+          </a:prstGeom>
+          <a:solidFill>
+            <a:srgbClr val="7C3AED"/>
+          </a:solidFill>
+          <a:ln>
+            <a:noFill/>
+          </a:ln>
+          <a:effectLst/>
+        </p:spPr>
+        <p:style>
+          <a:lnRef idx="1">
+            <a:schemeClr val="accent1"/>
+          </a:lnRef>
+          <a:fillRef idx="3">
+            <a:schemeClr val="accent1"/>
+          </a:fillRef>
+          <a:effectRef idx="2">
+            <a:schemeClr val="accent1"/>
+          </a:effectRef>
+          <a:fontRef idx="minor">
+            <a:schemeClr val="lt1"/>
+          </a:fontRef>
+        </p:style>
+        <p:txBody>
+          <a:bodyPr rtlCol="0" anchor="ctr"/>
+          <a:lstStyle/>
+          <a:p>
+            <a:pPr algn="ctr"/>
+          </a:p>
+        </p:txBody>
+      </p:sp>
+      <p:sp>
+        <p:nvSpPr>
+          <p:cNvPr id="5" name="TextBox 4"/>
+          <p:cNvSpPr txBox="1"/>
+          <p:nvPr/>
+        </p:nvSpPr>
+        <p:spPr>
+          <a:xfrm>
+            <a:off x="10003536" y="182880"/>
+            <a:ext cx="640080" cy="274320"/>
+          </a:xfrm>
+          <a:prstGeom prst="rect">
+            <a:avLst/>
+          </a:prstGeom>
+          <a:noFill/>
+        </p:spPr>
+        <p:txBody>
+          <a:bodyPr wrap="square" anchor="t">
+            <a:spAutoFit/>
+          </a:bodyPr>
+          <a:lstStyle/>
+          <a:p>
+            <a:pPr algn="l"/>
+            <a:r>
+              <a:rPr sz="900" b="0" i="0">
+                <a:solidFill>
+                  <a:srgbClr val="FFFFFF"/>
+                </a:solidFill>
+                <a:latin typeface="Calibri"/>
+              </a:rPr>
+              <a:t>PI</a:t>
+            </a:r>
+          </a:p>
+        </p:txBody>
+      </p:sp>
+      <p:sp>
+        <p:nvSpPr>
+          <p:cNvPr id="6" name="Rectangle 5"/>
+          <p:cNvSpPr/>
+          <p:nvPr/>
+        </p:nvSpPr>
+        <p:spPr>
+          <a:xfrm>
+            <a:off x="10616184" y="246888"/>
+            <a:ext cx="146304" cy="146304"/>
+          </a:xfrm>
+          <a:prstGeom prst="rect">
+            <a:avLst/>
+          </a:prstGeom>
+          <a:solidFill>
+            <a:srgbClr val="2563EB"/>
+          </a:solidFill>
+          <a:ln>
+            <a:noFill/>
+          </a:ln>
+          <a:effectLst/>
+        </p:spPr>
+        <p:style>
+          <a:lnRef idx="1">
+            <a:schemeClr val="accent1"/>
+          </a:lnRef>
+          <a:fillRef idx="3">
+            <a:schemeClr val="accent1"/>
+          </a:fillRef>
+          <a:effectRef idx="2">
+            <a:schemeClr val="accent1"/>
+          </a:effectRef>
+          <a:fontRef idx="minor">
+            <a:schemeClr val="lt1"/>
+          </a:fontRef>
+        </p:style>
+        <p:txBody>
+          <a:bodyPr rtlCol="0" anchor="ctr"/>
+          <a:lstStyle/>
+          <a:p>
+            <a:pPr algn="ctr"/>
+          </a:p>
+        </p:txBody>
+      </p:sp>
+      <p:sp>
+        <p:nvSpPr>
+          <p:cNvPr id="7" name="TextBox 6"/>
+          <p:cNvSpPr txBox="1"/>
+          <p:nvPr/>
+        </p:nvSpPr>
+        <p:spPr>
+          <a:xfrm>
+            <a:off x="10789919" y="182880"/>
+            <a:ext cx="640080" cy="274320"/>
+          </a:xfrm>
+          <a:prstGeom prst="rect">
+            <a:avLst/>
+          </a:prstGeom>
+          <a:noFill/>
+        </p:spPr>
+        <p:txBody>
+          <a:bodyPr wrap="square" anchor="t">
+            <a:spAutoFit/>
+          </a:bodyPr>
+          <a:lstStyle/>
+          <a:p>
+            <a:pPr algn="l"/>
+            <a:r>
+              <a:rPr sz="900" b="0" i="0">
+                <a:solidFill>
+                  <a:srgbClr val="FFFFFF"/>
+                </a:solidFill>
+                <a:latin typeface="Calibri"/>
+              </a:rPr>
+              <a:t>Manager</a:t>
+            </a:r>
+          </a:p>
+        </p:txBody>
+      </p:sp>
+      <p:sp>
+        <p:nvSpPr>
+          <p:cNvPr id="8" name="Rectangle 7"/>
+          <p:cNvSpPr/>
+          <p:nvPr/>
+        </p:nvSpPr>
+        <p:spPr>
+          <a:xfrm>
+            <a:off x="11402568" y="246888"/>
+            <a:ext cx="146304" cy="146304"/>
+          </a:xfrm>
+          <a:prstGeom prst="rect">
+            <a:avLst/>
+          </a:prstGeom>
+          <a:solidFill>
+            <a:srgbClr val="334155"/>
+          </a:solidFill>
+          <a:ln>
+            <a:noFill/>
+          </a:ln>
+          <a:effectLst/>
+        </p:spPr>
+        <p:style>
+          <a:lnRef idx="1">
+            <a:schemeClr val="accent1"/>
+          </a:lnRef>
+          <a:fillRef idx="3">
+            <a:schemeClr val="accent1"/>
+          </a:fillRef>
+          <a:effectRef idx="2">
+            <a:schemeClr val="accent1"/>
+          </a:effectRef>
+          <a:fontRef idx="minor">
+            <a:schemeClr val="lt1"/>
+          </a:fontRef>
+        </p:style>
+        <p:txBody>
+          <a:bodyPr rtlCol="0" anchor="ctr"/>
+          <a:lstStyle/>
+          <a:p>
+            <a:pPr algn="ctr"/>
+          </a:p>
+        </p:txBody>
+      </p:sp>
+      <p:sp>
+        <p:nvSpPr>
+          <p:cNvPr id="9" name="TextBox 8"/>
+          <p:cNvSpPr txBox="1"/>
+          <p:nvPr/>
+        </p:nvSpPr>
+        <p:spPr>
+          <a:xfrm>
+            <a:off x="11576304" y="182880"/>
+            <a:ext cx="640080" cy="274320"/>
+          </a:xfrm>
+          <a:prstGeom prst="rect">
+            <a:avLst/>
+          </a:prstGeom>
+          <a:noFill/>
+        </p:spPr>
+        <p:txBody>
+          <a:bodyPr wrap="square" anchor="t">
+            <a:spAutoFit/>
+          </a:bodyPr>
+          <a:lstStyle/>
+          <a:p>
+            <a:pPr algn="l"/>
+            <a:r>
+              <a:rPr sz="900" b="0" i="0">
+                <a:solidFill>
+                  <a:srgbClr val="FFFFFF"/>
+                </a:solidFill>
+                <a:latin typeface="Calibri"/>
+              </a:rPr>
+              <a:t>Member</a:t>
+            </a:r>
+          </a:p>
+        </p:txBody>
+      </p:sp>
+      <p:sp>
+        <p:nvSpPr>
+          <p:cNvPr id="10" name="TextBox 9"/>
+          <p:cNvSpPr txBox="1"/>
+          <p:nvPr/>
+        </p:nvSpPr>
+        <p:spPr>
+          <a:xfrm>
+            <a:off x="320040" y="868680"/>
+            <a:ext cx="1371600" cy="274320"/>
+          </a:xfrm>
+          <a:prstGeom prst="rect">
+            <a:avLst/>
+          </a:prstGeom>
+          <a:noFill/>
+        </p:spPr>
+        <p:txBody>
+          <a:bodyPr wrap="square" anchor="t">
+            <a:spAutoFit/>
+          </a:bodyPr>
+          <a:lstStyle/>
+          <a:p>
+            <a:pPr algn="l"/>
+            <a:r>
+              <a:rPr sz="1100" b="1" i="0">
+                <a:solidFill>
+                  <a:srgbClr val="64748B"/>
+                </a:solidFill>
+                <a:latin typeface="Calibri"/>
+              </a:rPr>
+              <a:t>USERS</a:t>
+            </a:r>
+          </a:p>
+        </p:txBody>
+      </p:sp>
+      <p:sp>
+        <p:nvSpPr>
+          <p:cNvPr id="11" name="Rounded Rectangle 10"/>
+          <p:cNvSpPr/>
+          <p:nvPr/>
+        </p:nvSpPr>
+        <p:spPr>
+          <a:xfrm>
+            <a:off x="320040" y="1170432"/>
+            <a:ext cx="1417320" cy="402336"/>
+          </a:xfrm>
+          <a:prstGeom prst="roundRect">
+            <a:avLst/>
+          </a:prstGeom>
+          <a:solidFill>
+            <a:srgbClr val="7C3AED"/>
+          </a:solidFill>
+          <a:ln>
+            <a:noFill/>
+          </a:ln>
+          <a:effectLst/>
+        </p:spPr>
+        <p:style>
+          <a:lnRef idx="1">
+            <a:schemeClr val="accent1"/>
+          </a:lnRef>
+          <a:fillRef idx="3">
+            <a:schemeClr val="accent1"/>
+          </a:fillRef>
+          <a:effectRef idx="2">
+            <a:schemeClr val="accent1"/>
+          </a:effectRef>
+          <a:fontRef idx="minor">
+            <a:schemeClr val="lt1"/>
+          </a:fontRef>
+        </p:style>
+        <p:txBody>
+          <a:bodyPr rtlCol="0" anchor="ctr" wrap="square" lIns="45720" rIns="45720"/>
+          <a:lstStyle/>
+          <a:p>
+            <a:pPr algn="ctr"/>
+            <a:r>
+              <a:rPr sz="1200" b="1">
+                <a:solidFill>
+                  <a:srgbClr val="FFFFFF"/>
+                </a:solidFill>
+                <a:latin typeface="Calibri"/>
+              </a:rPr>
+              <a:t>PI</a:t>
+            </a:r>
+          </a:p>
+        </p:txBody>
+      </p:sp>
+      <p:sp>
+        <p:nvSpPr>
+          <p:cNvPr id="12" name="Rounded Rectangle 11"/>
+          <p:cNvSpPr/>
+          <p:nvPr/>
+        </p:nvSpPr>
+        <p:spPr>
+          <a:xfrm>
+            <a:off x="320040" y="1627632"/>
+            <a:ext cx="1417320" cy="402336"/>
+          </a:xfrm>
+          <a:prstGeom prst="roundRect">
+            <a:avLst/>
+          </a:prstGeom>
+          <a:solidFill>
+            <a:srgbClr val="2563EB"/>
+          </a:solidFill>
+          <a:ln>
+            <a:noFill/>
+          </a:ln>
+          <a:effectLst/>
+        </p:spPr>
+        <p:style>
+          <a:lnRef idx="1">
+            <a:schemeClr val="accent1"/>
+          </a:lnRef>
+          <a:fillRef idx="3">
+            <a:schemeClr val="accent1"/>
+          </a:fillRef>
+          <a:effectRef idx="2">
+            <a:schemeClr val="accent1"/>
+          </a:effectRef>
+          <a:fontRef idx="minor">
+            <a:schemeClr val="lt1"/>
+          </a:fontRef>
+        </p:style>
+        <p:txBody>
+          <a:bodyPr rtlCol="0" anchor="ctr" wrap="square" lIns="45720" rIns="45720"/>
+          <a:lstStyle/>
+          <a:p>
+            <a:pPr algn="ctr"/>
+            <a:r>
+              <a:rPr sz="1200" b="1">
+                <a:solidFill>
+                  <a:srgbClr val="FFFFFF"/>
+                </a:solidFill>
+                <a:latin typeface="Calibri"/>
+              </a:rPr>
+              <a:t>Manager</a:t>
+            </a:r>
+          </a:p>
+        </p:txBody>
+      </p:sp>
+      <p:sp>
+        <p:nvSpPr>
+          <p:cNvPr id="13" name="Rounded Rectangle 12"/>
+          <p:cNvSpPr/>
+          <p:nvPr/>
+        </p:nvSpPr>
+        <p:spPr>
+          <a:xfrm>
+            <a:off x="320040" y="2084831"/>
+            <a:ext cx="1417320" cy="402336"/>
           </a:xfrm>
           <a:prstGeom prst="roundRect">
             <a:avLst/>
@@ -3366,6 +3707,7 @@
           <a:ln>
             <a:noFill/>
           </a:ln>
+          <a:effectLst/>
         </p:spPr>
         <p:style>
           <a:lnRef idx="1">
@@ -3382,54 +3724,43 @@
           </a:fontRef>
         </p:style>
         <p:txBody>
-          <a:bodyPr rtlCol="0" anchor="ctr" wrap="square" lIns="73152" rIns="73152" tIns="36576" bIns="36576"/>
+          <a:bodyPr rtlCol="0" anchor="ctr" wrap="square" lIns="45720" rIns="45720"/>
           <a:lstStyle/>
           <a:p>
             <a:pPr algn="ctr"/>
             <a:r>
-              <a:rPr sz="1300" b="1">
+              <a:rPr sz="1200" b="1">
                 <a:solidFill>
                   <a:srgbClr val="FFFFFF"/>
                 </a:solidFill>
                 <a:latin typeface="Calibri"/>
               </a:rPr>
-              <a:t>Lab member</a:t>
-            </a:r>
-          </a:p>
-          <a:p>
-            <a:pPr algn="ctr"/>
-            <a:r>
-              <a:rPr sz="1100" b="0">
-                <a:solidFill>
-                  <a:srgbClr val="FFFFFF"/>
-                </a:solidFill>
-                <a:latin typeface="Calibri"/>
-              </a:rPr>
-              <a:t>(browser: laptop / phone)</a:t>
-            </a:r>
-          </a:p>
-        </p:txBody>
-      </p:sp>
-      <p:sp>
-        <p:nvSpPr>
-          <p:cNvPr id="5" name="Right Arrow 4"/>
+              <a:t>Member</a:t>
+            </a:r>
+          </a:p>
+        </p:txBody>
+      </p:sp>
+      <p:sp>
+        <p:nvSpPr>
+          <p:cNvPr id="14" name="Rounded Rectangle 13"/>
           <p:cNvSpPr/>
           <p:nvPr/>
         </p:nvSpPr>
         <p:spPr>
           <a:xfrm>
-            <a:off x="3063240" y="2148840"/>
-            <a:ext cx="457200" cy="365760"/>
-          </a:xfrm>
-          <a:prstGeom prst="rightArrow">
+            <a:off x="2331720" y="1325880"/>
+            <a:ext cx="1874519" cy="868680"/>
+          </a:xfrm>
+          <a:prstGeom prst="roundRect">
             <a:avLst/>
           </a:prstGeom>
           <a:solidFill>
-            <a:srgbClr val="64748B"/>
+            <a:srgbClr val="1E3A8A"/>
           </a:solidFill>
           <a:ln>
             <a:noFill/>
           </a:ln>
+          <a:effectLst/>
         </p:spPr>
         <p:style>
           <a:lnRef idx="1">
@@ -3446,23 +3777,44 @@
           </a:fontRef>
         </p:style>
         <p:txBody>
-          <a:bodyPr rtlCol="0" anchor="ctr"/>
+          <a:bodyPr rtlCol="0" anchor="ctr" wrap="square" lIns="45720" rIns="45720"/>
           <a:lstStyle/>
           <a:p>
             <a:pPr algn="ctr"/>
-          </a:p>
-        </p:txBody>
-      </p:sp>
-      <p:sp>
-        <p:nvSpPr>
-          <p:cNvPr id="6" name="Rounded Rectangle 5"/>
+            <a:r>
+              <a:rPr sz="1200" b="1">
+                <a:solidFill>
+                  <a:srgbClr val="FFFFFF"/>
+                </a:solidFill>
+                <a:latin typeface="Calibri"/>
+              </a:rPr>
+              <a:t>Log in</a:t>
+            </a:r>
+          </a:p>
+          <a:p>
+            <a:pPr algn="ctr"/>
+            <a:r>
+              <a:rPr sz="1000">
+                <a:solidFill>
+                  <a:srgbClr val="FFFFFF"/>
+                </a:solidFill>
+                <a:latin typeface="Calibri"/>
+              </a:rPr>
+              <a:t>name + shared password · email once</a:t>
+            </a:r>
+          </a:p>
+        </p:txBody>
+      </p:sp>
+      <p:sp>
+        <p:nvSpPr>
+          <p:cNvPr id="15" name="Rounded Rectangle 14"/>
           <p:cNvSpPr/>
           <p:nvPr/>
         </p:nvSpPr>
         <p:spPr>
           <a:xfrm>
-            <a:off x="3611880" y="1737360"/>
-            <a:ext cx="2514600" cy="1188720"/>
+            <a:off x="4617720" y="1280160"/>
+            <a:ext cx="2286000" cy="960120"/>
           </a:xfrm>
           <a:prstGeom prst="roundRect">
             <a:avLst/>
@@ -3473,6 +3825,7 @@
           <a:ln>
             <a:noFill/>
           </a:ln>
+          <a:effectLst/>
         </p:spPr>
         <p:style>
           <a:lnRef idx="1">
@@ -3489,7 +3842,7 @@
           </a:fontRef>
         </p:style>
         <p:txBody>
-          <a:bodyPr rtlCol="0" anchor="ctr" wrap="square" lIns="73152" rIns="73152" tIns="36576" bIns="36576"/>
+          <a:bodyPr rtlCol="0" anchor="ctr" wrap="square" lIns="45720" rIns="45720"/>
           <a:lstStyle/>
           <a:p>
             <a:pPr algn="ctr"/>
@@ -3500,88 +3853,33 @@
                 </a:solidFill>
                 <a:latin typeface="Calibri"/>
               </a:rPr>
-              <a:t>GitHub Pages</a:t>
+              <a:t>Colony web app</a:t>
             </a:r>
           </a:p>
           <a:p>
             <a:pPr algn="ctr"/>
             <a:r>
-              <a:rPr sz="1100" b="0">
+              <a:rPr sz="1100">
                 <a:solidFill>
                   <a:srgbClr val="FFFFFF"/>
                 </a:solidFill>
                 <a:latin typeface="Calibri"/>
               </a:rPr>
-              <a:t>serves index.html</a:t>
-            </a:r>
-          </a:p>
-          <a:p>
-            <a:pPr algn="ctr"/>
-            <a:r>
-              <a:rPr sz="1100" b="0">
-                <a:solidFill>
-                  <a:srgbClr val="FFFFFF"/>
-                </a:solidFill>
-                <a:latin typeface="Calibri"/>
-              </a:rPr>
-              <a:t>(one HTML file, free)</a:t>
-            </a:r>
-          </a:p>
-        </p:txBody>
-      </p:sp>
-      <p:sp>
-        <p:nvSpPr>
-          <p:cNvPr id="7" name="Right Arrow 6"/>
+              <a:t>index.html · GitHub Pages</a:t>
+            </a:r>
+          </a:p>
+        </p:txBody>
+      </p:sp>
+      <p:sp>
+        <p:nvSpPr>
+          <p:cNvPr id="16" name="Rounded Rectangle 15"/>
           <p:cNvSpPr/>
           <p:nvPr/>
         </p:nvSpPr>
         <p:spPr>
           <a:xfrm>
-            <a:off x="6217920" y="2148840"/>
-            <a:ext cx="457200" cy="365760"/>
-          </a:xfrm>
-          <a:prstGeom prst="rightArrow">
-            <a:avLst/>
-          </a:prstGeom>
-          <a:solidFill>
-            <a:srgbClr val="64748B"/>
-          </a:solidFill>
-          <a:ln>
-            <a:noFill/>
-          </a:ln>
-        </p:spPr>
-        <p:style>
-          <a:lnRef idx="1">
-            <a:schemeClr val="accent1"/>
-          </a:lnRef>
-          <a:fillRef idx="3">
-            <a:schemeClr val="accent1"/>
-          </a:fillRef>
-          <a:effectRef idx="2">
-            <a:schemeClr val="accent1"/>
-          </a:effectRef>
-          <a:fontRef idx="minor">
-            <a:schemeClr val="lt1"/>
-          </a:fontRef>
-        </p:style>
-        <p:txBody>
-          <a:bodyPr rtlCol="0" anchor="ctr"/>
-          <a:lstStyle/>
-          <a:p>
-            <a:pPr algn="ctr"/>
-          </a:p>
-        </p:txBody>
-      </p:sp>
-      <p:sp>
-        <p:nvSpPr>
-          <p:cNvPr id="8" name="Rounded Rectangle 7"/>
-          <p:cNvSpPr/>
-          <p:nvPr/>
-        </p:nvSpPr>
-        <p:spPr>
-          <a:xfrm>
-            <a:off x="6766560" y="1737360"/>
-            <a:ext cx="2743200" cy="1188720"/>
+            <a:off x="9281160" y="1143000"/>
+            <a:ext cx="2697480" cy="960120"/>
           </a:xfrm>
           <a:prstGeom prst="roundRect">
             <a:avLst/>
@@ -3592,6 +3890,7 @@
           <a:ln>
             <a:noFill/>
           </a:ln>
+          <a:effectLst/>
         </p:spPr>
         <p:style>
           <a:lnRef idx="1">
@@ -3608,7 +3907,7 @@
           </a:fontRef>
         </p:style>
         <p:txBody>
-          <a:bodyPr rtlCol="0" anchor="ctr" wrap="square" lIns="73152" rIns="73152" tIns="36576" bIns="36576"/>
+          <a:bodyPr rtlCol="0" anchor="ctr" wrap="square" lIns="45720" rIns="45720"/>
           <a:lstStyle/>
           <a:p>
             <a:pPr algn="ctr"/>
@@ -3625,82 +3924,27 @@
           <a:p>
             <a:pPr algn="ctr"/>
             <a:r>
-              <a:rPr sz="1100" b="0">
+              <a:rPr sz="1100">
                 <a:solidFill>
                   <a:srgbClr val="FFFFFF"/>
                 </a:solidFill>
                 <a:latin typeface="Calibri"/>
               </a:rPr>
-              <a:t>Postgres DB + auto REST API</a:t>
-            </a:r>
-          </a:p>
-          <a:p>
-            <a:pPr algn="ctr"/>
-            <a:r>
-              <a:rPr sz="1100" b="0">
-                <a:solidFill>
-                  <a:srgbClr val="FFFFFF"/>
-                </a:solidFill>
-                <a:latin typeface="Calibri"/>
-              </a:rPr>
-              <a:t>+ Row-Level Security</a:t>
-            </a:r>
-          </a:p>
-        </p:txBody>
-      </p:sp>
-      <p:sp>
-        <p:nvSpPr>
-          <p:cNvPr id="9" name="Down Arrow 8"/>
+              <a:t>Postgres + RLS + auto REST API</a:t>
+            </a:r>
+          </a:p>
+        </p:txBody>
+      </p:sp>
+      <p:sp>
+        <p:nvSpPr>
+          <p:cNvPr id="17" name="Rounded Rectangle 16"/>
           <p:cNvSpPr/>
           <p:nvPr/>
         </p:nvSpPr>
         <p:spPr>
           <a:xfrm>
-            <a:off x="7955279" y="2971800"/>
-            <a:ext cx="365760" cy="365760"/>
-          </a:xfrm>
-          <a:prstGeom prst="downArrow">
-            <a:avLst/>
-          </a:prstGeom>
-          <a:solidFill>
-            <a:srgbClr val="64748B"/>
-          </a:solidFill>
-          <a:ln>
-            <a:noFill/>
-          </a:ln>
-        </p:spPr>
-        <p:style>
-          <a:lnRef idx="1">
-            <a:schemeClr val="accent1"/>
-          </a:lnRef>
-          <a:fillRef idx="3">
-            <a:schemeClr val="accent1"/>
-          </a:fillRef>
-          <a:effectRef idx="2">
-            <a:schemeClr val="accent1"/>
-          </a:effectRef>
-          <a:fontRef idx="minor">
-            <a:schemeClr val="lt1"/>
-          </a:fontRef>
-        </p:style>
-        <p:txBody>
-          <a:bodyPr rtlCol="0" anchor="ctr"/>
-          <a:lstStyle/>
-          <a:p>
-            <a:pPr algn="ctr"/>
-          </a:p>
-        </p:txBody>
-      </p:sp>
-      <p:sp>
-        <p:nvSpPr>
-          <p:cNvPr id="10" name="Rounded Rectangle 9"/>
-          <p:cNvSpPr/>
-          <p:nvPr/>
-        </p:nvSpPr>
-        <p:spPr>
-          <a:xfrm>
-            <a:off x="6766560" y="3429000"/>
-            <a:ext cx="2743200" cy="822960"/>
+            <a:off x="9281160" y="2212848"/>
+            <a:ext cx="2697480" cy="457200"/>
           </a:xfrm>
           <a:prstGeom prst="roundRect">
             <a:avLst/>
@@ -3711,6 +3955,7 @@
           <a:ln>
             <a:noFill/>
           </a:ln>
+          <a:effectLst/>
         </p:spPr>
         <p:style>
           <a:lnRef idx="1">
@@ -3727,87 +3972,32 @@
           </a:fontRef>
         </p:style>
         <p:txBody>
-          <a:bodyPr rtlCol="0" anchor="ctr" wrap="square" lIns="73152" rIns="73152" tIns="36576" bIns="36576"/>
+          <a:bodyPr rtlCol="0" anchor="ctr" wrap="square" lIns="45720" rIns="45720"/>
           <a:lstStyle/>
           <a:p>
             <a:pPr algn="ctr"/>
             <a:r>
-              <a:rPr sz="1200" b="1">
+              <a:rPr sz="1000" b="1">
                 <a:solidFill>
                   <a:srgbClr val="FFFFFF"/>
                 </a:solidFill>
                 <a:latin typeface="Calibri"/>
               </a:rPr>
-              <a:t>mice • app_users • requests</a:t>
-            </a:r>
-          </a:p>
-          <a:p>
-            <a:pPr algn="ctr"/>
-            <a:r>
-              <a:rPr sz="1000" b="0">
-                <a:solidFill>
-                  <a:srgbClr val="FFFFFF"/>
-                </a:solidFill>
-                <a:latin typeface="Calibri"/>
-              </a:rPr>
-              <a:t>audit_log • app_config</a:t>
-            </a:r>
-          </a:p>
-        </p:txBody>
-      </p:sp>
-      <p:sp>
-        <p:nvSpPr>
-          <p:cNvPr id="11" name="Right Arrow 10"/>
+              <a:t>mice · app_users · requests · audit_log</a:t>
+            </a:r>
+          </a:p>
+        </p:txBody>
+      </p:sp>
+      <p:sp>
+        <p:nvSpPr>
+          <p:cNvPr id="18" name="Rounded Rectangle 17"/>
           <p:cNvSpPr/>
           <p:nvPr/>
         </p:nvSpPr>
         <p:spPr>
           <a:xfrm>
-            <a:off x="9601200" y="2148840"/>
-            <a:ext cx="411480" cy="365760"/>
-          </a:xfrm>
-          <a:prstGeom prst="rightArrow">
-            <a:avLst/>
-          </a:prstGeom>
-          <a:solidFill>
-            <a:srgbClr val="64748B"/>
-          </a:solidFill>
-          <a:ln>
-            <a:noFill/>
-          </a:ln>
-        </p:spPr>
-        <p:style>
-          <a:lnRef idx="1">
-            <a:schemeClr val="accent1"/>
-          </a:lnRef>
-          <a:fillRef idx="3">
-            <a:schemeClr val="accent1"/>
-          </a:fillRef>
-          <a:effectRef idx="2">
-            <a:schemeClr val="accent1"/>
-          </a:effectRef>
-          <a:fontRef idx="minor">
-            <a:schemeClr val="lt1"/>
-          </a:fontRef>
-        </p:style>
-        <p:txBody>
-          <a:bodyPr rtlCol="0" anchor="ctr"/>
-          <a:lstStyle/>
-          <a:p>
-            <a:pPr algn="ctr"/>
-          </a:p>
-        </p:txBody>
-      </p:sp>
-      <p:sp>
-        <p:nvSpPr>
-          <p:cNvPr id="12" name="Rounded Rectangle 11"/>
-          <p:cNvSpPr/>
-          <p:nvPr/>
-        </p:nvSpPr>
-        <p:spPr>
-          <a:xfrm>
-            <a:off x="10058400" y="1737360"/>
-            <a:ext cx="1828800" cy="1188720"/>
+            <a:off x="9281160" y="2798064"/>
+            <a:ext cx="2697480" cy="457200"/>
           </a:xfrm>
           <a:prstGeom prst="roundRect">
             <a:avLst/>
@@ -3818,6 +4008,7 @@
           <a:ln>
             <a:noFill/>
           </a:ln>
+          <a:effectLst/>
         </p:spPr>
         <p:style>
           <a:lnRef idx="1">
@@ -3834,56 +4025,213 @@
           </a:fontRef>
         </p:style>
         <p:txBody>
-          <a:bodyPr rtlCol="0" anchor="ctr" wrap="square" lIns="73152" rIns="73152" tIns="36576" bIns="36576"/>
+          <a:bodyPr rtlCol="0" anchor="ctr" wrap="square" lIns="45720" rIns="45720"/>
           <a:lstStyle/>
           <a:p>
             <a:pPr algn="ctr"/>
             <a:r>
-              <a:rPr sz="1200" b="1">
+              <a:rPr sz="1100" b="1">
                 <a:solidFill>
                   <a:srgbClr val="FFFFFF"/>
                 </a:solidFill>
                 <a:latin typeface="Calibri"/>
               </a:rPr>
-              <a:t>GitHub Actions</a:t>
-            </a:r>
-          </a:p>
-          <a:p>
-            <a:pPr algn="ctr"/>
-            <a:r>
-              <a:rPr sz="1000" b="0">
-                <a:solidFill>
-                  <a:srgbClr val="FFFFFF"/>
-                </a:solidFill>
-                <a:latin typeface="Calibri"/>
-              </a:rPr>
-              <a:t>daily backup</a:t>
-            </a:r>
-          </a:p>
-          <a:p>
-            <a:pPr algn="ctr"/>
-            <a:r>
-              <a:rPr sz="1000" b="0">
-                <a:solidFill>
-                  <a:srgbClr val="FFFFFF"/>
-                </a:solidFill>
-                <a:latin typeface="Calibri"/>
-              </a:rPr>
-              <a:t>snapshots</a:t>
-            </a:r>
-          </a:p>
-        </p:txBody>
-      </p:sp>
-      <p:sp>
-        <p:nvSpPr>
-          <p:cNvPr id="13" name="TextBox 12"/>
+              <a:t>Daily backups (GitHub Actions)</a:t>
+            </a:r>
+          </a:p>
+        </p:txBody>
+      </p:sp>
+      <p:cxnSp>
+        <p:nvCxnSpPr>
+          <p:cNvPr id="19" name="Connector 18"/>
+          <p:cNvCxnSpPr/>
+          <p:nvPr/>
+        </p:nvCxnSpPr>
+        <p:spPr>
+          <a:xfrm>
+            <a:off x="1737360" y="1371600"/>
+            <a:ext cx="594360" cy="388619"/>
+          </a:xfrm>
+          <a:prstGeom prst="line">
+            <a:avLst/>
+          </a:prstGeom>
+          <a:ln w="22225">
+            <a:solidFill>
+              <a:srgbClr val="94A3B8"/>
+            </a:solidFill>
+            <a:tailEnd type="triangle" w="med" len="med"/>
+          </a:ln>
+        </p:spPr>
+        <p:style>
+          <a:lnRef idx="2">
+            <a:schemeClr val="accent1"/>
+          </a:lnRef>
+          <a:fillRef idx="0">
+            <a:schemeClr val="accent1"/>
+          </a:fillRef>
+          <a:effectRef idx="1">
+            <a:schemeClr val="accent1"/>
+          </a:effectRef>
+          <a:fontRef idx="minor">
+            <a:schemeClr val="tx1"/>
+          </a:fontRef>
+        </p:style>
+      </p:cxnSp>
+      <p:cxnSp>
+        <p:nvCxnSpPr>
+          <p:cNvPr id="20" name="Connector 19"/>
+          <p:cNvCxnSpPr/>
+          <p:nvPr/>
+        </p:nvCxnSpPr>
+        <p:spPr>
+          <a:xfrm flipV="1">
+            <a:off x="1737360" y="1760219"/>
+            <a:ext cx="594360" cy="68581"/>
+          </a:xfrm>
+          <a:prstGeom prst="line">
+            <a:avLst/>
+          </a:prstGeom>
+          <a:ln w="22225">
+            <a:solidFill>
+              <a:srgbClr val="94A3B8"/>
+            </a:solidFill>
+            <a:tailEnd type="triangle" w="med" len="med"/>
+          </a:ln>
+        </p:spPr>
+        <p:style>
+          <a:lnRef idx="2">
+            <a:schemeClr val="accent1"/>
+          </a:lnRef>
+          <a:fillRef idx="0">
+            <a:schemeClr val="accent1"/>
+          </a:fillRef>
+          <a:effectRef idx="1">
+            <a:schemeClr val="accent1"/>
+          </a:effectRef>
+          <a:fontRef idx="minor">
+            <a:schemeClr val="tx1"/>
+          </a:fontRef>
+        </p:style>
+      </p:cxnSp>
+      <p:cxnSp>
+        <p:nvCxnSpPr>
+          <p:cNvPr id="21" name="Connector 20"/>
+          <p:cNvCxnSpPr/>
+          <p:nvPr/>
+        </p:nvCxnSpPr>
+        <p:spPr>
+          <a:xfrm flipV="1">
+            <a:off x="1737360" y="1760219"/>
+            <a:ext cx="594360" cy="525781"/>
+          </a:xfrm>
+          <a:prstGeom prst="line">
+            <a:avLst/>
+          </a:prstGeom>
+          <a:ln w="22225">
+            <a:solidFill>
+              <a:srgbClr val="94A3B8"/>
+            </a:solidFill>
+            <a:tailEnd type="triangle" w="med" len="med"/>
+          </a:ln>
+        </p:spPr>
+        <p:style>
+          <a:lnRef idx="2">
+            <a:schemeClr val="accent1"/>
+          </a:lnRef>
+          <a:fillRef idx="0">
+            <a:schemeClr val="accent1"/>
+          </a:fillRef>
+          <a:effectRef idx="1">
+            <a:schemeClr val="accent1"/>
+          </a:effectRef>
+          <a:fontRef idx="minor">
+            <a:schemeClr val="tx1"/>
+          </a:fontRef>
+        </p:style>
+      </p:cxnSp>
+      <p:cxnSp>
+        <p:nvCxnSpPr>
+          <p:cNvPr id="22" name="Connector 21"/>
+          <p:cNvCxnSpPr/>
+          <p:nvPr/>
+        </p:nvCxnSpPr>
+        <p:spPr>
+          <a:xfrm>
+            <a:off x="4206240" y="1760219"/>
+            <a:ext cx="411480" cy="0"/>
+          </a:xfrm>
+          <a:prstGeom prst="line">
+            <a:avLst/>
+          </a:prstGeom>
+          <a:ln w="22225">
+            <a:solidFill>
+              <a:srgbClr val="94A3B8"/>
+            </a:solidFill>
+            <a:tailEnd type="triangle" w="med" len="med"/>
+          </a:ln>
+        </p:spPr>
+        <p:style>
+          <a:lnRef idx="2">
+            <a:schemeClr val="accent1"/>
+          </a:lnRef>
+          <a:fillRef idx="0">
+            <a:schemeClr val="accent1"/>
+          </a:fillRef>
+          <a:effectRef idx="1">
+            <a:schemeClr val="accent1"/>
+          </a:effectRef>
+          <a:fontRef idx="minor">
+            <a:schemeClr val="tx1"/>
+          </a:fontRef>
+        </p:style>
+      </p:cxnSp>
+      <p:cxnSp>
+        <p:nvCxnSpPr>
+          <p:cNvPr id="23" name="Connector 22"/>
+          <p:cNvCxnSpPr/>
+          <p:nvPr/>
+        </p:nvCxnSpPr>
+        <p:spPr>
+          <a:xfrm flipV="1">
+            <a:off x="6903720" y="1623060"/>
+            <a:ext cx="2377440" cy="137159"/>
+          </a:xfrm>
+          <a:prstGeom prst="line">
+            <a:avLst/>
+          </a:prstGeom>
+          <a:ln w="22225">
+            <a:solidFill>
+              <a:srgbClr val="94A3B8"/>
+            </a:solidFill>
+            <a:tailEnd type="triangle" w="med" len="med"/>
+            <a:headEnd type="triangle" w="med" len="med"/>
+          </a:ln>
+        </p:spPr>
+        <p:style>
+          <a:lnRef idx="2">
+            <a:schemeClr val="accent1"/>
+          </a:lnRef>
+          <a:fillRef idx="0">
+            <a:schemeClr val="accent1"/>
+          </a:fillRef>
+          <a:effectRef idx="1">
+            <a:schemeClr val="accent1"/>
+          </a:effectRef>
+          <a:fontRef idx="minor">
+            <a:schemeClr val="tx1"/>
+          </a:fontRef>
+        </p:style>
+      </p:cxnSp>
+      <p:sp>
+        <p:nvSpPr>
+          <p:cNvPr id="24" name="TextBox 23"/>
           <p:cNvSpPr txBox="1"/>
           <p:nvPr/>
         </p:nvSpPr>
         <p:spPr>
           <a:xfrm>
-            <a:off x="548640" y="4480560"/>
-            <a:ext cx="11155680" cy="2194560"/>
+            <a:off x="6766560" y="1371600"/>
+            <a:ext cx="2651760" cy="274320"/>
           </a:xfrm>
           <a:prstGeom prst="rect">
             <a:avLst/>
@@ -3891,156 +4239,106 @@
           <a:noFill/>
         </p:spPr>
         <p:txBody>
-          <a:bodyPr wrap="square">
+          <a:bodyPr wrap="square" anchor="t">
             <a:spAutoFit/>
           </a:bodyPr>
           <a:lstStyle/>
           <a:p>
-            <a:pPr>
-              <a:spcAft>
-                <a:spcPts val="600"/>
-              </a:spcAft>
-            </a:pPr>
-            <a:r>
-              <a:rPr sz="1500" b="0">
-                <a:solidFill>
-                  <a:srgbClr val="1A1D26"/>
+            <a:pPr algn="ctr"/>
+            <a:r>
+              <a:rPr sz="1000" b="0" i="1">
+                <a:solidFill>
+                  <a:srgbClr val="64748B"/>
                 </a:solidFill>
                 <a:latin typeface="Calibri"/>
               </a:rPr>
-              <a:t>• Browser loads one self-contained index.html — no build, no backend to run.</a:t>
-            </a:r>
-          </a:p>
-          <a:p>
-            <a:pPr>
-              <a:spcAft>
-                <a:spcPts val="600"/>
-              </a:spcAft>
-            </a:pPr>
-            <a:r>
-              <a:rPr sz="1500" b="0">
-                <a:solidFill>
-                  <a:srgbClr val="1A1D26"/>
-                </a:solidFill>
-                <a:latin typeface="Calibri"/>
-              </a:rPr>
-              <a:t>• It calls Supabase directly with a public (publishable) key; Row-Level Security controls access.</a:t>
-            </a:r>
-          </a:p>
-          <a:p>
-            <a:pPr>
-              <a:spcAft>
-                <a:spcPts val="600"/>
-              </a:spcAft>
-            </a:pPr>
-            <a:r>
-              <a:rPr sz="1500" b="0">
-                <a:solidFill>
-                  <a:srgbClr val="1A1D26"/>
-                </a:solidFill>
-                <a:latin typeface="Calibri"/>
-              </a:rPr>
-              <a:t>• Postgres stores everything; a mouse_v view derives age &amp; staleness from date-of-birth.</a:t>
-            </a:r>
-          </a:p>
-          <a:p>
-            <a:pPr>
-              <a:spcAft>
-                <a:spcPts val="600"/>
-              </a:spcAft>
-            </a:pPr>
-            <a:r>
-              <a:rPr sz="1500" b="0">
-                <a:solidFill>
-                  <a:srgbClr val="1A1D26"/>
-                </a:solidFill>
-                <a:latin typeface="Calibri"/>
-              </a:rPr>
-              <a:t>• A daily GitHub Action dumps every table to a private repo (restorable snapshots) and keeps the free DB awake.</a:t>
-            </a:r>
-          </a:p>
-        </p:txBody>
-      </p:sp>
-    </p:spTree>
-  </p:cSld>
-  <p:clrMapOvr>
-    <a:masterClrMapping/>
-  </p:clrMapOvr>
-</p:sld>
-</file>
-
-<file path=ppt/slides/slide3.xml><?xml version="1.0" encoding="utf-8"?>
-<p:sld xmlns:a="http://schemas.openxmlformats.org/drawingml/2006/main" xmlns:p="http://schemas.openxmlformats.org/presentationml/2006/main" xmlns:r="http://schemas.openxmlformats.org/officeDocument/2006/relationships">
-  <p:cSld>
-    <p:spTree>
-      <p:nvGrpSpPr>
-        <p:cNvPr id="1" name=""/>
-        <p:cNvGrpSpPr/>
-        <p:nvPr/>
-      </p:nvGrpSpPr>
-      <p:grpSpPr/>
-      <p:sp>
-        <p:nvSpPr>
-          <p:cNvPr id="2" name="Rectangle 1"/>
-          <p:cNvSpPr/>
+              <a:t>reads / writes  (public key + RLS)</a:t>
+            </a:r>
+          </a:p>
+        </p:txBody>
+      </p:sp>
+      <p:cxnSp>
+        <p:nvCxnSpPr>
+          <p:cNvPr id="25" name="Connector 24"/>
+          <p:cNvCxnSpPr/>
           <p:nvPr/>
-        </p:nvSpPr>
-        <p:spPr>
-          <a:xfrm>
-            <a:off x="0" y="0"/>
-            <a:ext cx="12191695" cy="960120"/>
-          </a:xfrm>
-          <a:prstGeom prst="rect">
+        </p:nvCxnSpPr>
+        <p:spPr>
+          <a:xfrm>
+            <a:off x="10629900" y="2103120"/>
+            <a:ext cx="0" cy="109728"/>
+          </a:xfrm>
+          <a:prstGeom prst="line">
             <a:avLst/>
           </a:prstGeom>
-          <a:solidFill>
-            <a:srgbClr val="1E3A8A"/>
-          </a:solidFill>
-          <a:ln>
-            <a:noFill/>
+          <a:ln w="22225">
+            <a:solidFill>
+              <a:srgbClr val="94A3B8"/>
+            </a:solidFill>
+            <a:tailEnd type="triangle" w="med" len="med"/>
           </a:ln>
         </p:spPr>
         <p:style>
-          <a:lnRef idx="1">
+          <a:lnRef idx="2">
             <a:schemeClr val="accent1"/>
           </a:lnRef>
-          <a:fillRef idx="3">
+          <a:fillRef idx="0">
             <a:schemeClr val="accent1"/>
           </a:fillRef>
-          <a:effectRef idx="2">
+          <a:effectRef idx="1">
             <a:schemeClr val="accent1"/>
           </a:effectRef>
           <a:fontRef idx="minor">
-            <a:schemeClr val="lt1"/>
+            <a:schemeClr val="tx1"/>
           </a:fontRef>
         </p:style>
-        <p:txBody>
-          <a:bodyPr rtlCol="0" anchor="ctr" lIns="457200"/>
-          <a:lstStyle/>
-          <a:p>
-            <a:pPr algn="ctr"/>
-            <a:r>
-              <a:rPr sz="2600" b="1">
-                <a:solidFill>
-                  <a:srgbClr val="FFFFFF"/>
-                </a:solidFill>
-                <a:latin typeface="Calibri"/>
-              </a:rPr>
-              <a:t>What flows through it</a:t>
-            </a:r>
-          </a:p>
-        </p:txBody>
-      </p:sp>
-      <p:sp>
-        <p:nvSpPr>
-          <p:cNvPr id="3" name="TextBox 2"/>
+      </p:cxnSp>
+      <p:cxnSp>
+        <p:nvCxnSpPr>
+          <p:cNvPr id="26" name="Connector 25"/>
+          <p:cNvCxnSpPr/>
+          <p:nvPr/>
+        </p:nvCxnSpPr>
+        <p:spPr>
+          <a:xfrm>
+            <a:off x="10629900" y="2670048"/>
+            <a:ext cx="0" cy="128016"/>
+          </a:xfrm>
+          <a:prstGeom prst="line">
+            <a:avLst/>
+          </a:prstGeom>
+          <a:ln w="22225">
+            <a:solidFill>
+              <a:srgbClr val="94A3B8"/>
+            </a:solidFill>
+            <a:tailEnd type="triangle" w="med" len="med"/>
+          </a:ln>
+        </p:spPr>
+        <p:style>
+          <a:lnRef idx="2">
+            <a:schemeClr val="accent1"/>
+          </a:lnRef>
+          <a:fillRef idx="0">
+            <a:schemeClr val="accent1"/>
+          </a:fillRef>
+          <a:effectRef idx="1">
+            <a:schemeClr val="accent1"/>
+          </a:effectRef>
+          <a:fontRef idx="minor">
+            <a:schemeClr val="tx1"/>
+          </a:fontRef>
+        </p:style>
+      </p:cxnSp>
+      <p:sp>
+        <p:nvSpPr>
+          <p:cNvPr id="27" name="TextBox 26"/>
           <p:cNvSpPr txBox="1"/>
           <p:nvPr/>
         </p:nvSpPr>
         <p:spPr>
           <a:xfrm>
-            <a:off x="475488" y="1005840"/>
-            <a:ext cx="11338560" cy="365760"/>
+            <a:off x="4572000" y="2468880"/>
+            <a:ext cx="3657600" cy="274320"/>
           </a:xfrm>
           <a:prstGeom prst="rect">
             <a:avLst/>
@@ -4055,27 +4353,27 @@
           <a:p>
             <a:pPr algn="l"/>
             <a:r>
-              <a:rPr sz="1300" b="0" i="1">
+              <a:rPr sz="1100" b="1" i="1">
                 <a:solidFill>
                   <a:srgbClr val="64748B"/>
                 </a:solidFill>
                 <a:latin typeface="Calibri"/>
               </a:rPr>
-              <a:t>From data entry to finding a mouse.</a:t>
-            </a:r>
-          </a:p>
-        </p:txBody>
-      </p:sp>
-      <p:sp>
-        <p:nvSpPr>
-          <p:cNvPr id="4" name="Rounded Rectangle 3"/>
+              <a:t>In the app, anyone can:</a:t>
+            </a:r>
+          </a:p>
+        </p:txBody>
+      </p:sp>
+      <p:sp>
+        <p:nvSpPr>
+          <p:cNvPr id="28" name="Rounded Rectangle 27"/>
           <p:cNvSpPr/>
           <p:nvPr/>
         </p:nvSpPr>
         <p:spPr>
           <a:xfrm>
-            <a:off x="457200" y="1691640"/>
-            <a:ext cx="2743200" cy="1051560"/>
+            <a:off x="2331720" y="2880360"/>
+            <a:ext cx="2148840" cy="822960"/>
           </a:xfrm>
           <a:prstGeom prst="roundRect">
             <a:avLst/>
@@ -4086,6 +4384,7 @@
           <a:ln>
             <a:noFill/>
           </a:ln>
+          <a:effectLst/>
         </p:spPr>
         <p:style>
           <a:lnRef idx="1">
@@ -4102,7 +4401,7 @@
           </a:fontRef>
         </p:style>
         <p:txBody>
-          <a:bodyPr rtlCol="0" anchor="ctr" wrap="square" lIns="73152" rIns="73152" tIns="36576" bIns="36576"/>
+          <a:bodyPr rtlCol="0" anchor="ctr" wrap="square" lIns="45720" rIns="45720"/>
           <a:lstStyle/>
           <a:p>
             <a:pPr algn="ctr"/>
@@ -4113,45 +4412,341 @@
                 </a:solidFill>
                 <a:latin typeface="Calibri"/>
               </a:rPr>
-              <a:t>ADD</a:t>
+              <a:t>Add cohort (by cage)</a:t>
             </a:r>
           </a:p>
           <a:p>
             <a:pPr algn="ctr"/>
             <a:r>
-              <a:rPr sz="1000" b="0">
+              <a:rPr sz="1000">
                 <a:solidFill>
                   <a:srgbClr val="FFFFFF"/>
                 </a:solidFill>
                 <a:latin typeface="Calibri"/>
               </a:rPr>
-              <a:t>Add cohort by cage</a:t>
-            </a:r>
-          </a:p>
+              <a:t>or Import CSV / Excel</a:t>
+            </a:r>
+          </a:p>
+        </p:txBody>
+      </p:sp>
+      <p:sp>
+        <p:nvSpPr>
+          <p:cNvPr id="29" name="Rounded Rectangle 28"/>
+          <p:cNvSpPr/>
+          <p:nvPr/>
+        </p:nvSpPr>
+        <p:spPr>
+          <a:xfrm>
+            <a:off x="4617720" y="2880360"/>
+            <a:ext cx="2194560" cy="822960"/>
+          </a:xfrm>
+          <a:prstGeom prst="roundRect">
+            <a:avLst/>
+          </a:prstGeom>
+          <a:solidFill>
+            <a:srgbClr val="334155"/>
+          </a:solidFill>
+          <a:ln>
+            <a:noFill/>
+          </a:ln>
+          <a:effectLst/>
+        </p:spPr>
+        <p:style>
+          <a:lnRef idx="1">
+            <a:schemeClr val="accent1"/>
+          </a:lnRef>
+          <a:fillRef idx="3">
+            <a:schemeClr val="accent1"/>
+          </a:fillRef>
+          <a:effectRef idx="2">
+            <a:schemeClr val="accent1"/>
+          </a:effectRef>
+          <a:fontRef idx="minor">
+            <a:schemeClr val="lt1"/>
+          </a:fontRef>
+        </p:style>
+        <p:txBody>
+          <a:bodyPr rtlCol="0" anchor="ctr" wrap="square" lIns="45720" rIns="45720"/>
+          <a:lstStyle/>
           <a:p>
             <a:pPr algn="ctr"/>
             <a:r>
-              <a:rPr sz="1000" b="0">
+              <a:rPr sz="1200" b="1">
                 <a:solidFill>
                   <a:srgbClr val="FFFFFF"/>
                 </a:solidFill>
                 <a:latin typeface="Calibri"/>
               </a:rPr>
-              <a:t>(sex • age/DOB • strain • cage #)</a:t>
-            </a:r>
-          </a:p>
-        </p:txBody>
-      </p:sp>
-      <p:sp>
-        <p:nvSpPr>
-          <p:cNvPr id="5" name="Rounded Rectangle 4"/>
+              <a:t>Browse the colony</a:t>
+            </a:r>
+          </a:p>
+          <a:p>
+            <a:pPr algn="ctr"/>
+            <a:r>
+              <a:rPr sz="1000">
+                <a:solidFill>
+                  <a:srgbClr val="FFFFFF"/>
+                </a:solidFill>
+                <a:latin typeface="Calibri"/>
+              </a:rPr>
+              <a:t>search · filter · Grouped view</a:t>
+            </a:r>
+          </a:p>
+        </p:txBody>
+      </p:sp>
+      <p:sp>
+        <p:nvSpPr>
+          <p:cNvPr id="30" name="Rounded Rectangle 29"/>
           <p:cNvSpPr/>
           <p:nvPr/>
         </p:nvSpPr>
         <p:spPr>
           <a:xfrm>
-            <a:off x="457200" y="3063240"/>
-            <a:ext cx="2743200" cy="1051560"/>
+            <a:off x="6949440" y="2880360"/>
+            <a:ext cx="2194560" cy="822960"/>
+          </a:xfrm>
+          <a:prstGeom prst="roundRect">
+            <a:avLst/>
+          </a:prstGeom>
+          <a:solidFill>
+            <a:srgbClr val="7C3AED"/>
+          </a:solidFill>
+          <a:ln>
+            <a:noFill/>
+          </a:ln>
+          <a:effectLst/>
+        </p:spPr>
+        <p:style>
+          <a:lnRef idx="1">
+            <a:schemeClr val="accent1"/>
+          </a:lnRef>
+          <a:fillRef idx="3">
+            <a:schemeClr val="accent1"/>
+          </a:fillRef>
+          <a:effectRef idx="2">
+            <a:schemeClr val="accent1"/>
+          </a:effectRef>
+          <a:fontRef idx="minor">
+            <a:schemeClr val="lt1"/>
+          </a:fontRef>
+        </p:style>
+        <p:txBody>
+          <a:bodyPr rtlCol="0" anchor="ctr" wrap="square" lIns="45720" rIns="45720"/>
+          <a:lstStyle/>
+          <a:p>
+            <a:pPr algn="ctr"/>
+            <a:r>
+              <a:rPr sz="1200" b="1">
+                <a:solidFill>
+                  <a:srgbClr val="FFFFFF"/>
+                </a:solidFill>
+                <a:latin typeface="Calibri"/>
+              </a:rPr>
+              <a:t>My colony</a:t>
+            </a:r>
+          </a:p>
+          <a:p>
+            <a:pPr algn="ctr"/>
+            <a:r>
+              <a:rPr sz="1000">
+                <a:solidFill>
+                  <a:srgbClr val="FFFFFF"/>
+                </a:solidFill>
+                <a:latin typeface="Calibri"/>
+              </a:rPr>
+              <a:t>only YOUR cohorts</a:t>
+            </a:r>
+          </a:p>
+        </p:txBody>
+      </p:sp>
+      <p:cxnSp>
+        <p:nvCxnSpPr>
+          <p:cNvPr id="31" name="Connector 30"/>
+          <p:cNvCxnSpPr/>
+          <p:nvPr/>
+        </p:nvCxnSpPr>
+        <p:spPr>
+          <a:xfrm flipH="1">
+            <a:off x="3406139" y="2240280"/>
+            <a:ext cx="2354581" cy="640080"/>
+          </a:xfrm>
+          <a:prstGeom prst="line">
+            <a:avLst/>
+          </a:prstGeom>
+          <a:ln w="22225">
+            <a:solidFill>
+              <a:srgbClr val="94A3B8"/>
+            </a:solidFill>
+            <a:tailEnd type="triangle" w="med" len="med"/>
+          </a:ln>
+        </p:spPr>
+        <p:style>
+          <a:lnRef idx="2">
+            <a:schemeClr val="accent1"/>
+          </a:lnRef>
+          <a:fillRef idx="0">
+            <a:schemeClr val="accent1"/>
+          </a:fillRef>
+          <a:effectRef idx="1">
+            <a:schemeClr val="accent1"/>
+          </a:effectRef>
+          <a:fontRef idx="minor">
+            <a:schemeClr val="tx1"/>
+          </a:fontRef>
+        </p:style>
+      </p:cxnSp>
+      <p:cxnSp>
+        <p:nvCxnSpPr>
+          <p:cNvPr id="32" name="Connector 31"/>
+          <p:cNvCxnSpPr/>
+          <p:nvPr/>
+        </p:nvCxnSpPr>
+        <p:spPr>
+          <a:xfrm flipH="1">
+            <a:off x="5715000" y="2240280"/>
+            <a:ext cx="45720" cy="640080"/>
+          </a:xfrm>
+          <a:prstGeom prst="line">
+            <a:avLst/>
+          </a:prstGeom>
+          <a:ln w="22225">
+            <a:solidFill>
+              <a:srgbClr val="94A3B8"/>
+            </a:solidFill>
+            <a:tailEnd type="triangle" w="med" len="med"/>
+          </a:ln>
+        </p:spPr>
+        <p:style>
+          <a:lnRef idx="2">
+            <a:schemeClr val="accent1"/>
+          </a:lnRef>
+          <a:fillRef idx="0">
+            <a:schemeClr val="accent1"/>
+          </a:fillRef>
+          <a:effectRef idx="1">
+            <a:schemeClr val="accent1"/>
+          </a:effectRef>
+          <a:fontRef idx="minor">
+            <a:schemeClr val="tx1"/>
+          </a:fontRef>
+        </p:style>
+      </p:cxnSp>
+      <p:cxnSp>
+        <p:nvCxnSpPr>
+          <p:cNvPr id="33" name="Connector 32"/>
+          <p:cNvCxnSpPr/>
+          <p:nvPr/>
+        </p:nvCxnSpPr>
+        <p:spPr>
+          <a:xfrm>
+            <a:off x="5760720" y="2240280"/>
+            <a:ext cx="2285999" cy="640080"/>
+          </a:xfrm>
+          <a:prstGeom prst="line">
+            <a:avLst/>
+          </a:prstGeom>
+          <a:ln w="22225">
+            <a:solidFill>
+              <a:srgbClr val="94A3B8"/>
+            </a:solidFill>
+            <a:tailEnd type="triangle" w="med" len="med"/>
+          </a:ln>
+        </p:spPr>
+        <p:style>
+          <a:lnRef idx="2">
+            <a:schemeClr val="accent1"/>
+          </a:lnRef>
+          <a:fillRef idx="0">
+            <a:schemeClr val="accent1"/>
+          </a:fillRef>
+          <a:effectRef idx="1">
+            <a:schemeClr val="accent1"/>
+          </a:effectRef>
+          <a:fontRef idx="minor">
+            <a:schemeClr val="tx1"/>
+          </a:fontRef>
+        </p:style>
+      </p:cxnSp>
+      <p:sp>
+        <p:nvSpPr>
+          <p:cNvPr id="34" name="TextBox 33"/>
+          <p:cNvSpPr txBox="1"/>
+          <p:nvPr/>
+        </p:nvSpPr>
+        <p:spPr>
+          <a:xfrm>
+            <a:off x="6766560" y="3712463"/>
+            <a:ext cx="2560320" cy="274320"/>
+          </a:xfrm>
+          <a:prstGeom prst="rect">
+            <a:avLst/>
+          </a:prstGeom>
+          <a:noFill/>
+        </p:spPr>
+        <p:txBody>
+          <a:bodyPr wrap="square" anchor="t">
+            <a:spAutoFit/>
+          </a:bodyPr>
+          <a:lstStyle/>
+          <a:p>
+            <a:pPr algn="ctr"/>
+            <a:r>
+              <a:rPr sz="1000" b="0" i="1">
+                <a:solidFill>
+                  <a:srgbClr val="B45309"/>
+                </a:solidFill>
+                <a:latin typeface="Calibri"/>
+              </a:rPr>
+              <a:t>↑ owner-scoped: you see the mice you own</a:t>
+            </a:r>
+          </a:p>
+        </p:txBody>
+      </p:sp>
+      <p:sp>
+        <p:nvSpPr>
+          <p:cNvPr id="35" name="TextBox 34"/>
+          <p:cNvSpPr txBox="1"/>
+          <p:nvPr/>
+        </p:nvSpPr>
+        <p:spPr>
+          <a:xfrm>
+            <a:off x="320040" y="4160520"/>
+            <a:ext cx="4572000" cy="274320"/>
+          </a:xfrm>
+          <a:prstGeom prst="rect">
+            <a:avLst/>
+          </a:prstGeom>
+          <a:noFill/>
+        </p:spPr>
+        <p:txBody>
+          <a:bodyPr wrap="square" anchor="t">
+            <a:spAutoFit/>
+          </a:bodyPr>
+          <a:lstStyle/>
+          <a:p>
+            <a:pPr algn="l"/>
+            <a:r>
+              <a:rPr sz="1100" b="1" i="1">
+                <a:solidFill>
+                  <a:srgbClr val="64748B"/>
+                </a:solidFill>
+                <a:latin typeface="Calibri"/>
+              </a:rPr>
+              <a:t>Requests &amp; email notifications:</a:t>
+            </a:r>
+          </a:p>
+        </p:txBody>
+      </p:sp>
+      <p:sp>
+        <p:nvSpPr>
+          <p:cNvPr id="36" name="Rounded Rectangle 35"/>
+          <p:cNvSpPr/>
+          <p:nvPr/>
+        </p:nvSpPr>
+        <p:spPr>
+          <a:xfrm>
+            <a:off x="320040" y="4480560"/>
+            <a:ext cx="2148840" cy="914400"/>
           </a:xfrm>
           <a:prstGeom prst="roundRect">
             <a:avLst/>
@@ -4162,6 +4757,7 @@
           <a:ln>
             <a:noFill/>
           </a:ln>
+          <a:effectLst/>
         </p:spPr>
         <p:style>
           <a:lnRef idx="1">
@@ -4178,7 +4774,7 @@
           </a:fontRef>
         </p:style>
         <p:txBody>
-          <a:bodyPr rtlCol="0" anchor="ctr" wrap="square" lIns="73152" rIns="73152" tIns="36576" bIns="36576"/>
+          <a:bodyPr rtlCol="0" anchor="ctr" wrap="square" lIns="45720" rIns="45720"/>
           <a:lstStyle/>
           <a:p>
             <a:pPr algn="ctr"/>
@@ -4189,76 +4785,33 @@
                 </a:solidFill>
                 <a:latin typeface="Calibri"/>
               </a:rPr>
-              <a:t>IMPORT</a:t>
+              <a:t>File a request</a:t>
             </a:r>
           </a:p>
           <a:p>
             <a:pPr algn="ctr"/>
             <a:r>
-              <a:rPr sz="1000" b="0">
+              <a:rPr sz="1000">
                 <a:solidFill>
                   <a:srgbClr val="FFFFFF"/>
                 </a:solidFill>
                 <a:latin typeface="Calibri"/>
               </a:rPr>
-              <a:t>CSV / Excel → map → preview</a:t>
-            </a:r>
-          </a:p>
-        </p:txBody>
-      </p:sp>
-      <p:sp>
-        <p:nvSpPr>
-          <p:cNvPr id="6" name="Right Arrow 5"/>
+              <a:t>specific mouse # or by criteria</a:t>
+            </a:r>
+          </a:p>
+        </p:txBody>
+      </p:sp>
+      <p:sp>
+        <p:nvSpPr>
+          <p:cNvPr id="37" name="Rounded Rectangle 36"/>
           <p:cNvSpPr/>
           <p:nvPr/>
         </p:nvSpPr>
         <p:spPr>
           <a:xfrm>
-            <a:off x="3291840" y="2606040"/>
-            <a:ext cx="457200" cy="457200"/>
-          </a:xfrm>
-          <a:prstGeom prst="rightArrow">
-            <a:avLst/>
-          </a:prstGeom>
-          <a:solidFill>
-            <a:srgbClr val="64748B"/>
-          </a:solidFill>
-          <a:ln>
-            <a:noFill/>
-          </a:ln>
-        </p:spPr>
-        <p:style>
-          <a:lnRef idx="1">
-            <a:schemeClr val="accent1"/>
-          </a:lnRef>
-          <a:fillRef idx="3">
-            <a:schemeClr val="accent1"/>
-          </a:fillRef>
-          <a:effectRef idx="2">
-            <a:schemeClr val="accent1"/>
-          </a:effectRef>
-          <a:fontRef idx="minor">
-            <a:schemeClr val="lt1"/>
-          </a:fontRef>
-        </p:style>
-        <p:txBody>
-          <a:bodyPr rtlCol="0" anchor="ctr"/>
-          <a:lstStyle/>
-          <a:p>
-            <a:pPr algn="ctr"/>
-          </a:p>
-        </p:txBody>
-      </p:sp>
-      <p:sp>
-        <p:nvSpPr>
-          <p:cNvPr id="7" name="Rounded Rectangle 6"/>
-          <p:cNvSpPr/>
-          <p:nvPr/>
-        </p:nvSpPr>
-        <p:spPr>
-          <a:xfrm>
-            <a:off x="3886200" y="2011680"/>
-            <a:ext cx="2286000" cy="1463040"/>
+            <a:off x="2743200" y="4480560"/>
+            <a:ext cx="2514600" cy="914400"/>
           </a:xfrm>
           <a:prstGeom prst="roundRect">
             <a:avLst/>
@@ -4269,6 +4822,7 @@
           <a:ln>
             <a:noFill/>
           </a:ln>
+          <a:effectLst/>
         </p:spPr>
         <p:style>
           <a:lnRef idx="1">
@@ -4285,211 +4839,44 @@
           </a:fontRef>
         </p:style>
         <p:txBody>
-          <a:bodyPr rtlCol="0" anchor="ctr" wrap="square" lIns="73152" rIns="73152" tIns="36576" bIns="36576"/>
+          <a:bodyPr rtlCol="0" anchor="ctr" wrap="square" lIns="45720" rIns="45720"/>
           <a:lstStyle/>
           <a:p>
             <a:pPr algn="ctr"/>
             <a:r>
-              <a:rPr sz="1300" b="1">
+              <a:rPr sz="1200" b="1">
                 <a:solidFill>
                   <a:srgbClr val="FFFFFF"/>
                 </a:solidFill>
                 <a:latin typeface="Calibri"/>
               </a:rPr>
-              <a:t>mice table</a:t>
+              <a:t>Match a live mouse → Owner</a:t>
             </a:r>
           </a:p>
           <a:p>
             <a:pPr algn="ctr"/>
             <a:r>
-              <a:rPr sz="1100" b="0">
+              <a:rPr sz="1000">
                 <a:solidFill>
                   <a:srgbClr val="FFFFFF"/>
                 </a:solidFill>
                 <a:latin typeface="Calibri"/>
               </a:rPr>
-              <a:t>(+ mouse_v view:</a:t>
-            </a:r>
-          </a:p>
-          <a:p>
-            <a:pPr algn="ctr"/>
-            <a:r>
-              <a:rPr sz="1100" b="0">
-                <a:solidFill>
-                  <a:srgbClr val="FFFFFF"/>
-                </a:solidFill>
-                <a:latin typeface="Calibri"/>
-              </a:rPr>
-              <a:t>age, staleness)</a:t>
-            </a:r>
-          </a:p>
-        </p:txBody>
-      </p:sp>
-      <p:sp>
-        <p:nvSpPr>
-          <p:cNvPr id="8" name="Right Arrow 7"/>
+              <a:t>none available → Breeding queue</a:t>
+            </a:r>
+          </a:p>
+        </p:txBody>
+      </p:sp>
+      <p:sp>
+        <p:nvSpPr>
+          <p:cNvPr id="38" name="Rounded Rectangle 37"/>
           <p:cNvSpPr/>
           <p:nvPr/>
         </p:nvSpPr>
         <p:spPr>
           <a:xfrm>
-            <a:off x="6263640" y="2606040"/>
-            <a:ext cx="457200" cy="457200"/>
-          </a:xfrm>
-          <a:prstGeom prst="rightArrow">
-            <a:avLst/>
-          </a:prstGeom>
-          <a:solidFill>
-            <a:srgbClr val="64748B"/>
-          </a:solidFill>
-          <a:ln>
-            <a:noFill/>
-          </a:ln>
-        </p:spPr>
-        <p:style>
-          <a:lnRef idx="1">
-            <a:schemeClr val="accent1"/>
-          </a:lnRef>
-          <a:fillRef idx="3">
-            <a:schemeClr val="accent1"/>
-          </a:fillRef>
-          <a:effectRef idx="2">
-            <a:schemeClr val="accent1"/>
-          </a:effectRef>
-          <a:fontRef idx="minor">
-            <a:schemeClr val="lt1"/>
-          </a:fontRef>
-        </p:style>
-        <p:txBody>
-          <a:bodyPr rtlCol="0" anchor="ctr"/>
-          <a:lstStyle/>
-          <a:p>
-            <a:pPr algn="ctr"/>
-          </a:p>
-        </p:txBody>
-      </p:sp>
-      <p:sp>
-        <p:nvSpPr>
-          <p:cNvPr id="9" name="Rounded Rectangle 8"/>
-          <p:cNvSpPr/>
-          <p:nvPr/>
-        </p:nvSpPr>
-        <p:spPr>
-          <a:xfrm>
-            <a:off x="6858000" y="1600200"/>
-            <a:ext cx="4846320" cy="2194560"/>
-          </a:xfrm>
-          <a:prstGeom prst="roundRect">
-            <a:avLst/>
-          </a:prstGeom>
-          <a:solidFill>
-            <a:srgbClr val="334155"/>
-          </a:solidFill>
-          <a:ln>
-            <a:noFill/>
-          </a:ln>
-        </p:spPr>
-        <p:style>
-          <a:lnRef idx="1">
-            <a:schemeClr val="accent1"/>
-          </a:lnRef>
-          <a:fillRef idx="3">
-            <a:schemeClr val="accent1"/>
-          </a:fillRef>
-          <a:effectRef idx="2">
-            <a:schemeClr val="accent1"/>
-          </a:effectRef>
-          <a:fontRef idx="minor">
-            <a:schemeClr val="lt1"/>
-          </a:fontRef>
-        </p:style>
-        <p:txBody>
-          <a:bodyPr rtlCol="0" anchor="ctr" wrap="square" lIns="73152" rIns="73152" tIns="36576" bIns="36576"/>
-          <a:lstStyle/>
-          <a:p>
-            <a:pPr algn="ctr"/>
-            <a:r>
-              <a:rPr sz="1200" b="0">
-                <a:solidFill>
-                  <a:srgbClr val="FFFFFF"/>
-                </a:solidFill>
-                <a:latin typeface="Calibri"/>
-              </a:rPr>
-              <a:t>BROWSE &amp; MANAGE</a:t>
-            </a:r>
-          </a:p>
-          <a:p>
-            <a:pPr algn="ctr"/>
-            <a:r>
-              <a:rPr sz="1000" b="0">
-                <a:solidFill>
-                  <a:srgbClr val="FFFFFF"/>
-                </a:solidFill>
-                <a:latin typeface="Calibri"/>
-              </a:rPr>
-              <a:t/>
-            </a:r>
-          </a:p>
-          <a:p>
-            <a:pPr algn="ctr"/>
-            <a:r>
-              <a:rPr sz="1000" b="0">
-                <a:solidFill>
-                  <a:srgbClr val="FFFFFF"/>
-                </a:solidFill>
-                <a:latin typeface="Calibri"/>
-              </a:rPr>
-              <a:t>• Search / filter / sort • Individual &amp; Grouped views</a:t>
-            </a:r>
-          </a:p>
-          <a:p>
-            <a:pPr algn="ctr"/>
-            <a:r>
-              <a:rPr sz="1000" b="0">
-                <a:solidFill>
-                  <a:srgbClr val="FFFFFF"/>
-                </a:solidFill>
-                <a:latin typeface="Calibri"/>
-              </a:rPr>
-              <a:t>• My colony (your cohorts) • batch edit</a:t>
-            </a:r>
-          </a:p>
-          <a:p>
-            <a:pPr algn="ctr"/>
-            <a:r>
-              <a:rPr sz="1000" b="0">
-                <a:solidFill>
-                  <a:srgbClr val="FFFFFF"/>
-                </a:solidFill>
-                <a:latin typeface="Calibri"/>
-              </a:rPr>
-              <a:t>• Modify a cohort: add / remove / renumber</a:t>
-            </a:r>
-          </a:p>
-          <a:p>
-            <a:pPr algn="ctr"/>
-            <a:r>
-              <a:rPr sz="1000" b="0">
-                <a:solidFill>
-                  <a:srgbClr val="FFFFFF"/>
-                </a:solidFill>
-                <a:latin typeface="Calibri"/>
-              </a:rPr>
-              <a:t>• Requests &amp; approvals</a:t>
-            </a:r>
-          </a:p>
-        </p:txBody>
-      </p:sp>
-      <p:sp>
-        <p:nvSpPr>
-          <p:cNvPr id="10" name="Rounded Rectangle 9"/>
-          <p:cNvSpPr/>
-          <p:nvPr/>
-        </p:nvSpPr>
-        <p:spPr>
-          <a:xfrm>
-            <a:off x="457200" y="4572000"/>
-            <a:ext cx="11247120" cy="640080"/>
+            <a:off x="5532120" y="4480560"/>
+            <a:ext cx="2331720" cy="914400"/>
           </a:xfrm>
           <a:prstGeom prst="roundRect">
             <a:avLst/>
@@ -4500,6 +4887,7 @@
           <a:ln>
             <a:noFill/>
           </a:ln>
+          <a:effectLst/>
         </p:spPr>
         <p:style>
           <a:lnRef idx="1">
@@ -4516,283 +4904,44 @@
           </a:fontRef>
         </p:style>
         <p:txBody>
-          <a:bodyPr rtlCol="0" anchor="ctr" wrap="square" lIns="73152" rIns="73152" tIns="36576" bIns="36576"/>
+          <a:bodyPr rtlCol="0" anchor="ctr" wrap="square" lIns="45720" rIns="45720"/>
           <a:lstStyle/>
           <a:p>
             <a:pPr algn="ctr"/>
             <a:r>
-              <a:rPr sz="1300" b="1">
+              <a:rPr sz="1200" b="1">
                 <a:solidFill>
                   <a:srgbClr val="FFFFFF"/>
                 </a:solidFill>
                 <a:latin typeface="Calibri"/>
               </a:rPr>
-              <a:t>Every create / edit / delete is attributed to a user and written to the audit_log</a:t>
-            </a:r>
-          </a:p>
-        </p:txBody>
-      </p:sp>
-      <p:sp>
-        <p:nvSpPr>
-          <p:cNvPr id="11" name="TextBox 10"/>
-          <p:cNvSpPr txBox="1"/>
-          <p:nvPr/>
-        </p:nvSpPr>
-        <p:spPr>
-          <a:xfrm>
-            <a:off x="548640" y="5806440"/>
-            <a:ext cx="11155680" cy="914400"/>
-          </a:xfrm>
-          <a:prstGeom prst="rect">
-            <a:avLst/>
-          </a:prstGeom>
-          <a:noFill/>
-        </p:spPr>
-        <p:txBody>
-          <a:bodyPr wrap="square">
-            <a:spAutoFit/>
-          </a:bodyPr>
-          <a:lstStyle/>
-          <a:p>
-            <a:pPr>
-              <a:spcAft>
-                <a:spcPts val="600"/>
-              </a:spcAft>
-            </a:pPr>
-            <a:r>
-              <a:rPr sz="1300" b="0">
-                <a:solidFill>
-                  <a:srgbClr val="64748B"/>
+              <a:t>Approve / transfer / route</a:t>
+            </a:r>
+          </a:p>
+          <a:p>
+            <a:pPr algn="ctr"/>
+            <a:r>
+              <a:rPr sz="1000">
+                <a:solidFill>
+                  <a:srgbClr val="FFFFFF"/>
                 </a:solidFill>
                 <a:latin typeface="Calibri"/>
               </a:rPr>
-              <a:t>• Genotype = WT / Tau / … (controlled) · Strain = C57BL/6 / hMAP · Location = Facility→Room→Rack→Row/Col→Cage.</a:t>
-            </a:r>
-          </a:p>
-        </p:txBody>
-      </p:sp>
-    </p:spTree>
-  </p:cSld>
-  <p:clrMapOvr>
-    <a:masterClrMapping/>
-  </p:clrMapOvr>
-</p:sld>
-</file>
-
-<file path=ppt/slides/slide4.xml><?xml version="1.0" encoding="utf-8"?>
-<p:sld xmlns:a="http://schemas.openxmlformats.org/drawingml/2006/main" xmlns:p="http://schemas.openxmlformats.org/presentationml/2006/main" xmlns:r="http://schemas.openxmlformats.org/officeDocument/2006/relationships">
-  <p:cSld>
-    <p:spTree>
-      <p:nvGrpSpPr>
-        <p:cNvPr id="1" name=""/>
-        <p:cNvGrpSpPr/>
-        <p:nvPr/>
-      </p:nvGrpSpPr>
-      <p:grpSpPr/>
-      <p:sp>
-        <p:nvSpPr>
-          <p:cNvPr id="2" name="Rectangle 1"/>
+              <a:t>Manager or PI only</a:t>
+            </a:r>
+          </a:p>
+        </p:txBody>
+      </p:sp>
+      <p:sp>
+        <p:nvSpPr>
+          <p:cNvPr id="39" name="Rounded Rectangle 38"/>
           <p:cNvSpPr/>
           <p:nvPr/>
         </p:nvSpPr>
         <p:spPr>
           <a:xfrm>
-            <a:off x="0" y="0"/>
-            <a:ext cx="12191695" cy="960120"/>
-          </a:xfrm>
-          <a:prstGeom prst="rect">
-            <a:avLst/>
-          </a:prstGeom>
-          <a:solidFill>
-            <a:srgbClr val="1E3A8A"/>
-          </a:solidFill>
-          <a:ln>
-            <a:noFill/>
-          </a:ln>
-        </p:spPr>
-        <p:style>
-          <a:lnRef idx="1">
-            <a:schemeClr val="accent1"/>
-          </a:lnRef>
-          <a:fillRef idx="3">
-            <a:schemeClr val="accent1"/>
-          </a:fillRef>
-          <a:effectRef idx="2">
-            <a:schemeClr val="accent1"/>
-          </a:effectRef>
-          <a:fontRef idx="minor">
-            <a:schemeClr val="lt1"/>
-          </a:fontRef>
-        </p:style>
-        <p:txBody>
-          <a:bodyPr rtlCol="0" anchor="ctr" lIns="457200"/>
-          <a:lstStyle/>
-          <a:p>
-            <a:pPr algn="ctr"/>
-            <a:r>
-              <a:rPr sz="2600" b="1">
-                <a:solidFill>
-                  <a:srgbClr val="FFFFFF"/>
-                </a:solidFill>
-                <a:latin typeface="Calibri"/>
-              </a:rPr>
-              <a:t>Multiple users</a:t>
-            </a:r>
-          </a:p>
-        </p:txBody>
-      </p:sp>
-      <p:sp>
-        <p:nvSpPr>
-          <p:cNvPr id="3" name="TextBox 2"/>
-          <p:cNvSpPr txBox="1"/>
-          <p:nvPr/>
-        </p:nvSpPr>
-        <p:spPr>
-          <a:xfrm>
-            <a:off x="475488" y="1005840"/>
-            <a:ext cx="11338560" cy="365760"/>
-          </a:xfrm>
-          <a:prstGeom prst="rect">
-            <a:avLst/>
-          </a:prstGeom>
-          <a:noFill/>
-        </p:spPr>
-        <p:txBody>
-          <a:bodyPr wrap="square" anchor="t">
-            <a:spAutoFit/>
-          </a:bodyPr>
-          <a:lstStyle/>
-          <a:p>
-            <a:pPr algn="l"/>
-            <a:r>
-              <a:rPr sz="1300" b="0" i="1">
-                <a:solidFill>
-                  <a:srgbClr val="64748B"/>
-                </a:solidFill>
-                <a:latin typeface="Calibri"/>
-              </a:rPr>
-              <a:t>Simple shared login now; upgradeable to real accounts later.</a:t>
-            </a:r>
-          </a:p>
-        </p:txBody>
-      </p:sp>
-      <p:sp>
-        <p:nvSpPr>
-          <p:cNvPr id="4" name="Rounded Rectangle 3"/>
-          <p:cNvSpPr/>
-          <p:nvPr/>
-        </p:nvSpPr>
-        <p:spPr>
-          <a:xfrm>
-            <a:off x="457200" y="1737360"/>
-            <a:ext cx="3108960" cy="1051560"/>
-          </a:xfrm>
-          <a:prstGeom prst="roundRect">
-            <a:avLst/>
-          </a:prstGeom>
-          <a:solidFill>
-            <a:srgbClr val="2563EB"/>
-          </a:solidFill>
-          <a:ln>
-            <a:noFill/>
-          </a:ln>
-        </p:spPr>
-        <p:style>
-          <a:lnRef idx="1">
-            <a:schemeClr val="accent1"/>
-          </a:lnRef>
-          <a:fillRef idx="3">
-            <a:schemeClr val="accent1"/>
-          </a:fillRef>
-          <a:effectRef idx="2">
-            <a:schemeClr val="accent1"/>
-          </a:effectRef>
-          <a:fontRef idx="minor">
-            <a:schemeClr val="lt1"/>
-          </a:fontRef>
-        </p:style>
-        <p:txBody>
-          <a:bodyPr rtlCol="0" anchor="ctr" wrap="square" lIns="73152" rIns="73152" tIns="36576" bIns="36576"/>
-          <a:lstStyle/>
-          <a:p>
-            <a:pPr algn="ctr"/>
-            <a:r>
-              <a:rPr sz="1300" b="1">
-                <a:solidFill>
-                  <a:srgbClr val="FFFFFF"/>
-                </a:solidFill>
-                <a:latin typeface="Calibri"/>
-              </a:rPr>
-              <a:t>Pick your name</a:t>
-            </a:r>
-          </a:p>
-          <a:p>
-            <a:pPr algn="ctr"/>
-            <a:r>
-              <a:rPr sz="1100" b="0">
-                <a:solidFill>
-                  <a:srgbClr val="FFFFFF"/>
-                </a:solidFill>
-                <a:latin typeface="Calibri"/>
-              </a:rPr>
-              <a:t>+ shared lab password</a:t>
-            </a:r>
-          </a:p>
-        </p:txBody>
-      </p:sp>
-      <p:sp>
-        <p:nvSpPr>
-          <p:cNvPr id="5" name="Right Arrow 4"/>
-          <p:cNvSpPr/>
-          <p:nvPr/>
-        </p:nvSpPr>
-        <p:spPr>
-          <a:xfrm>
-            <a:off x="3657600" y="2057400"/>
-            <a:ext cx="457200" cy="411480"/>
-          </a:xfrm>
-          <a:prstGeom prst="rightArrow">
-            <a:avLst/>
-          </a:prstGeom>
-          <a:solidFill>
-            <a:srgbClr val="64748B"/>
-          </a:solidFill>
-          <a:ln>
-            <a:noFill/>
-          </a:ln>
-        </p:spPr>
-        <p:style>
-          <a:lnRef idx="1">
-            <a:schemeClr val="accent1"/>
-          </a:lnRef>
-          <a:fillRef idx="3">
-            <a:schemeClr val="accent1"/>
-          </a:fillRef>
-          <a:effectRef idx="2">
-            <a:schemeClr val="accent1"/>
-          </a:effectRef>
-          <a:fontRef idx="minor">
-            <a:schemeClr val="lt1"/>
-          </a:fontRef>
-        </p:style>
-        <p:txBody>
-          <a:bodyPr rtlCol="0" anchor="ctr"/>
-          <a:lstStyle/>
-          <a:p>
-            <a:pPr algn="ctr"/>
-          </a:p>
-        </p:txBody>
-      </p:sp>
-      <p:sp>
-        <p:nvSpPr>
-          <p:cNvPr id="6" name="Rounded Rectangle 5"/>
-          <p:cNvSpPr/>
-          <p:nvPr/>
-        </p:nvSpPr>
-        <p:spPr>
-          <a:xfrm>
-            <a:off x="4206240" y="1737360"/>
-            <a:ext cx="3108960" cy="1051560"/>
+            <a:off x="8138160" y="4315968"/>
+            <a:ext cx="3840480" cy="566928"/>
           </a:xfrm>
           <a:prstGeom prst="roundRect">
             <a:avLst/>
@@ -4803,6 +4952,7 @@
           <a:ln>
             <a:noFill/>
           </a:ln>
+          <a:effectLst/>
         </p:spPr>
         <p:style>
           <a:lnRef idx="1">
@@ -4819,807 +4969,32 @@
           </a:fontRef>
         </p:style>
         <p:txBody>
-          <a:bodyPr rtlCol="0" anchor="ctr" wrap="square" lIns="73152" rIns="73152" tIns="36576" bIns="36576"/>
+          <a:bodyPr rtlCol="0" anchor="ctr" wrap="square" lIns="45720" rIns="45720"/>
           <a:lstStyle/>
           <a:p>
             <a:pPr algn="ctr"/>
             <a:r>
-              <a:rPr sz="1300" b="1">
+              <a:rPr sz="1200" b="1">
                 <a:solidFill>
                   <a:srgbClr val="FFFFFF"/>
                 </a:solidFill>
                 <a:latin typeface="Calibri"/>
               </a:rPr>
-              <a:t>First login only:</a:t>
-            </a:r>
-          </a:p>
-          <a:p>
-            <a:pPr algn="ctr"/>
-            <a:r>
-              <a:rPr sz="1100" b="0">
-                <a:solidFill>
-                  <a:srgbClr val="FFFFFF"/>
-                </a:solidFill>
-                <a:latin typeface="Calibri"/>
-              </a:rPr>
-              <a:t>enter your email once</a:t>
-            </a:r>
-          </a:p>
-        </p:txBody>
-      </p:sp>
-      <p:sp>
-        <p:nvSpPr>
-          <p:cNvPr id="7" name="Right Arrow 6"/>
+              <a:t>Notify: Owner · Managers · PI</a:t>
+            </a:r>
+          </a:p>
+        </p:txBody>
+      </p:sp>
+      <p:sp>
+        <p:nvSpPr>
+          <p:cNvPr id="40" name="Rounded Rectangle 39"/>
           <p:cNvSpPr/>
           <p:nvPr/>
         </p:nvSpPr>
         <p:spPr>
           <a:xfrm>
-            <a:off x="7406640" y="2057400"/>
-            <a:ext cx="457200" cy="411480"/>
-          </a:xfrm>
-          <a:prstGeom prst="rightArrow">
-            <a:avLst/>
-          </a:prstGeom>
-          <a:solidFill>
-            <a:srgbClr val="64748B"/>
-          </a:solidFill>
-          <a:ln>
-            <a:noFill/>
-          </a:ln>
-        </p:spPr>
-        <p:style>
-          <a:lnRef idx="1">
-            <a:schemeClr val="accent1"/>
-          </a:lnRef>
-          <a:fillRef idx="3">
-            <a:schemeClr val="accent1"/>
-          </a:fillRef>
-          <a:effectRef idx="2">
-            <a:schemeClr val="accent1"/>
-          </a:effectRef>
-          <a:fontRef idx="minor">
-            <a:schemeClr val="lt1"/>
-          </a:fontRef>
-        </p:style>
-        <p:txBody>
-          <a:bodyPr rtlCol="0" anchor="ctr"/>
-          <a:lstStyle/>
-          <a:p>
-            <a:pPr algn="ctr"/>
-          </a:p>
-        </p:txBody>
-      </p:sp>
-      <p:sp>
-        <p:nvSpPr>
-          <p:cNvPr id="8" name="Rounded Rectangle 7"/>
-          <p:cNvSpPr/>
-          <p:nvPr/>
-        </p:nvSpPr>
-        <p:spPr>
-          <a:xfrm>
-            <a:off x="7955279" y="1737360"/>
-            <a:ext cx="3749039" cy="1051560"/>
-          </a:xfrm>
-          <a:prstGeom prst="roundRect">
-            <a:avLst/>
-          </a:prstGeom>
-          <a:solidFill>
-            <a:srgbClr val="15803D"/>
-          </a:solidFill>
-          <a:ln>
-            <a:noFill/>
-          </a:ln>
-        </p:spPr>
-        <p:style>
-          <a:lnRef idx="1">
-            <a:schemeClr val="accent1"/>
-          </a:lnRef>
-          <a:fillRef idx="3">
-            <a:schemeClr val="accent1"/>
-          </a:fillRef>
-          <a:effectRef idx="2">
-            <a:schemeClr val="accent1"/>
-          </a:effectRef>
-          <a:fontRef idx="minor">
-            <a:schemeClr val="lt1"/>
-          </a:fontRef>
-        </p:style>
-        <p:txBody>
-          <a:bodyPr rtlCol="0" anchor="ctr" wrap="square" lIns="73152" rIns="73152" tIns="36576" bIns="36576"/>
-          <a:lstStyle/>
-          <a:p>
-            <a:pPr algn="ctr"/>
-            <a:r>
-              <a:rPr sz="1300" b="1">
-                <a:solidFill>
-                  <a:srgbClr val="FFFFFF"/>
-                </a:solidFill>
-                <a:latin typeface="Calibri"/>
-              </a:rPr>
-              <a:t>Use the app — every edit</a:t>
-            </a:r>
-          </a:p>
-          <a:p>
-            <a:pPr algn="ctr"/>
-            <a:r>
-              <a:rPr sz="1100" b="0">
-                <a:solidFill>
-                  <a:srgbClr val="FFFFFF"/>
-                </a:solidFill>
-                <a:latin typeface="Calibri"/>
-              </a:rPr>
-              <a:t>tagged with your name</a:t>
-            </a:r>
-          </a:p>
-        </p:txBody>
-      </p:sp>
-      <p:sp>
-        <p:nvSpPr>
-          <p:cNvPr id="9" name="TextBox 8"/>
-          <p:cNvSpPr txBox="1"/>
-          <p:nvPr/>
-        </p:nvSpPr>
-        <p:spPr>
-          <a:xfrm>
-            <a:off x="548640" y="3200400"/>
-            <a:ext cx="11155680" cy="3108960"/>
-          </a:xfrm>
-          <a:prstGeom prst="rect">
-            <a:avLst/>
-          </a:prstGeom>
-          <a:noFill/>
-        </p:spPr>
-        <p:txBody>
-          <a:bodyPr wrap="square">
-            <a:spAutoFit/>
-          </a:bodyPr>
-          <a:lstStyle/>
-          <a:p>
-            <a:pPr>
-              <a:spcAft>
-                <a:spcPts val="600"/>
-              </a:spcAft>
-            </a:pPr>
-            <a:r>
-              <a:rPr sz="1500" b="0">
-                <a:solidFill>
-                  <a:srgbClr val="1A1D26"/>
-                </a:solidFill>
-                <a:latin typeface="Calibri"/>
-              </a:rPr>
-              <a:t>• Roles: PI · Manager · Member (drive request routing &amp; who can approve).</a:t>
-            </a:r>
-          </a:p>
-          <a:p>
-            <a:pPr>
-              <a:spcAft>
-                <a:spcPts val="600"/>
-              </a:spcAft>
-            </a:pPr>
-            <a:r>
-              <a:rPr sz="1500" b="0">
-                <a:solidFill>
-                  <a:srgbClr val="1A1D26"/>
-                </a:solidFill>
-                <a:latin typeface="Calibri"/>
-              </a:rPr>
-              <a:t>• Identity is remembered in your browser; your name is stamped on every change (audit trail).</a:t>
-            </a:r>
-          </a:p>
-          <a:p>
-            <a:pPr>
-              <a:spcAft>
-                <a:spcPts val="600"/>
-              </a:spcAft>
-            </a:pPr>
-            <a:r>
-              <a:rPr sz="1500" b="0">
-                <a:solidFill>
-                  <a:srgbClr val="1A1D26"/>
-                </a:solidFill>
-                <a:latin typeface="Calibri"/>
-              </a:rPr>
-              <a:t>• Your saved email is used for notifications (set once, never asked again).</a:t>
-            </a:r>
-          </a:p>
-          <a:p>
-            <a:pPr>
-              <a:spcAft>
-                <a:spcPts val="600"/>
-              </a:spcAft>
-            </a:pPr>
-            <a:r>
-              <a:rPr sz="1500" b="1">
-                <a:solidFill>
-                  <a:srgbClr val="1A1D26"/>
-                </a:solidFill>
-                <a:latin typeface="Calibri"/>
-              </a:rPr>
-              <a:t>• Security model:</a:t>
-            </a:r>
-          </a:p>
-          <a:p>
-            <a:pPr lvl="1">
-              <a:spcAft>
-                <a:spcPts val="600"/>
-              </a:spcAft>
-            </a:pPr>
-            <a:r>
-              <a:rPr sz="1300" b="0">
-                <a:solidFill>
-                  <a:srgbClr val="1A1D26"/>
-                </a:solidFill>
-                <a:latin typeface="Calibri"/>
-              </a:rPr>
-              <a:t>– Internal shared password + one public key — a soft gate for a trusted lab, not per-person security.</a:t>
-            </a:r>
-          </a:p>
-          <a:p>
-            <a:pPr lvl="1">
-              <a:spcAft>
-                <a:spcPts val="600"/>
-              </a:spcAft>
-            </a:pPr>
-            <a:r>
-              <a:rPr sz="1300" b="0">
-                <a:solidFill>
-                  <a:srgbClr val="1A1D26"/>
-                </a:solidFill>
-                <a:latin typeface="Calibri"/>
-              </a:rPr>
-              <a:t>– Anyone with the link + password can view/edit; all actions are logged.</a:t>
-            </a:r>
-          </a:p>
-          <a:p>
-            <a:pPr lvl="1">
-              <a:spcAft>
-                <a:spcPts val="600"/>
-              </a:spcAft>
-            </a:pPr>
-            <a:r>
-              <a:rPr sz="1300" b="0">
-                <a:solidFill>
-                  <a:srgbClr val="1A1D26"/>
-                </a:solidFill>
-                <a:latin typeface="Calibri"/>
-              </a:rPr>
-              <a:t>– Upgrade path: swap in real per-user accounts (magic-link / Google SSO) with no schema change.</a:t>
-            </a:r>
-          </a:p>
-        </p:txBody>
-      </p:sp>
-    </p:spTree>
-  </p:cSld>
-  <p:clrMapOvr>
-    <a:masterClrMapping/>
-  </p:clrMapOvr>
-</p:sld>
-</file>
-
-<file path=ppt/slides/slide5.xml><?xml version="1.0" encoding="utf-8"?>
-<p:sld xmlns:a="http://schemas.openxmlformats.org/drawingml/2006/main" xmlns:p="http://schemas.openxmlformats.org/presentationml/2006/main" xmlns:r="http://schemas.openxmlformats.org/officeDocument/2006/relationships">
-  <p:cSld>
-    <p:spTree>
-      <p:nvGrpSpPr>
-        <p:cNvPr id="1" name=""/>
-        <p:cNvGrpSpPr/>
-        <p:nvPr/>
-      </p:nvGrpSpPr>
-      <p:grpSpPr/>
-      <p:sp>
-        <p:nvSpPr>
-          <p:cNvPr id="2" name="Rectangle 1"/>
-          <p:cNvSpPr/>
-          <p:nvPr/>
-        </p:nvSpPr>
-        <p:spPr>
-          <a:xfrm>
-            <a:off x="0" y="0"/>
-            <a:ext cx="12191695" cy="960120"/>
-          </a:xfrm>
-          <a:prstGeom prst="rect">
-            <a:avLst/>
-          </a:prstGeom>
-          <a:solidFill>
-            <a:srgbClr val="1E3A8A"/>
-          </a:solidFill>
-          <a:ln>
-            <a:noFill/>
-          </a:ln>
-        </p:spPr>
-        <p:style>
-          <a:lnRef idx="1">
-            <a:schemeClr val="accent1"/>
-          </a:lnRef>
-          <a:fillRef idx="3">
-            <a:schemeClr val="accent1"/>
-          </a:fillRef>
-          <a:effectRef idx="2">
-            <a:schemeClr val="accent1"/>
-          </a:effectRef>
-          <a:fontRef idx="minor">
-            <a:schemeClr val="lt1"/>
-          </a:fontRef>
-        </p:style>
-        <p:txBody>
-          <a:bodyPr rtlCol="0" anchor="ctr" lIns="457200"/>
-          <a:lstStyle/>
-          <a:p>
-            <a:pPr algn="ctr"/>
-            <a:r>
-              <a:rPr sz="2600" b="1">
-                <a:solidFill>
-                  <a:srgbClr val="FFFFFF"/>
-                </a:solidFill>
-                <a:latin typeface="Calibri"/>
-              </a:rPr>
-              <a:t>Requests &amp; email notifications</a:t>
-            </a:r>
-          </a:p>
-        </p:txBody>
-      </p:sp>
-      <p:sp>
-        <p:nvSpPr>
-          <p:cNvPr id="3" name="TextBox 2"/>
-          <p:cNvSpPr txBox="1"/>
-          <p:nvPr/>
-        </p:nvSpPr>
-        <p:spPr>
-          <a:xfrm>
-            <a:off x="475488" y="1005840"/>
-            <a:ext cx="11338560" cy="365760"/>
-          </a:xfrm>
-          <a:prstGeom prst="rect">
-            <a:avLst/>
-          </a:prstGeom>
-          <a:noFill/>
-        </p:spPr>
-        <p:txBody>
-          <a:bodyPr wrap="square" anchor="t">
-            <a:spAutoFit/>
-          </a:bodyPr>
-          <a:lstStyle/>
-          <a:p>
-            <a:pPr algn="l"/>
-            <a:r>
-              <a:rPr sz="1300" b="0" i="1">
-                <a:solidFill>
-                  <a:srgbClr val="64748B"/>
-                </a:solidFill>
-                <a:latin typeface="Calibri"/>
-              </a:rPr>
-              <a:t>Ask for mice; the right people get emailed automatically.</a:t>
-            </a:r>
-          </a:p>
-        </p:txBody>
-      </p:sp>
-      <p:sp>
-        <p:nvSpPr>
-          <p:cNvPr id="4" name="Rounded Rectangle 3"/>
-          <p:cNvSpPr/>
-          <p:nvPr/>
-        </p:nvSpPr>
-        <p:spPr>
-          <a:xfrm>
-            <a:off x="365760" y="1600200"/>
-            <a:ext cx="2468880" cy="1051560"/>
-          </a:xfrm>
-          <a:prstGeom prst="roundRect">
-            <a:avLst/>
-          </a:prstGeom>
-          <a:solidFill>
-            <a:srgbClr val="2563EB"/>
-          </a:solidFill>
-          <a:ln>
-            <a:noFill/>
-          </a:ln>
-        </p:spPr>
-        <p:style>
-          <a:lnRef idx="1">
-            <a:schemeClr val="accent1"/>
-          </a:lnRef>
-          <a:fillRef idx="3">
-            <a:schemeClr val="accent1"/>
-          </a:fillRef>
-          <a:effectRef idx="2">
-            <a:schemeClr val="accent1"/>
-          </a:effectRef>
-          <a:fontRef idx="minor">
-            <a:schemeClr val="lt1"/>
-          </a:fontRef>
-        </p:style>
-        <p:txBody>
-          <a:bodyPr rtlCol="0" anchor="ctr" wrap="square" lIns="73152" rIns="73152" tIns="36576" bIns="36576"/>
-          <a:lstStyle/>
-          <a:p>
-            <a:pPr algn="ctr"/>
-            <a:r>
-              <a:rPr sz="1200" b="1">
-                <a:solidFill>
-                  <a:srgbClr val="FFFFFF"/>
-                </a:solidFill>
-                <a:latin typeface="Calibri"/>
-              </a:rPr>
-              <a:t>Member files a request</a:t>
-            </a:r>
-          </a:p>
-          <a:p>
-            <a:pPr algn="ctr"/>
-            <a:r>
-              <a:rPr sz="1000" b="0">
-                <a:solidFill>
-                  <a:srgbClr val="FFFFFF"/>
-                </a:solidFill>
-                <a:latin typeface="Calibri"/>
-              </a:rPr>
-              <a:t>(specific mouse # or by criteria)</a:t>
-            </a:r>
-          </a:p>
-        </p:txBody>
-      </p:sp>
-      <p:sp>
-        <p:nvSpPr>
-          <p:cNvPr id="5" name="Right Arrow 4"/>
-          <p:cNvSpPr/>
-          <p:nvPr/>
-        </p:nvSpPr>
-        <p:spPr>
-          <a:xfrm>
-            <a:off x="2926080" y="1920240"/>
-            <a:ext cx="411480" cy="411480"/>
-          </a:xfrm>
-          <a:prstGeom prst="rightArrow">
-            <a:avLst/>
-          </a:prstGeom>
-          <a:solidFill>
-            <a:srgbClr val="64748B"/>
-          </a:solidFill>
-          <a:ln>
-            <a:noFill/>
-          </a:ln>
-        </p:spPr>
-        <p:style>
-          <a:lnRef idx="1">
-            <a:schemeClr val="accent1"/>
-          </a:lnRef>
-          <a:fillRef idx="3">
-            <a:schemeClr val="accent1"/>
-          </a:fillRef>
-          <a:effectRef idx="2">
-            <a:schemeClr val="accent1"/>
-          </a:effectRef>
-          <a:fontRef idx="minor">
-            <a:schemeClr val="lt1"/>
-          </a:fontRef>
-        </p:style>
-        <p:txBody>
-          <a:bodyPr rtlCol="0" anchor="ctr"/>
-          <a:lstStyle/>
-          <a:p>
-            <a:pPr algn="ctr"/>
-          </a:p>
-        </p:txBody>
-      </p:sp>
-      <p:sp>
-        <p:nvSpPr>
-          <p:cNvPr id="6" name="Rounded Rectangle 5"/>
-          <p:cNvSpPr/>
-          <p:nvPr/>
-        </p:nvSpPr>
-        <p:spPr>
-          <a:xfrm>
-            <a:off x="3429000" y="1600200"/>
-            <a:ext cx="2468880" cy="1051560"/>
-          </a:xfrm>
-          <a:prstGeom prst="roundRect">
-            <a:avLst/>
-          </a:prstGeom>
-          <a:solidFill>
-            <a:srgbClr val="15803D"/>
-          </a:solidFill>
-          <a:ln>
-            <a:noFill/>
-          </a:ln>
-        </p:spPr>
-        <p:style>
-          <a:lnRef idx="1">
-            <a:schemeClr val="accent1"/>
-          </a:lnRef>
-          <a:fillRef idx="3">
-            <a:schemeClr val="accent1"/>
-          </a:fillRef>
-          <a:effectRef idx="2">
-            <a:schemeClr val="accent1"/>
-          </a:effectRef>
-          <a:fontRef idx="minor">
-            <a:schemeClr val="lt1"/>
-          </a:fontRef>
-        </p:style>
-        <p:txBody>
-          <a:bodyPr rtlCol="0" anchor="ctr" wrap="square" lIns="73152" rIns="73152" tIns="36576" bIns="36576"/>
-          <a:lstStyle/>
-          <a:p>
-            <a:pPr algn="ctr"/>
-            <a:r>
-              <a:rPr sz="1200" b="1">
-                <a:solidFill>
-                  <a:srgbClr val="FFFFFF"/>
-                </a:solidFill>
-                <a:latin typeface="Calibri"/>
-              </a:rPr>
-              <a:t>App finds a matching</a:t>
-            </a:r>
-          </a:p>
-          <a:p>
-            <a:pPr algn="ctr"/>
-            <a:r>
-              <a:rPr sz="1000" b="0">
-                <a:solidFill>
-                  <a:srgbClr val="FFFFFF"/>
-                </a:solidFill>
-                <a:latin typeface="Calibri"/>
-              </a:rPr>
-              <a:t>live mouse → its Owner</a:t>
-            </a:r>
-          </a:p>
-        </p:txBody>
-      </p:sp>
-      <p:sp>
-        <p:nvSpPr>
-          <p:cNvPr id="7" name="Right Arrow 6"/>
-          <p:cNvSpPr/>
-          <p:nvPr/>
-        </p:nvSpPr>
-        <p:spPr>
-          <a:xfrm>
-            <a:off x="5989320" y="1920240"/>
-            <a:ext cx="411480" cy="411480"/>
-          </a:xfrm>
-          <a:prstGeom prst="rightArrow">
-            <a:avLst/>
-          </a:prstGeom>
-          <a:solidFill>
-            <a:srgbClr val="64748B"/>
-          </a:solidFill>
-          <a:ln>
-            <a:noFill/>
-          </a:ln>
-        </p:spPr>
-        <p:style>
-          <a:lnRef idx="1">
-            <a:schemeClr val="accent1"/>
-          </a:lnRef>
-          <a:fillRef idx="3">
-            <a:schemeClr val="accent1"/>
-          </a:fillRef>
-          <a:effectRef idx="2">
-            <a:schemeClr val="accent1"/>
-          </a:effectRef>
-          <a:fontRef idx="minor">
-            <a:schemeClr val="lt1"/>
-          </a:fontRef>
-        </p:style>
-        <p:txBody>
-          <a:bodyPr rtlCol="0" anchor="ctr"/>
-          <a:lstStyle/>
-          <a:p>
-            <a:pPr algn="ctr"/>
-          </a:p>
-        </p:txBody>
-      </p:sp>
-      <p:sp>
-        <p:nvSpPr>
-          <p:cNvPr id="8" name="Rounded Rectangle 7"/>
-          <p:cNvSpPr/>
-          <p:nvPr/>
-        </p:nvSpPr>
-        <p:spPr>
-          <a:xfrm>
-            <a:off x="6492240" y="1600200"/>
-            <a:ext cx="2468880" cy="1051560"/>
-          </a:xfrm>
-          <a:prstGeom prst="roundRect">
-            <a:avLst/>
-          </a:prstGeom>
-          <a:solidFill>
-            <a:srgbClr val="B45309"/>
-          </a:solidFill>
-          <a:ln>
-            <a:noFill/>
-          </a:ln>
-        </p:spPr>
-        <p:style>
-          <a:lnRef idx="1">
-            <a:schemeClr val="accent1"/>
-          </a:lnRef>
-          <a:fillRef idx="3">
-            <a:schemeClr val="accent1"/>
-          </a:fillRef>
-          <a:effectRef idx="2">
-            <a:schemeClr val="accent1"/>
-          </a:effectRef>
-          <a:fontRef idx="minor">
-            <a:schemeClr val="lt1"/>
-          </a:fontRef>
-        </p:style>
-        <p:txBody>
-          <a:bodyPr rtlCol="0" anchor="ctr" wrap="square" lIns="73152" rIns="73152" tIns="36576" bIns="36576"/>
-          <a:lstStyle/>
-          <a:p>
-            <a:pPr algn="ctr"/>
-            <a:r>
-              <a:rPr sz="1200" b="1">
-                <a:solidFill>
-                  <a:srgbClr val="FFFFFF"/>
-                </a:solidFill>
-                <a:latin typeface="Calibri"/>
-              </a:rPr>
-              <a:t>None available →</a:t>
-            </a:r>
-          </a:p>
-          <a:p>
-            <a:pPr algn="ctr"/>
-            <a:r>
-              <a:rPr sz="1000" b="0">
-                <a:solidFill>
-                  <a:srgbClr val="FFFFFF"/>
-                </a:solidFill>
-                <a:latin typeface="Calibri"/>
-              </a:rPr>
-              <a:t>Breeding queue (Manager)</a:t>
-            </a:r>
-          </a:p>
-        </p:txBody>
-      </p:sp>
-      <p:sp>
-        <p:nvSpPr>
-          <p:cNvPr id="9" name="Down Arrow 8"/>
-          <p:cNvSpPr/>
-          <p:nvPr/>
-        </p:nvSpPr>
-        <p:spPr>
-          <a:xfrm>
-            <a:off x="4572000" y="2697480"/>
-            <a:ext cx="365760" cy="411480"/>
-          </a:xfrm>
-          <a:prstGeom prst="downArrow">
-            <a:avLst/>
-          </a:prstGeom>
-          <a:solidFill>
-            <a:srgbClr val="64748B"/>
-          </a:solidFill>
-          <a:ln>
-            <a:noFill/>
-          </a:ln>
-        </p:spPr>
-        <p:style>
-          <a:lnRef idx="1">
-            <a:schemeClr val="accent1"/>
-          </a:lnRef>
-          <a:fillRef idx="3">
-            <a:schemeClr val="accent1"/>
-          </a:fillRef>
-          <a:effectRef idx="2">
-            <a:schemeClr val="accent1"/>
-          </a:effectRef>
-          <a:fontRef idx="minor">
-            <a:schemeClr val="lt1"/>
-          </a:fontRef>
-        </p:style>
-        <p:txBody>
-          <a:bodyPr rtlCol="0" anchor="ctr"/>
-          <a:lstStyle/>
-          <a:p>
-            <a:pPr algn="ctr"/>
-          </a:p>
-        </p:txBody>
-      </p:sp>
-      <p:sp>
-        <p:nvSpPr>
-          <p:cNvPr id="10" name="Rounded Rectangle 9"/>
-          <p:cNvSpPr/>
-          <p:nvPr/>
-        </p:nvSpPr>
-        <p:spPr>
-          <a:xfrm>
-            <a:off x="2377440" y="3200400"/>
-            <a:ext cx="4754880" cy="914400"/>
-          </a:xfrm>
-          <a:prstGeom prst="roundRect">
-            <a:avLst/>
-          </a:prstGeom>
-          <a:solidFill>
-            <a:srgbClr val="7C3AED"/>
-          </a:solidFill>
-          <a:ln>
-            <a:noFill/>
-          </a:ln>
-        </p:spPr>
-        <p:style>
-          <a:lnRef idx="1">
-            <a:schemeClr val="accent1"/>
-          </a:lnRef>
-          <a:fillRef idx="3">
-            <a:schemeClr val="accent1"/>
-          </a:fillRef>
-          <a:effectRef idx="2">
-            <a:schemeClr val="accent1"/>
-          </a:effectRef>
-          <a:fontRef idx="minor">
-            <a:schemeClr val="lt1"/>
-          </a:fontRef>
-        </p:style>
-        <p:txBody>
-          <a:bodyPr rtlCol="0" anchor="ctr" wrap="square" lIns="73152" rIns="73152" tIns="36576" bIns="36576"/>
-          <a:lstStyle/>
-          <a:p>
-            <a:pPr algn="ctr"/>
-            <a:r>
-              <a:rPr sz="1300" b="1">
-                <a:solidFill>
-                  <a:srgbClr val="FFFFFF"/>
-                </a:solidFill>
-                <a:latin typeface="Calibri"/>
-              </a:rPr>
-              <a:t>Choose who to notify:  Owner · Managers · PI</a:t>
-            </a:r>
-          </a:p>
-        </p:txBody>
-      </p:sp>
-      <p:sp>
-        <p:nvSpPr>
-          <p:cNvPr id="11" name="Right Arrow 10"/>
-          <p:cNvSpPr/>
-          <p:nvPr/>
-        </p:nvSpPr>
-        <p:spPr>
-          <a:xfrm>
-            <a:off x="7223760" y="3520440"/>
-            <a:ext cx="457200" cy="411480"/>
-          </a:xfrm>
-          <a:prstGeom prst="rightArrow">
-            <a:avLst/>
-          </a:prstGeom>
-          <a:solidFill>
-            <a:srgbClr val="64748B"/>
-          </a:solidFill>
-          <a:ln>
-            <a:noFill/>
-          </a:ln>
-        </p:spPr>
-        <p:style>
-          <a:lnRef idx="1">
-            <a:schemeClr val="accent1"/>
-          </a:lnRef>
-          <a:fillRef idx="3">
-            <a:schemeClr val="accent1"/>
-          </a:fillRef>
-          <a:effectRef idx="2">
-            <a:schemeClr val="accent1"/>
-          </a:effectRef>
-          <a:fontRef idx="minor">
-            <a:schemeClr val="lt1"/>
-          </a:fontRef>
-        </p:style>
-        <p:txBody>
-          <a:bodyPr rtlCol="0" anchor="ctr"/>
-          <a:lstStyle/>
-          <a:p>
-            <a:pPr algn="ctr"/>
-          </a:p>
-        </p:txBody>
-      </p:sp>
-      <p:sp>
-        <p:nvSpPr>
-          <p:cNvPr id="12" name="Rounded Rectangle 11"/>
-          <p:cNvSpPr/>
-          <p:nvPr/>
-        </p:nvSpPr>
-        <p:spPr>
-          <a:xfrm>
-            <a:off x="7772400" y="3017520"/>
-            <a:ext cx="4023360" cy="1325880"/>
+            <a:off x="8138160" y="5029200"/>
+            <a:ext cx="3840480" cy="822960"/>
           </a:xfrm>
           <a:prstGeom prst="roundRect">
             <a:avLst/>
@@ -5630,6 +5005,7 @@
           <a:ln>
             <a:noFill/>
           </a:ln>
+          <a:effectLst/>
         </p:spPr>
         <p:style>
           <a:lnRef idx="1">
@@ -5646,54 +5022,273 @@
           </a:fontRef>
         </p:style>
         <p:txBody>
-          <a:bodyPr rtlCol="0" anchor="ctr" wrap="square" lIns="73152" rIns="73152" tIns="36576" bIns="36576"/>
+          <a:bodyPr rtlCol="0" anchor="ctr" wrap="square" lIns="45720" rIns="45720"/>
           <a:lstStyle/>
           <a:p>
             <a:pPr algn="ctr"/>
             <a:r>
-              <a:rPr sz="1200" b="1">
+              <a:rPr sz="1100" b="1">
                 <a:solidFill>
                   <a:srgbClr val="FFFFFF"/>
                 </a:solidFill>
                 <a:latin typeface="Calibri"/>
               </a:rPr>
-              <a:t>notify-request  (Supabase Edge Function)</a:t>
+              <a:t>Edge Function → Resend → emails</a:t>
             </a:r>
           </a:p>
           <a:p>
             <a:pPr algn="ctr"/>
             <a:r>
-              <a:rPr sz="1000" b="0">
+              <a:rPr sz="900">
                 <a:solidFill>
                   <a:srgbClr val="FFFFFF"/>
                 </a:solidFill>
                 <a:latin typeface="Calibri"/>
               </a:rPr>
-              <a:t>resolves emails server-side → Resend → sends</a:t>
-            </a:r>
-          </a:p>
-        </p:txBody>
-      </p:sp>
-      <p:sp>
-        <p:nvSpPr>
-          <p:cNvPr id="13" name="Rounded Rectangle 12"/>
+              <a:t>fallback: pre-filled draft email</a:t>
+            </a:r>
+          </a:p>
+        </p:txBody>
+      </p:sp>
+      <p:cxnSp>
+        <p:nvCxnSpPr>
+          <p:cNvPr id="41" name="Connector 40"/>
+          <p:cNvCxnSpPr/>
+          <p:nvPr/>
+        </p:nvCxnSpPr>
+        <p:spPr>
+          <a:xfrm>
+            <a:off x="1028700" y="2487168"/>
+            <a:ext cx="342900" cy="1993392"/>
+          </a:xfrm>
+          <a:prstGeom prst="line">
+            <a:avLst/>
+          </a:prstGeom>
+          <a:ln w="22225">
+            <a:solidFill>
+              <a:srgbClr val="94A3B8"/>
+            </a:solidFill>
+            <a:prstDash val="dash"/>
+            <a:tailEnd type="triangle" w="med" len="med"/>
+          </a:ln>
+        </p:spPr>
+        <p:style>
+          <a:lnRef idx="2">
+            <a:schemeClr val="accent1"/>
+          </a:lnRef>
+          <a:fillRef idx="0">
+            <a:schemeClr val="accent1"/>
+          </a:fillRef>
+          <a:effectRef idx="1">
+            <a:schemeClr val="accent1"/>
+          </a:effectRef>
+          <a:fontRef idx="minor">
+            <a:schemeClr val="tx1"/>
+          </a:fontRef>
+        </p:style>
+      </p:cxnSp>
+      <p:cxnSp>
+        <p:nvCxnSpPr>
+          <p:cNvPr id="42" name="Connector 41"/>
+          <p:cNvCxnSpPr/>
+          <p:nvPr/>
+        </p:nvCxnSpPr>
+        <p:spPr>
+          <a:xfrm>
+            <a:off x="2468880" y="4937760"/>
+            <a:ext cx="274320" cy="0"/>
+          </a:xfrm>
+          <a:prstGeom prst="line">
+            <a:avLst/>
+          </a:prstGeom>
+          <a:ln w="22225">
+            <a:solidFill>
+              <a:srgbClr val="94A3B8"/>
+            </a:solidFill>
+            <a:tailEnd type="triangle" w="med" len="med"/>
+          </a:ln>
+        </p:spPr>
+        <p:style>
+          <a:lnRef idx="2">
+            <a:schemeClr val="accent1"/>
+          </a:lnRef>
+          <a:fillRef idx="0">
+            <a:schemeClr val="accent1"/>
+          </a:fillRef>
+          <a:effectRef idx="1">
+            <a:schemeClr val="accent1"/>
+          </a:effectRef>
+          <a:fontRef idx="minor">
+            <a:schemeClr val="tx1"/>
+          </a:fontRef>
+        </p:style>
+      </p:cxnSp>
+      <p:cxnSp>
+        <p:nvCxnSpPr>
+          <p:cNvPr id="43" name="Connector 42"/>
+          <p:cNvCxnSpPr/>
+          <p:nvPr/>
+        </p:nvCxnSpPr>
+        <p:spPr>
+          <a:xfrm>
+            <a:off x="5257800" y="4937760"/>
+            <a:ext cx="274320" cy="0"/>
+          </a:xfrm>
+          <a:prstGeom prst="line">
+            <a:avLst/>
+          </a:prstGeom>
+          <a:ln w="22225">
+            <a:solidFill>
+              <a:srgbClr val="94A3B8"/>
+            </a:solidFill>
+            <a:tailEnd type="triangle" w="med" len="med"/>
+          </a:ln>
+        </p:spPr>
+        <p:style>
+          <a:lnRef idx="2">
+            <a:schemeClr val="accent1"/>
+          </a:lnRef>
+          <a:fillRef idx="0">
+            <a:schemeClr val="accent1"/>
+          </a:fillRef>
+          <a:effectRef idx="1">
+            <a:schemeClr val="accent1"/>
+          </a:effectRef>
+          <a:fontRef idx="minor">
+            <a:schemeClr val="tx1"/>
+          </a:fontRef>
+        </p:style>
+      </p:cxnSp>
+      <p:cxnSp>
+        <p:nvCxnSpPr>
+          <p:cNvPr id="44" name="Connector 43"/>
+          <p:cNvCxnSpPr/>
+          <p:nvPr/>
+        </p:nvCxnSpPr>
+        <p:spPr>
+          <a:xfrm flipV="1">
+            <a:off x="7863840" y="4599431"/>
+            <a:ext cx="274320" cy="338329"/>
+          </a:xfrm>
+          <a:prstGeom prst="line">
+            <a:avLst/>
+          </a:prstGeom>
+          <a:ln w="22225">
+            <a:solidFill>
+              <a:srgbClr val="94A3B8"/>
+            </a:solidFill>
+            <a:tailEnd type="triangle" w="med" len="med"/>
+          </a:ln>
+        </p:spPr>
+        <p:style>
+          <a:lnRef idx="2">
+            <a:schemeClr val="accent1"/>
+          </a:lnRef>
+          <a:fillRef idx="0">
+            <a:schemeClr val="accent1"/>
+          </a:fillRef>
+          <a:effectRef idx="1">
+            <a:schemeClr val="accent1"/>
+          </a:effectRef>
+          <a:fontRef idx="minor">
+            <a:schemeClr val="tx1"/>
+          </a:fontRef>
+        </p:style>
+      </p:cxnSp>
+      <p:cxnSp>
+        <p:nvCxnSpPr>
+          <p:cNvPr id="45" name="Connector 44"/>
+          <p:cNvCxnSpPr/>
+          <p:nvPr/>
+        </p:nvCxnSpPr>
+        <p:spPr>
+          <a:xfrm>
+            <a:off x="10058400" y="4882896"/>
+            <a:ext cx="0" cy="146304"/>
+          </a:xfrm>
+          <a:prstGeom prst="line">
+            <a:avLst/>
+          </a:prstGeom>
+          <a:ln w="22225">
+            <a:solidFill>
+              <a:srgbClr val="94A3B8"/>
+            </a:solidFill>
+            <a:tailEnd type="triangle" w="med" len="med"/>
+          </a:ln>
+        </p:spPr>
+        <p:style>
+          <a:lnRef idx="2">
+            <a:schemeClr val="accent1"/>
+          </a:lnRef>
+          <a:fillRef idx="0">
+            <a:schemeClr val="accent1"/>
+          </a:fillRef>
+          <a:effectRef idx="1">
+            <a:schemeClr val="accent1"/>
+          </a:effectRef>
+          <a:fontRef idx="minor">
+            <a:schemeClr val="tx1"/>
+          </a:fontRef>
+        </p:style>
+      </p:cxnSp>
+      <p:sp>
+        <p:nvSpPr>
+          <p:cNvPr id="46" name="TextBox 45"/>
+          <p:cNvSpPr txBox="1"/>
+          <p:nvPr/>
+        </p:nvSpPr>
+        <p:spPr>
+          <a:xfrm>
+            <a:off x="5394960" y="5440680"/>
+            <a:ext cx="2651760" cy="274320"/>
+          </a:xfrm>
+          <a:prstGeom prst="rect">
+            <a:avLst/>
+          </a:prstGeom>
+          <a:noFill/>
+        </p:spPr>
+        <p:txBody>
+          <a:bodyPr wrap="square" anchor="t">
+            <a:spAutoFit/>
+          </a:bodyPr>
+          <a:lstStyle/>
+          <a:p>
+            <a:pPr algn="ctr"/>
+            <a:r>
+              <a:rPr sz="1000" b="0" i="1">
+                <a:solidFill>
+                  <a:srgbClr val="B45309"/>
+                </a:solidFill>
+                <a:latin typeface="Calibri"/>
+              </a:rPr>
+              <a:t>role decides who approves &amp; who gets emailed</a:t>
+            </a:r>
+          </a:p>
+        </p:txBody>
+      </p:sp>
+      <p:sp>
+        <p:nvSpPr>
+          <p:cNvPr id="47" name="Rounded Rectangle 46"/>
           <p:cNvSpPr/>
           <p:nvPr/>
         </p:nvSpPr>
         <p:spPr>
           <a:xfrm>
-            <a:off x="7772400" y="4480560"/>
-            <a:ext cx="4023360" cy="685800"/>
+            <a:off x="320040" y="6172200"/>
+            <a:ext cx="11567160" cy="502920"/>
           </a:xfrm>
           <a:prstGeom prst="roundRect">
             <a:avLst/>
           </a:prstGeom>
           <a:solidFill>
-            <a:srgbClr val="64748B"/>
+            <a:srgbClr val="EFF3FB"/>
           </a:solidFill>
-          <a:ln>
-            <a:noFill/>
+          <a:ln w="12700">
+            <a:solidFill>
+              <a:srgbClr val="2563EB"/>
+            </a:solidFill>
           </a:ln>
+          <a:effectLst/>
         </p:spPr>
         <p:style>
           <a:lnRef idx="1">
@@ -5710,326 +5305,18 @@
           </a:fontRef>
         </p:style>
         <p:txBody>
-          <a:bodyPr rtlCol="0" anchor="ctr" wrap="square" lIns="73152" rIns="73152" tIns="36576" bIns="36576"/>
+          <a:bodyPr rtlCol="0" anchor="ctr"/>
           <a:lstStyle/>
           <a:p>
             <a:pPr algn="ctr"/>
             <a:r>
-              <a:rPr sz="1100" b="0">
-                <a:solidFill>
-                  <a:srgbClr val="FFFFFF"/>
+              <a:rPr sz="1200" b="1">
+                <a:solidFill>
+                  <a:srgbClr val="1E3A8A"/>
                 </a:solidFill>
                 <a:latin typeface="Calibri"/>
               </a:rPr>
-              <a:t>If not deployed → opens a pre-filled draft email (fallback)</a:t>
-            </a:r>
-          </a:p>
-        </p:txBody>
-      </p:sp>
-      <p:sp>
-        <p:nvSpPr>
-          <p:cNvPr id="14" name="TextBox 13"/>
-          <p:cNvSpPr txBox="1"/>
-          <p:nvPr/>
-        </p:nvSpPr>
-        <p:spPr>
-          <a:xfrm>
-            <a:off x="457200" y="4617720"/>
-            <a:ext cx="7040880" cy="2011680"/>
-          </a:xfrm>
-          <a:prstGeom prst="rect">
-            <a:avLst/>
-          </a:prstGeom>
-          <a:noFill/>
-        </p:spPr>
-        <p:txBody>
-          <a:bodyPr wrap="square">
-            <a:spAutoFit/>
-          </a:bodyPr>
-          <a:lstStyle/>
-          <a:p>
-            <a:pPr>
-              <a:spcAft>
-                <a:spcPts val="600"/>
-              </a:spcAft>
-            </a:pPr>
-            <a:r>
-              <a:rPr sz="1400" b="0">
-                <a:solidFill>
-                  <a:srgbClr val="1A1D26"/>
-                </a:solidFill>
-                <a:latin typeface="Calibri"/>
-              </a:rPr>
-              <a:t>• Recipients &amp; message are built server-side from the stored request —</a:t>
-            </a:r>
-          </a:p>
-          <a:p>
-            <a:pPr lvl="1">
-              <a:spcAft>
-                <a:spcPts val="600"/>
-              </a:spcAft>
-            </a:pPr>
-            <a:r>
-              <a:rPr sz="1200" b="0">
-                <a:solidFill>
-                  <a:srgbClr val="1A1D26"/>
-                </a:solidFill>
-                <a:latin typeface="Calibri"/>
-              </a:rPr>
-              <a:t>– the app never sends a raw address list (can't be an open relay).</a:t>
-            </a:r>
-          </a:p>
-          <a:p>
-            <a:pPr>
-              <a:spcAft>
-                <a:spcPts val="600"/>
-              </a:spcAft>
-            </a:pPr>
-            <a:r>
-              <a:rPr sz="1400" b="0">
-                <a:solidFill>
-                  <a:srgbClr val="1A1D26"/>
-                </a:solidFill>
-                <a:latin typeface="Calibri"/>
-              </a:rPr>
-              <a:t>• Guards: request-must-be-recent (replay), optional API-key check.</a:t>
-            </a:r>
-          </a:p>
-          <a:p>
-            <a:pPr>
-              <a:spcAft>
-                <a:spcPts val="600"/>
-              </a:spcAft>
-            </a:pPr>
-            <a:r>
-              <a:rPr sz="1400" b="0">
-                <a:solidFill>
-                  <a:srgbClr val="1A1D26"/>
-                </a:solidFill>
-                <a:latin typeface="Calibri"/>
-              </a:rPr>
-              <a:t>• Works with zero setup via the draft popup; turn on auto-send with a Resend key.</a:t>
-            </a:r>
-          </a:p>
-        </p:txBody>
-      </p:sp>
-    </p:spTree>
-  </p:cSld>
-  <p:clrMapOvr>
-    <a:masterClrMapping/>
-  </p:clrMapOvr>
-</p:sld>
-</file>
-
-<file path=ppt/slides/slide6.xml><?xml version="1.0" encoding="utf-8"?>
-<p:sld xmlns:a="http://schemas.openxmlformats.org/drawingml/2006/main" xmlns:p="http://schemas.openxmlformats.org/presentationml/2006/main" xmlns:r="http://schemas.openxmlformats.org/officeDocument/2006/relationships">
-  <p:cSld>
-    <p:spTree>
-      <p:nvGrpSpPr>
-        <p:cNvPr id="1" name=""/>
-        <p:cNvGrpSpPr/>
-        <p:nvPr/>
-      </p:nvGrpSpPr>
-      <p:grpSpPr/>
-      <p:sp>
-        <p:nvSpPr>
-          <p:cNvPr id="2" name="Rectangle 1"/>
-          <p:cNvSpPr/>
-          <p:nvPr/>
-        </p:nvSpPr>
-        <p:spPr>
-          <a:xfrm>
-            <a:off x="0" y="0"/>
-            <a:ext cx="12191695" cy="960120"/>
-          </a:xfrm>
-          <a:prstGeom prst="rect">
-            <a:avLst/>
-          </a:prstGeom>
-          <a:solidFill>
-            <a:srgbClr val="1E3A8A"/>
-          </a:solidFill>
-          <a:ln>
-            <a:noFill/>
-          </a:ln>
-        </p:spPr>
-        <p:style>
-          <a:lnRef idx="1">
-            <a:schemeClr val="accent1"/>
-          </a:lnRef>
-          <a:fillRef idx="3">
-            <a:schemeClr val="accent1"/>
-          </a:fillRef>
-          <a:effectRef idx="2">
-            <a:schemeClr val="accent1"/>
-          </a:effectRef>
-          <a:fontRef idx="minor">
-            <a:schemeClr val="lt1"/>
-          </a:fontRef>
-        </p:style>
-        <p:txBody>
-          <a:bodyPr rtlCol="0" anchor="ctr" lIns="457200"/>
-          <a:lstStyle/>
-          <a:p>
-            <a:pPr algn="ctr"/>
-            <a:r>
-              <a:rPr sz="2600" b="1">
-                <a:solidFill>
-                  <a:srgbClr val="FFFFFF"/>
-                </a:solidFill>
-                <a:latin typeface="Calibri"/>
-              </a:rPr>
-              <a:t>In one line each</a:t>
-            </a:r>
-          </a:p>
-        </p:txBody>
-      </p:sp>
-      <p:sp>
-        <p:nvSpPr>
-          <p:cNvPr id="3" name="TextBox 2"/>
-          <p:cNvSpPr txBox="1"/>
-          <p:nvPr/>
-        </p:nvSpPr>
-        <p:spPr>
-          <a:xfrm>
-            <a:off x="640080" y="1554480"/>
-            <a:ext cx="10972800" cy="4754880"/>
-          </a:xfrm>
-          <a:prstGeom prst="rect">
-            <a:avLst/>
-          </a:prstGeom>
-          <a:noFill/>
-        </p:spPr>
-        <p:txBody>
-          <a:bodyPr wrap="square">
-            <a:spAutoFit/>
-          </a:bodyPr>
-          <a:lstStyle/>
-          <a:p>
-            <a:pPr>
-              <a:spcAft>
-                <a:spcPts val="1000"/>
-              </a:spcAft>
-            </a:pPr>
-            <a:r>
-              <a:rPr sz="1700" b="0">
-                <a:solidFill>
-                  <a:srgbClr val="1A1D26"/>
-                </a:solidFill>
-                <a:latin typeface="Calibri"/>
-              </a:rPr>
-              <a:t>• Hosting:  one HTML file on GitHub Pages — free, nothing to run.</a:t>
-            </a:r>
-          </a:p>
-          <a:p>
-            <a:pPr>
-              <a:spcAft>
-                <a:spcPts val="1000"/>
-              </a:spcAft>
-            </a:pPr>
-            <a:r>
-              <a:rPr sz="1700" b="0">
-                <a:solidFill>
-                  <a:srgbClr val="1A1D26"/>
-                </a:solidFill>
-                <a:latin typeface="Calibri"/>
-              </a:rPr>
-              <a:t>• Data:  Supabase Postgres, reached directly via its auto REST API + Row-Level Security.</a:t>
-            </a:r>
-          </a:p>
-          <a:p>
-            <a:pPr>
-              <a:spcAft>
-                <a:spcPts val="1000"/>
-              </a:spcAft>
-            </a:pPr>
-            <a:r>
-              <a:rPr sz="1700" b="0">
-                <a:solidFill>
-                  <a:srgbClr val="1A1D26"/>
-                </a:solidFill>
-                <a:latin typeface="Calibri"/>
-              </a:rPr>
-              <a:t>• Entry:  add cohorts by cage, or import CSV/Excel with a mapping + preview step.</a:t>
-            </a:r>
-          </a:p>
-          <a:p>
-            <a:pPr>
-              <a:spcAft>
-                <a:spcPts val="1000"/>
-              </a:spcAft>
-            </a:pPr>
-            <a:r>
-              <a:rPr sz="1700" b="0">
-                <a:solidFill>
-                  <a:srgbClr val="1A1D26"/>
-                </a:solidFill>
-                <a:latin typeface="Calibri"/>
-              </a:rPr>
-              <a:t>• Find:  search / filter / sort, Individual or Grouped views, and a personal 'My colony'.</a:t>
-            </a:r>
-          </a:p>
-          <a:p>
-            <a:pPr>
-              <a:spcAft>
-                <a:spcPts val="1000"/>
-              </a:spcAft>
-            </a:pPr>
-            <a:r>
-              <a:rPr sz="1700" b="0">
-                <a:solidFill>
-                  <a:srgbClr val="1A1D26"/>
-                </a:solidFill>
-                <a:latin typeface="Calibri"/>
-              </a:rPr>
-              <a:t>• Edit:  per-mouse, in bulk, or whole-cohort (add / remove / renumber) — all audit-logged.</a:t>
-            </a:r>
-          </a:p>
-          <a:p>
-            <a:pPr>
-              <a:spcAft>
-                <a:spcPts val="1000"/>
-              </a:spcAft>
-            </a:pPr>
-            <a:r>
-              <a:rPr sz="1700" b="0">
-                <a:solidFill>
-                  <a:srgbClr val="1A1D26"/>
-                </a:solidFill>
-                <a:latin typeface="Calibri"/>
-              </a:rPr>
-              <a:t>• Users:  name + shared password, per-user email captured once, every action attributed.</a:t>
-            </a:r>
-          </a:p>
-          <a:p>
-            <a:pPr>
-              <a:spcAft>
-                <a:spcPts val="1000"/>
-              </a:spcAft>
-            </a:pPr>
-            <a:r>
-              <a:rPr sz="1700" b="0">
-                <a:solidFill>
-                  <a:srgbClr val="1A1D26"/>
-                </a:solidFill>
-                <a:latin typeface="Calibri"/>
-              </a:rPr>
-              <a:t>• Notify:  requests email Owner / Managers / PI via an Edge Function + Resend (draft fallback).</a:t>
-            </a:r>
-          </a:p>
-          <a:p>
-            <a:pPr>
-              <a:spcAft>
-                <a:spcPts val="1000"/>
-              </a:spcAft>
-            </a:pPr>
-            <a:r>
-              <a:rPr sz="1700" b="0">
-                <a:solidFill>
-                  <a:srgbClr val="1A1D26"/>
-                </a:solidFill>
-                <a:latin typeface="Calibri"/>
-              </a:rPr>
-              <a:t>• Safety:  daily off-site backups; keep-alive so the free database never sleeps.</a:t>
+              <a:t>Same data, different views: everyone browses &amp; adds · 'My colony' is scoped to you · only Managers/PI approve &amp; route to breeding · every change is logged in audit_log</a:t>
             </a:r>
           </a:p>
         </p:txBody>

</xml_diff>

<commit_message>
docs: add speaker notes (roles, per-view scoping, how Supabase works)
Attach speaker notes to the workflow deck: a title-slide intro, and detailed
notes on slide 2 covering how Supabase works (hosted Postgres + auto REST API +
RLS + Edge Functions + backups), the PI/Manager/Member roles, and how the app
gives different users different views via ownership + role (with the honest
soft-security caveat and the per-user-auth upgrade path).

Co-Authored-By: Claude Opus 4.8 (1M context) <noreply@anthropic.com>
</commit_message>
<xml_diff>
--- a/docs/Colony_DB_Overview.pptx
+++ b/docs/Colony_DB_Overview.pptx
@@ -6,7 +6,7 @@
   </p:sldMasterIdLst>
   <p:sldIdLst>
     <p:sldId id="256" r:id="rId7"/>
-    <p:sldId id="257" r:id="rId8"/>
+    <p:sldId id="257" r:id="rId9"/>
   </p:sldIdLst>
   <p:sldSz cx="12191695" cy="6858000" type="screen4x3"/>
   <p:notesSz cx="6858000" cy="9144000"/>
@@ -106,6 +106,595 @@
     </a:lvl9pPr>
   </p:defaultTextStyle>
 </p:presentation>
+</file>
+
+<file path=ppt/notesMasters/notesMaster1.xml><?xml version="1.0" encoding="utf-8"?>
+<p:notesMaster xmlns:a="http://schemas.openxmlformats.org/drawingml/2006/main" xmlns:p="http://schemas.openxmlformats.org/presentationml/2006/main" xmlns:r="http://schemas.openxmlformats.org/officeDocument/2006/relationships">
+  <p:cSld>
+    <p:bg>
+      <p:bgRef idx="1001">
+        <a:schemeClr val="bg1"/>
+      </p:bgRef>
+    </p:bg>
+    <p:spTree>
+      <p:nvGrpSpPr>
+        <p:cNvPr id="1" name=""/>
+        <p:cNvGrpSpPr/>
+        <p:nvPr/>
+      </p:nvGrpSpPr>
+      <p:grpSpPr>
+        <a:xfrm>
+          <a:off x="0" y="0"/>
+          <a:ext cx="0" cy="0"/>
+          <a:chOff x="0" y="0"/>
+          <a:chExt cx="0" cy="0"/>
+        </a:xfrm>
+      </p:grpSpPr>
+      <p:sp>
+        <p:nvSpPr>
+          <p:cNvPr id="2" name="Header Placeholder 1"/>
+          <p:cNvSpPr>
+            <a:spLocks noGrp="1"/>
+          </p:cNvSpPr>
+          <p:nvPr>
+            <p:ph type="hdr" sz="quarter"/>
+          </p:nvPr>
+        </p:nvSpPr>
+        <p:spPr>
+          <a:xfrm>
+            <a:off x="0" y="0"/>
+            <a:ext cx="2971800" cy="457200"/>
+          </a:xfrm>
+          <a:prstGeom prst="rect">
+            <a:avLst/>
+          </a:prstGeom>
+        </p:spPr>
+        <p:txBody>
+          <a:bodyPr vert="horz" lIns="91440" tIns="45720" rIns="91440" bIns="45720" rtlCol="0"/>
+          <a:lstStyle>
+            <a:lvl1pPr algn="l">
+              <a:defRPr sz="1200"/>
+            </a:lvl1pPr>
+          </a:lstStyle>
+          <a:p>
+            <a:endParaRPr lang="en-US"/>
+          </a:p>
+        </p:txBody>
+      </p:sp>
+      <p:sp>
+        <p:nvSpPr>
+          <p:cNvPr id="3" name="Date Placeholder 2"/>
+          <p:cNvSpPr>
+            <a:spLocks noGrp="1"/>
+          </p:cNvSpPr>
+          <p:nvPr>
+            <p:ph type="dt" idx="1"/>
+          </p:nvPr>
+        </p:nvSpPr>
+        <p:spPr>
+          <a:xfrm>
+            <a:off x="3884613" y="0"/>
+            <a:ext cx="2971800" cy="457200"/>
+          </a:xfrm>
+          <a:prstGeom prst="rect">
+            <a:avLst/>
+          </a:prstGeom>
+        </p:spPr>
+        <p:txBody>
+          <a:bodyPr vert="horz" lIns="91440" tIns="45720" rIns="91440" bIns="45720" rtlCol="0"/>
+          <a:lstStyle>
+            <a:lvl1pPr algn="r">
+              <a:defRPr sz="1200"/>
+            </a:lvl1pPr>
+          </a:lstStyle>
+          <a:p>
+            <a:fld id="{0F89C1C7-3DCD-1040-A9CF-14679D8B5DDD}" type="datetimeFigureOut">
+              <a:rPr lang="en-US" smtClean="0"/>
+              <a:t>10/17/16</a:t>
+            </a:fld>
+            <a:endParaRPr lang="en-US"/>
+          </a:p>
+        </p:txBody>
+      </p:sp>
+      <p:sp>
+        <p:nvSpPr>
+          <p:cNvPr id="4" name="Slide Image Placeholder 3"/>
+          <p:cNvSpPr>
+            <a:spLocks noGrp="1" noRot="1" noChangeAspect="1"/>
+          </p:cNvSpPr>
+          <p:nvPr>
+            <p:ph type="sldImg" idx="2"/>
+          </p:nvPr>
+        </p:nvSpPr>
+        <p:spPr>
+          <a:xfrm>
+            <a:off x="1143000" y="685800"/>
+            <a:ext cx="4572000" cy="3429000"/>
+          </a:xfrm>
+          <a:prstGeom prst="rect">
+            <a:avLst/>
+          </a:prstGeom>
+          <a:noFill/>
+          <a:ln w="12700">
+            <a:solidFill>
+              <a:prstClr val="black"/>
+            </a:solidFill>
+          </a:ln>
+        </p:spPr>
+        <p:txBody>
+          <a:bodyPr vert="horz" lIns="91440" tIns="45720" rIns="91440" bIns="45720" rtlCol="0" anchor="ctr"/>
+          <a:lstStyle/>
+          <a:p>
+            <a:endParaRPr lang="en-US"/>
+          </a:p>
+        </p:txBody>
+      </p:sp>
+      <p:sp>
+        <p:nvSpPr>
+          <p:cNvPr id="5" name="Notes Placeholder 4"/>
+          <p:cNvSpPr>
+            <a:spLocks noGrp="1"/>
+          </p:cNvSpPr>
+          <p:nvPr>
+            <p:ph type="body" sz="quarter" idx="3"/>
+          </p:nvPr>
+        </p:nvSpPr>
+        <p:spPr>
+          <a:xfrm>
+            <a:off x="685800" y="4343400"/>
+            <a:ext cx="5486400" cy="4114800"/>
+          </a:xfrm>
+          <a:prstGeom prst="rect">
+            <a:avLst/>
+          </a:prstGeom>
+        </p:spPr>
+        <p:txBody>
+          <a:bodyPr vert="horz" lIns="91440" tIns="45720" rIns="91440" bIns="45720" rtlCol="0"/>
+          <a:lstStyle/>
+          <a:p>
+            <a:pPr lvl="0"/>
+            <a:r>
+              <a:rPr lang="en-US" smtClean="0"/>
+              <a:t>Click to edit Master text styles</a:t>
+            </a:r>
+          </a:p>
+          <a:p>
+            <a:pPr lvl="1"/>
+            <a:r>
+              <a:rPr lang="en-US" smtClean="0"/>
+              <a:t>Second level</a:t>
+            </a:r>
+          </a:p>
+          <a:p>
+            <a:pPr lvl="2"/>
+            <a:r>
+              <a:rPr lang="en-US" smtClean="0"/>
+              <a:t>Third level</a:t>
+            </a:r>
+          </a:p>
+          <a:p>
+            <a:pPr lvl="3"/>
+            <a:r>
+              <a:rPr lang="en-US" smtClean="0"/>
+              <a:t>Fourth level</a:t>
+            </a:r>
+          </a:p>
+          <a:p>
+            <a:pPr lvl="4"/>
+            <a:r>
+              <a:rPr lang="en-US" smtClean="0"/>
+              <a:t>Fifth level</a:t>
+            </a:r>
+            <a:endParaRPr lang="en-US"/>
+          </a:p>
+        </p:txBody>
+      </p:sp>
+      <p:sp>
+        <p:nvSpPr>
+          <p:cNvPr id="6" name="Footer Placeholder 5"/>
+          <p:cNvSpPr>
+            <a:spLocks noGrp="1"/>
+          </p:cNvSpPr>
+          <p:nvPr>
+            <p:ph type="ftr" sz="quarter" idx="4"/>
+          </p:nvPr>
+        </p:nvSpPr>
+        <p:spPr>
+          <a:xfrm>
+            <a:off x="0" y="8685213"/>
+            <a:ext cx="2971800" cy="457200"/>
+          </a:xfrm>
+          <a:prstGeom prst="rect">
+            <a:avLst/>
+          </a:prstGeom>
+        </p:spPr>
+        <p:txBody>
+          <a:bodyPr vert="horz" lIns="91440" tIns="45720" rIns="91440" bIns="45720" rtlCol="0" anchor="b"/>
+          <a:lstStyle>
+            <a:lvl1pPr algn="l">
+              <a:defRPr sz="1200"/>
+            </a:lvl1pPr>
+          </a:lstStyle>
+          <a:p>
+            <a:endParaRPr lang="en-US"/>
+          </a:p>
+        </p:txBody>
+      </p:sp>
+      <p:sp>
+        <p:nvSpPr>
+          <p:cNvPr id="7" name="Slide Number Placeholder 6"/>
+          <p:cNvSpPr>
+            <a:spLocks noGrp="1"/>
+          </p:cNvSpPr>
+          <p:nvPr>
+            <p:ph type="sldNum" sz="quarter" idx="5"/>
+          </p:nvPr>
+        </p:nvSpPr>
+        <p:spPr>
+          <a:xfrm>
+            <a:off x="3884613" y="8685213"/>
+            <a:ext cx="2971800" cy="457200"/>
+          </a:xfrm>
+          <a:prstGeom prst="rect">
+            <a:avLst/>
+          </a:prstGeom>
+        </p:spPr>
+        <p:txBody>
+          <a:bodyPr vert="horz" lIns="91440" tIns="45720" rIns="91440" bIns="45720" rtlCol="0" anchor="b"/>
+          <a:lstStyle>
+            <a:lvl1pPr algn="r">
+              <a:defRPr sz="1200"/>
+            </a:lvl1pPr>
+          </a:lstStyle>
+          <a:p>
+            <a:fld id="{BB5E49A5-4136-284D-997B-48E1D791AD67}" type="slidenum">
+              <a:rPr lang="en-US" smtClean="0"/>
+              <a:t>‹#›</a:t>
+            </a:fld>
+            <a:endParaRPr lang="en-US"/>
+          </a:p>
+        </p:txBody>
+      </p:sp>
+    </p:spTree>
+    <p:extLst>
+      <p:ext uri="{BB962C8B-B14F-4D97-AF65-F5344CB8AC3E}">
+        <p14:creationId xmlns:p14="http://schemas.microsoft.com/office/powerpoint/2010/main" val="2623252185"/>
+      </p:ext>
+    </p:extLst>
+  </p:cSld>
+  <p:clrMap bg1="lt1" tx1="dk1" bg2="lt2" tx2="dk2" accent1="accent1" accent2="accent2" accent3="accent3" accent4="accent4" accent5="accent5" accent6="accent6" hlink="hlink" folHlink="folHlink"/>
+  <p:notesStyle>
+    <a:lvl1pPr marL="0" algn="l" defTabSz="457200" rtl="0" eaLnBrk="1" latinLnBrk="0" hangingPunct="1">
+      <a:defRPr sz="1200" kern="1200">
+        <a:solidFill>
+          <a:schemeClr val="tx1"/>
+        </a:solidFill>
+        <a:latin typeface="+mn-lt"/>
+        <a:ea typeface="+mn-ea"/>
+        <a:cs typeface="+mn-cs"/>
+      </a:defRPr>
+    </a:lvl1pPr>
+    <a:lvl2pPr marL="457200" algn="l" defTabSz="457200" rtl="0" eaLnBrk="1" latinLnBrk="0" hangingPunct="1">
+      <a:defRPr sz="1200" kern="1200">
+        <a:solidFill>
+          <a:schemeClr val="tx1"/>
+        </a:solidFill>
+        <a:latin typeface="+mn-lt"/>
+        <a:ea typeface="+mn-ea"/>
+        <a:cs typeface="+mn-cs"/>
+      </a:defRPr>
+    </a:lvl2pPr>
+    <a:lvl3pPr marL="914400" algn="l" defTabSz="457200" rtl="0" eaLnBrk="1" latinLnBrk="0" hangingPunct="1">
+      <a:defRPr sz="1200" kern="1200">
+        <a:solidFill>
+          <a:schemeClr val="tx1"/>
+        </a:solidFill>
+        <a:latin typeface="+mn-lt"/>
+        <a:ea typeface="+mn-ea"/>
+        <a:cs typeface="+mn-cs"/>
+      </a:defRPr>
+    </a:lvl3pPr>
+    <a:lvl4pPr marL="1371600" algn="l" defTabSz="457200" rtl="0" eaLnBrk="1" latinLnBrk="0" hangingPunct="1">
+      <a:defRPr sz="1200" kern="1200">
+        <a:solidFill>
+          <a:schemeClr val="tx1"/>
+        </a:solidFill>
+        <a:latin typeface="+mn-lt"/>
+        <a:ea typeface="+mn-ea"/>
+        <a:cs typeface="+mn-cs"/>
+      </a:defRPr>
+    </a:lvl4pPr>
+    <a:lvl5pPr marL="1828800" algn="l" defTabSz="457200" rtl="0" eaLnBrk="1" latinLnBrk="0" hangingPunct="1">
+      <a:defRPr sz="1200" kern="1200">
+        <a:solidFill>
+          <a:schemeClr val="tx1"/>
+        </a:solidFill>
+        <a:latin typeface="+mn-lt"/>
+        <a:ea typeface="+mn-ea"/>
+        <a:cs typeface="+mn-cs"/>
+      </a:defRPr>
+    </a:lvl5pPr>
+    <a:lvl6pPr marL="2286000" algn="l" defTabSz="457200" rtl="0" eaLnBrk="1" latinLnBrk="0" hangingPunct="1">
+      <a:defRPr sz="1200" kern="1200">
+        <a:solidFill>
+          <a:schemeClr val="tx1"/>
+        </a:solidFill>
+        <a:latin typeface="+mn-lt"/>
+        <a:ea typeface="+mn-ea"/>
+        <a:cs typeface="+mn-cs"/>
+      </a:defRPr>
+    </a:lvl6pPr>
+    <a:lvl7pPr marL="2743200" algn="l" defTabSz="457200" rtl="0" eaLnBrk="1" latinLnBrk="0" hangingPunct="1">
+      <a:defRPr sz="1200" kern="1200">
+        <a:solidFill>
+          <a:schemeClr val="tx1"/>
+        </a:solidFill>
+        <a:latin typeface="+mn-lt"/>
+        <a:ea typeface="+mn-ea"/>
+        <a:cs typeface="+mn-cs"/>
+      </a:defRPr>
+    </a:lvl7pPr>
+    <a:lvl8pPr marL="3200400" algn="l" defTabSz="457200" rtl="0" eaLnBrk="1" latinLnBrk="0" hangingPunct="1">
+      <a:defRPr sz="1200" kern="1200">
+        <a:solidFill>
+          <a:schemeClr val="tx1"/>
+        </a:solidFill>
+        <a:latin typeface="+mn-lt"/>
+        <a:ea typeface="+mn-ea"/>
+        <a:cs typeface="+mn-cs"/>
+      </a:defRPr>
+    </a:lvl8pPr>
+    <a:lvl9pPr marL="3657600" algn="l" defTabSz="457200" rtl="0" eaLnBrk="1" latinLnBrk="0" hangingPunct="1">
+      <a:defRPr sz="1200" kern="1200">
+        <a:solidFill>
+          <a:schemeClr val="tx1"/>
+        </a:solidFill>
+        <a:latin typeface="+mn-lt"/>
+        <a:ea typeface="+mn-ea"/>
+        <a:cs typeface="+mn-cs"/>
+      </a:defRPr>
+    </a:lvl9pPr>
+  </p:notesStyle>
+</p:notesMaster>
+</file>
+
+<file path=ppt/notesSlides/notesSlide1.xml><?xml version="1.0" encoding="utf-8"?>
+<p:notes xmlns:a="http://schemas.openxmlformats.org/drawingml/2006/main" xmlns:p="http://schemas.openxmlformats.org/presentationml/2006/main" xmlns:r="http://schemas.openxmlformats.org/officeDocument/2006/relationships">
+  <p:cSld>
+    <p:spTree>
+      <p:nvGrpSpPr>
+        <p:cNvPr id="1" name=""/>
+        <p:cNvGrpSpPr/>
+        <p:nvPr/>
+      </p:nvGrpSpPr>
+      <p:grpSpPr>
+        <a:xfrm>
+          <a:off x="0" y="0"/>
+          <a:ext cx="0" cy="0"/>
+          <a:chOff x="0" y="0"/>
+          <a:chExt cx="0" cy="0"/>
+        </a:xfrm>
+      </p:grpSpPr>
+      <p:sp>
+        <p:nvSpPr>
+          <p:cNvPr id="2" name="Slide Image Placeholder 1"/>
+          <p:cNvSpPr>
+            <a:spLocks noGrp="1"/>
+          </p:cNvSpPr>
+          <p:nvPr>
+            <p:ph type="sldImg" idx="2"/>
+          </p:nvPr>
+        </p:nvSpPr>
+        <p:spPr/>
+      </p:sp>
+      <p:sp>
+        <p:nvSpPr>
+          <p:cNvPr id="3" name="Notes Placeholder 2"/>
+          <p:cNvSpPr>
+            <a:spLocks noGrp="1"/>
+          </p:cNvSpPr>
+          <p:nvPr>
+            <p:ph type="body" idx="3" sz="quarter"/>
+          </p:nvPr>
+        </p:nvSpPr>
+        <p:spPr/>
+        <p:txBody>
+          <a:bodyPr/>
+          <a:lstStyle/>
+          <a:p>
+            <a:r>
+              <a:t>Our lab's mouse colony database: a single web page backed by a hosted database (Supabase). This one diagram shows how it works end to end, how several people use it at once, and why different people see different things.</a:t>
+            </a:r>
+          </a:p>
+          <a:p/>
+          <a:p>
+            <a:r>
+              <a:t>Live at leomeow123.github.io/leelab-colony (moving to colony.kuofenleelab.com). No server to maintain and it runs on free tiers.</a:t>
+            </a:r>
+          </a:p>
+        </p:txBody>
+      </p:sp>
+      <p:sp>
+        <p:nvSpPr>
+          <p:cNvPr id="4" name="Slide Number Placeholder 3"/>
+          <p:cNvSpPr>
+            <a:spLocks noGrp="1"/>
+          </p:cNvSpPr>
+          <p:nvPr>
+            <p:ph type="sldNum" idx="5" sz="quarter"/>
+          </p:nvPr>
+        </p:nvSpPr>
+        <p:spPr/>
+      </p:sp>
+    </p:spTree>
+  </p:cSld>
+  <p:clrMapOvr>
+    <a:masterClrMapping/>
+  </p:clrMapOvr>
+</p:notes>
+</file>
+
+<file path=ppt/notesSlides/notesSlide2.xml><?xml version="1.0" encoding="utf-8"?>
+<p:notes xmlns:a="http://schemas.openxmlformats.org/drawingml/2006/main" xmlns:p="http://schemas.openxmlformats.org/presentationml/2006/main" xmlns:r="http://schemas.openxmlformats.org/officeDocument/2006/relationships">
+  <p:cSld>
+    <p:spTree>
+      <p:nvGrpSpPr>
+        <p:cNvPr id="1" name=""/>
+        <p:cNvGrpSpPr/>
+        <p:nvPr/>
+      </p:nvGrpSpPr>
+      <p:grpSpPr>
+        <a:xfrm>
+          <a:off x="0" y="0"/>
+          <a:ext cx="0" cy="0"/>
+          <a:chOff x="0" y="0"/>
+          <a:chExt cx="0" cy="0"/>
+        </a:xfrm>
+      </p:grpSpPr>
+      <p:sp>
+        <p:nvSpPr>
+          <p:cNvPr id="2" name="Slide Image Placeholder 1"/>
+          <p:cNvSpPr>
+            <a:spLocks noGrp="1"/>
+          </p:cNvSpPr>
+          <p:nvPr>
+            <p:ph type="sldImg" idx="2"/>
+          </p:nvPr>
+        </p:nvSpPr>
+        <p:spPr/>
+      </p:sp>
+      <p:sp>
+        <p:nvSpPr>
+          <p:cNvPr id="3" name="Notes Placeholder 2"/>
+          <p:cNvSpPr>
+            <a:spLocks noGrp="1"/>
+          </p:cNvSpPr>
+          <p:nvPr>
+            <p:ph type="body" idx="3" sz="quarter"/>
+          </p:nvPr>
+        </p:nvSpPr>
+        <p:spPr/>
+        <p:txBody>
+          <a:bodyPr/>
+          <a:lstStyle/>
+          <a:p>
+            <a:r>
+              <a:t>WALKTHROUGH (top row left→right, then the bottom lane)</a:t>
+            </a:r>
+          </a:p>
+          <a:p>
+            <a:r>
+              <a:t>Everyone signs in the same way — pick your name + one shared lab password — so there is no account admin. On first login you save your email once (used only for notifications). Your name is then attached to everything you do.</a:t>
+            </a:r>
+          </a:p>
+          <a:p/>
+          <a:p>
+            <a:r>
+              <a:t>HOW SUPABASE WORKS</a:t>
+            </a:r>
+          </a:p>
+          <a:p>
+            <a:r>
+              <a:t>- Supabase is a hosted PostgreSQL database that also auto-generates a web (REST) API in front of every table, plus Row-Level Security and small server-side functions.</a:t>
+            </a:r>
+          </a:p>
+          <a:p>
+            <a:r>
+              <a:t>- The web page is just one static HTML file (on GitHub Pages). It has no backend of its own — it calls Supabase's REST API directly, sending a public 'publishable' key with each request.</a:t>
+            </a:r>
+          </a:p>
+          <a:p>
+            <a:r>
+              <a:t>- Data lives in a few tables: mice (the hub), app_users (people + role + email), requests, audit_log, app_config. A database view (mouse_v) computes each mouse's age and staleness from its date of birth on the fly.</a:t>
+            </a:r>
+          </a:p>
+          <a:p>
+            <a:r>
+              <a:t>- Anything that needs a secret (sending email) can't run in the browser, so it runs in a Supabase Edge Function server-side, which holds the mail key.</a:t>
+            </a:r>
+          </a:p>
+          <a:p>
+            <a:r>
+              <a:t>- A GitHub Action dumps every table to a private repo once a day (restorable backups) and keeps the free database awake.</a:t>
+            </a:r>
+          </a:p>
+          <a:p/>
+          <a:p>
+            <a:r>
+              <a:t>THE ROLES (stored on each person, app_users.role)</a:t>
+            </a:r>
+          </a:p>
+          <a:p>
+            <a:r>
+              <a:t>- Member: files requests, adds/imports mice, manages their own colony.</a:t>
+            </a:r>
+          </a:p>
+          <a:p>
+            <a:r>
+              <a:t>- Manager: all of the above, plus approve/deny requests, transfer ownership, and route to breeding (breeding requests go to the manager, e.g. Bertha).</a:t>
+            </a:r>
+          </a:p>
+          <a:p>
+            <a:r>
+              <a:t>- PI: same authority as manager, for oversight.</a:t>
+            </a:r>
+          </a:p>
+          <a:p/>
+          <a:p>
+            <a:r>
+              <a:t>HOW DIFFERENT USERS SEE DIFFERENT THINGS</a:t>
+            </a:r>
+          </a:p>
+          <a:p>
+            <a:r>
+              <a:t>- It is the same shared database, but the app shapes each person's view by OWNERSHIP and ROLE:</a:t>
+            </a:r>
+          </a:p>
+          <a:p>
+            <a:r>
+              <a:t>   • 'My colony' and the 'Mine' filter show only the mice you own (responsible_person = you).</a:t>
+            </a:r>
+          </a:p>
+          <a:p>
+            <a:r>
+              <a:t>   • A request auto-routes to the owner of the matching mouse; if none is available it goes to the breeding queue (manager).</a:t>
+            </a:r>
+          </a:p>
+          <a:p>
+            <a:r>
+              <a:t>   • Approve / transfer / route buttons only appear for a Manager or PI (or the request's assignee).</a:t>
+            </a:r>
+          </a:p>
+          <a:p>
+            <a:r>
+              <a:t>   • When notifying, you choose Owner / Managers / PI and only those people are emailed.</a:t>
+            </a:r>
+          </a:p>
+          <a:p>
+            <a:r>
+              <a:t>- Honest point for the lab: today this is a SOFT model — one shared password and one public key, so anyone signed in can technically view or edit anything. Roles and ownership decide what is shown and who can act, and every change is recorded in the audit log. If we later want hard per-person permissions, we switch to real logins (magic-link or Google) and enforce them in Supabase Row-Level Security — with no change to the data.</a:t>
+            </a:r>
+          </a:p>
+        </p:txBody>
+      </p:sp>
+      <p:sp>
+        <p:nvSpPr>
+          <p:cNvPr id="4" name="Slide Number Placeholder 3"/>
+          <p:cNvSpPr>
+            <a:spLocks noGrp="1"/>
+          </p:cNvSpPr>
+          <p:nvPr>
+            <p:ph type="sldNum" idx="5" sz="quarter"/>
+          </p:nvPr>
+        </p:nvSpPr>
+        <p:spPr/>
+      </p:sp>
+    </p:spTree>
+  </p:cSld>
+  <p:clrMapOvr>
+    <a:masterClrMapping/>
+  </p:clrMapOvr>
+</p:notes>
 </file>
 
 <file path=ppt/slideLayouts/slideLayout1.xml><?xml version="1.0" encoding="utf-8"?>
@@ -5647,4 +6236,324 @@
   </a:objectDefaults>
   <a:extraClrSchemeLst/>
 </a:theme>
+</file>
+
+<file path=ppt/theme/theme2.xml><?xml version="1.0" encoding="utf-8"?>
+<a:theme xmlns:a="http://schemas.openxmlformats.org/drawingml/2006/main" name="Office Theme">
+  <a:themeElements>
+    <a:clrScheme name="Office">
+      <a:dk1>
+        <a:sysClr val="windowText" lastClr="000000"/>
+      </a:dk1>
+      <a:lt1>
+        <a:sysClr val="window" lastClr="FFFFFF"/>
+      </a:lt1>
+      <a:dk2>
+        <a:srgbClr val="1F497D"/>
+      </a:dk2>
+      <a:lt2>
+        <a:srgbClr val="EEECE1"/>
+      </a:lt2>
+      <a:accent1>
+        <a:srgbClr val="4F81BD"/>
+      </a:accent1>
+      <a:accent2>
+        <a:srgbClr val="C0504D"/>
+      </a:accent2>
+      <a:accent3>
+        <a:srgbClr val="9BBB59"/>
+      </a:accent3>
+      <a:accent4>
+        <a:srgbClr val="8064A2"/>
+      </a:accent4>
+      <a:accent5>
+        <a:srgbClr val="4BACC6"/>
+      </a:accent5>
+      <a:accent6>
+        <a:srgbClr val="F79646"/>
+      </a:accent6>
+      <a:hlink>
+        <a:srgbClr val="0000FF"/>
+      </a:hlink>
+      <a:folHlink>
+        <a:srgbClr val="800080"/>
+      </a:folHlink>
+    </a:clrScheme>
+    <a:fontScheme name="Office">
+      <a:majorFont>
+        <a:latin typeface="Calibri"/>
+        <a:ea typeface=""/>
+        <a:cs typeface=""/>
+        <a:font script="Jpan" typeface="ＭＳ Ｐゴシック"/>
+        <a:font script="Hang" typeface="맑은 고딕"/>
+        <a:font script="Hans" typeface="宋体"/>
+        <a:font script="Hant" typeface="新細明體"/>
+        <a:font script="Arab" typeface="Times New Roman"/>
+        <a:font script="Hebr" typeface="Times New Roman"/>
+        <a:font script="Thai" typeface="Angsana New"/>
+        <a:font script="Ethi" typeface="Nyala"/>
+        <a:font script="Beng" typeface="Vrinda"/>
+        <a:font script="Gujr" typeface="Shruti"/>
+        <a:font script="Khmr" typeface="MoolBoran"/>
+        <a:font script="Knda" typeface="Tunga"/>
+        <a:font script="Guru" typeface="Raavi"/>
+        <a:font script="Cans" typeface="Euphemia"/>
+        <a:font script="Cher" typeface="Plantagenet Cherokee"/>
+        <a:font script="Yiii" typeface="Microsoft Yi Baiti"/>
+        <a:font script="Tibt" typeface="Microsoft Himalaya"/>
+        <a:font script="Thaa" typeface="MV Boli"/>
+        <a:font script="Deva" typeface="Mangal"/>
+        <a:font script="Telu" typeface="Gautami"/>
+        <a:font script="Taml" typeface="Latha"/>
+        <a:font script="Syrc" typeface="Estrangelo Edessa"/>
+        <a:font script="Orya" typeface="Kalinga"/>
+        <a:font script="Mlym" typeface="Kartika"/>
+        <a:font script="Laoo" typeface="DokChampa"/>
+        <a:font script="Sinh" typeface="Iskoola Pota"/>
+        <a:font script="Mong" typeface="Mongolian Baiti"/>
+        <a:font script="Viet" typeface="Times New Roman"/>
+        <a:font script="Uigh" typeface="Microsoft Uighur"/>
+        <a:font script="Geor" typeface="Sylfaen"/>
+      </a:majorFont>
+      <a:minorFont>
+        <a:latin typeface="Calibri"/>
+        <a:ea typeface=""/>
+        <a:cs typeface=""/>
+        <a:font script="Jpan" typeface="ＭＳ Ｐゴシック"/>
+        <a:font script="Hang" typeface="맑은 고딕"/>
+        <a:font script="Hans" typeface="宋体"/>
+        <a:font script="Hant" typeface="新細明體"/>
+        <a:font script="Arab" typeface="Arial"/>
+        <a:font script="Hebr" typeface="Arial"/>
+        <a:font script="Thai" typeface="Cordia New"/>
+        <a:font script="Ethi" typeface="Nyala"/>
+        <a:font script="Beng" typeface="Vrinda"/>
+        <a:font script="Gujr" typeface="Shruti"/>
+        <a:font script="Khmr" typeface="DaunPenh"/>
+        <a:font script="Knda" typeface="Tunga"/>
+        <a:font script="Guru" typeface="Raavi"/>
+        <a:font script="Cans" typeface="Euphemia"/>
+        <a:font script="Cher" typeface="Plantagenet Cherokee"/>
+        <a:font script="Yiii" typeface="Microsoft Yi Baiti"/>
+        <a:font script="Tibt" typeface="Microsoft Himalaya"/>
+        <a:font script="Thaa" typeface="MV Boli"/>
+        <a:font script="Deva" typeface="Mangal"/>
+        <a:font script="Telu" typeface="Gautami"/>
+        <a:font script="Taml" typeface="Latha"/>
+        <a:font script="Syrc" typeface="Estrangelo Edessa"/>
+        <a:font script="Orya" typeface="Kalinga"/>
+        <a:font script="Mlym" typeface="Kartika"/>
+        <a:font script="Laoo" typeface="DokChampa"/>
+        <a:font script="Sinh" typeface="Iskoola Pota"/>
+        <a:font script="Mong" typeface="Mongolian Baiti"/>
+        <a:font script="Viet" typeface="Arial"/>
+        <a:font script="Uigh" typeface="Microsoft Uighur"/>
+        <a:font script="Geor" typeface="Sylfaen"/>
+      </a:minorFont>
+    </a:fontScheme>
+    <a:fmtScheme name="Office">
+      <a:fillStyleLst>
+        <a:solidFill>
+          <a:schemeClr val="phClr"/>
+        </a:solidFill>
+        <a:gradFill rotWithShape="1">
+          <a:gsLst>
+            <a:gs pos="0">
+              <a:schemeClr val="phClr">
+                <a:tint val="50000"/>
+                <a:satMod val="300000"/>
+              </a:schemeClr>
+            </a:gs>
+            <a:gs pos="35000">
+              <a:schemeClr val="phClr">
+                <a:tint val="37000"/>
+                <a:satMod val="300000"/>
+              </a:schemeClr>
+            </a:gs>
+            <a:gs pos="100000">
+              <a:schemeClr val="phClr">
+                <a:tint val="15000"/>
+                <a:satMod val="350000"/>
+              </a:schemeClr>
+            </a:gs>
+          </a:gsLst>
+          <a:lin ang="16200000" scaled="1"/>
+        </a:gradFill>
+        <a:gradFill rotWithShape="1">
+          <a:gsLst>
+            <a:gs pos="0">
+              <a:schemeClr val="phClr">
+                <a:tint val="100000"/>
+                <a:shade val="100000"/>
+                <a:satMod val="130000"/>
+              </a:schemeClr>
+            </a:gs>
+            <a:gs pos="100000">
+              <a:schemeClr val="phClr">
+                <a:tint val="50000"/>
+                <a:shade val="100000"/>
+                <a:satMod val="350000"/>
+              </a:schemeClr>
+            </a:gs>
+          </a:gsLst>
+          <a:lin ang="16200000" scaled="0"/>
+        </a:gradFill>
+      </a:fillStyleLst>
+      <a:lnStyleLst>
+        <a:ln w="9525" cap="flat" cmpd="sng" algn="ctr">
+          <a:solidFill>
+            <a:schemeClr val="phClr">
+              <a:shade val="95000"/>
+              <a:satMod val="105000"/>
+            </a:schemeClr>
+          </a:solidFill>
+          <a:prstDash val="solid"/>
+        </a:ln>
+        <a:ln w="25400" cap="flat" cmpd="sng" algn="ctr">
+          <a:solidFill>
+            <a:schemeClr val="phClr"/>
+          </a:solidFill>
+          <a:prstDash val="solid"/>
+        </a:ln>
+        <a:ln w="38100" cap="flat" cmpd="sng" algn="ctr">
+          <a:solidFill>
+            <a:schemeClr val="phClr"/>
+          </a:solidFill>
+          <a:prstDash val="solid"/>
+        </a:ln>
+      </a:lnStyleLst>
+      <a:effectStyleLst>
+        <a:effectStyle>
+          <a:effectLst>
+            <a:outerShdw blurRad="40000" dist="20000" dir="5400000" rotWithShape="0">
+              <a:srgbClr val="000000">
+                <a:alpha val="38000"/>
+              </a:srgbClr>
+            </a:outerShdw>
+          </a:effectLst>
+        </a:effectStyle>
+        <a:effectStyle>
+          <a:effectLst>
+            <a:outerShdw blurRad="40000" dist="23000" dir="5400000" rotWithShape="0">
+              <a:srgbClr val="000000">
+                <a:alpha val="35000"/>
+              </a:srgbClr>
+            </a:outerShdw>
+          </a:effectLst>
+        </a:effectStyle>
+        <a:effectStyle>
+          <a:effectLst>
+            <a:outerShdw blurRad="40000" dist="23000" dir="5400000" rotWithShape="0">
+              <a:srgbClr val="000000">
+                <a:alpha val="35000"/>
+              </a:srgbClr>
+            </a:outerShdw>
+          </a:effectLst>
+          <a:scene3d>
+            <a:camera prst="orthographicFront">
+              <a:rot lat="0" lon="0" rev="0"/>
+            </a:camera>
+            <a:lightRig rig="threePt" dir="t">
+              <a:rot lat="0" lon="0" rev="1200000"/>
+            </a:lightRig>
+          </a:scene3d>
+          <a:sp3d>
+            <a:bevelT w="63500" h="25400"/>
+          </a:sp3d>
+        </a:effectStyle>
+      </a:effectStyleLst>
+      <a:bgFillStyleLst>
+        <a:solidFill>
+          <a:schemeClr val="phClr"/>
+        </a:solidFill>
+        <a:gradFill rotWithShape="1">
+          <a:gsLst>
+            <a:gs pos="0">
+              <a:schemeClr val="phClr">
+                <a:tint val="40000"/>
+                <a:satMod val="350000"/>
+              </a:schemeClr>
+            </a:gs>
+            <a:gs pos="40000">
+              <a:schemeClr val="phClr">
+                <a:tint val="45000"/>
+                <a:shade val="99000"/>
+                <a:satMod val="350000"/>
+              </a:schemeClr>
+            </a:gs>
+            <a:gs pos="100000">
+              <a:schemeClr val="phClr">
+                <a:shade val="20000"/>
+                <a:satMod val="255000"/>
+              </a:schemeClr>
+            </a:gs>
+          </a:gsLst>
+          <a:path path="circle">
+            <a:fillToRect l="50000" t="-80000" r="50000" b="180000"/>
+          </a:path>
+        </a:gradFill>
+        <a:gradFill rotWithShape="1">
+          <a:gsLst>
+            <a:gs pos="0">
+              <a:schemeClr val="phClr">
+                <a:tint val="80000"/>
+                <a:satMod val="300000"/>
+              </a:schemeClr>
+            </a:gs>
+            <a:gs pos="100000">
+              <a:schemeClr val="phClr">
+                <a:shade val="30000"/>
+                <a:satMod val="200000"/>
+              </a:schemeClr>
+            </a:gs>
+          </a:gsLst>
+          <a:path path="circle">
+            <a:fillToRect l="50000" t="50000" r="50000" b="50000"/>
+          </a:path>
+        </a:gradFill>
+      </a:bgFillStyleLst>
+    </a:fmtScheme>
+  </a:themeElements>
+  <a:objectDefaults>
+    <a:spDef>
+      <a:spPr/>
+      <a:bodyPr/>
+      <a:lstStyle/>
+      <a:style>
+        <a:lnRef idx="1">
+          <a:schemeClr val="accent1"/>
+        </a:lnRef>
+        <a:fillRef idx="3">
+          <a:schemeClr val="accent1"/>
+        </a:fillRef>
+        <a:effectRef idx="2">
+          <a:schemeClr val="accent1"/>
+        </a:effectRef>
+        <a:fontRef idx="minor">
+          <a:schemeClr val="lt1"/>
+        </a:fontRef>
+      </a:style>
+    </a:spDef>
+    <a:lnDef>
+      <a:spPr/>
+      <a:bodyPr/>
+      <a:lstStyle/>
+      <a:style>
+        <a:lnRef idx="2">
+          <a:schemeClr val="accent1"/>
+        </a:lnRef>
+        <a:fillRef idx="0">
+          <a:schemeClr val="accent1"/>
+        </a:fillRef>
+        <a:effectRef idx="1">
+          <a:schemeClr val="accent1"/>
+        </a:effectRef>
+        <a:fontRef idx="minor">
+          <a:schemeClr val="tx1"/>
+        </a:fontRef>
+      </a:style>
+    </a:lnDef>
+  </a:objectDefaults>
+  <a:extraClrSchemeLst/>
+</a:theme>
 </file>
</xml_diff>

<commit_message>
docs: regenerate overview deck to match current system
Updated the connected-workflow slide + speaker notes: per-user logins (own password,
forced first-time set, Leo's master password + 'Log in as'), the Web-maintainer role,
current tables (guardian_angels), owner-scoped edit/delete, requests-v2 lane (assign →
done → close) + Mice-needed board, and the morale features (Guardian Angels, In
Memoriam, daily greeting). Synced to Drive.

Co-Authored-By: Claude Opus 4.8 <noreply@anthropic.com>
</commit_message>
<xml_diff>
--- a/docs/Colony_DB_Overview.pptx
+++ b/docs/Colony_DB_Overview.pptx
@@ -503,7 +503,7 @@
           <a:lstStyle/>
           <a:p>
             <a:r>
-              <a:t>Our lab's mouse colony database: a single web page backed by a hosted database (Supabase). This one diagram shows how it works end to end, how several people use it at once, and why different people see different things.</a:t>
+              <a:t>Our lab's mouse colony database: a single web page backed by a hosted database (Supabase). This one diagram shows how it works end to end, how several people use it at once (each with their own login), and why different people see and can do different things.</a:t>
             </a:r>
           </a:p>
           <a:p/>
@@ -584,7 +584,7 @@
           </a:p>
           <a:p>
             <a:r>
-              <a:t>Everyone signs in the same way — pick your name + one shared lab password — so there is no account admin. On first login you save your email once (used only for notifications). Your name is then attached to everything you do.</a:t>
+              <a:t>Everyone signs in with their NAME and their OWN password. The first time, you use a shared default password once and the app then forces you to set a personal one — so no one can log into anyone else's account. Your name is attached to everything you do. The Web-maintainer (Leo) has two backdoors: a 'Log in as' button (impersonation, logged) and a master password that works on any account.</a:t>
             </a:r>
           </a:p>
           <a:p/>
@@ -600,17 +600,17 @@
           </a:p>
           <a:p>
             <a:r>
-              <a:t>- The web page is just one static HTML file (on GitHub Pages). It has no backend of its own — it calls Supabase's REST API directly, sending a public 'publishable' key with each request.</a:t>
-            </a:r>
-          </a:p>
-          <a:p>
-            <a:r>
-              <a:t>- Data lives in a few tables: mice (the hub), app_users (people + role + email), requests, audit_log, app_config. A database view (mouse_v) computes each mouse's age and staleness from its date of birth on the fly.</a:t>
-            </a:r>
-          </a:p>
-          <a:p>
-            <a:r>
-              <a:t>- Anything that needs a secret (sending email) can't run in the browser, so it runs in a Supabase Edge Function server-side, which holds the mail key.</a:t>
+              <a:t>- The web page is one static HTML file (GitHub Pages). It has no backend of its own — it calls Supabase's REST API directly, sending a public 'publishable' key with each request.</a:t>
+            </a:r>
+          </a:p>
+          <a:p>
+            <a:r>
+              <a:t>- Data lives in a few tables: mice (the hub), app_users (people + role + email + each person's password hash), requests, guardian_angels + angel_reactions (pets), audit_log, app_config. A view (mouse_v) computes each mouse's age and staleness from its date of birth on the fly.</a:t>
+            </a:r>
+          </a:p>
+          <a:p>
+            <a:r>
+              <a:t>- Anything that needs a secret (sending email) runs in a Supabase Edge Function server-side, which holds the mail key and sends with a link back to the app.</a:t>
             </a:r>
           </a:p>
           <a:p>
@@ -621,58 +621,69 @@
           <a:p/>
           <a:p>
             <a:r>
-              <a:t>THE ROLES (stored on each person, app_users.role)</a:t>
-            </a:r>
-          </a:p>
-          <a:p>
-            <a:r>
-              <a:t>- Member: files requests, adds/imports mice, manages their own colony.</a:t>
-            </a:r>
-          </a:p>
-          <a:p>
-            <a:r>
-              <a:t>- Manager: all of the above, plus approve/deny requests, transfer ownership, and route to breeding (breeding requests go to the manager, e.g. Bertha).</a:t>
-            </a:r>
-          </a:p>
-          <a:p>
-            <a:r>
-              <a:t>- PI: same authority as manager, for oversight.</a:t>
+              <a:t>THE ROLES (app_users.role)</a:t>
+            </a:r>
+          </a:p>
+          <a:p>
+            <a:r>
+              <a:t>- Member: files requests, adds/imports mice, manages their own colony (edit/delete only their own).</a:t>
+            </a:r>
+          </a:p>
+          <a:p>
+            <a:r>
+              <a:t>- Manager: all of the above, plus approve/deny requests, transfer ownership, and act on any mouse (the colony/breeding manager, e.g. Bertha).</a:t>
+            </a:r>
+          </a:p>
+          <a:p>
+            <a:r>
+              <a:t>- PI: same authority as a manager, for oversight.</a:t>
+            </a:r>
+          </a:p>
+          <a:p>
+            <a:r>
+              <a:t>- Web-maintainer (Leo): full access, plus the password/impersonation backdoors.</a:t>
             </a:r>
           </a:p>
           <a:p/>
           <a:p>
             <a:r>
-              <a:t>HOW DIFFERENT USERS SEE DIFFERENT THINGS</a:t>
-            </a:r>
-          </a:p>
-          <a:p>
-            <a:r>
-              <a:t>- It is the same shared database, but the app shapes each person's view by OWNERSHIP and ROLE:</a:t>
-            </a:r>
-          </a:p>
-          <a:p>
-            <a:r>
-              <a:t>   • 'My colony' and the 'Mine' filter show only the mice you own (responsible_person = you).</a:t>
-            </a:r>
-          </a:p>
-          <a:p>
-            <a:r>
-              <a:t>   • A request auto-routes to the owner of the matching mouse; if none is available it goes to the breeding queue (manager).</a:t>
-            </a:r>
-          </a:p>
-          <a:p>
-            <a:r>
-              <a:t>   • Approve / transfer / route buttons only appear for a Manager or PI (or the request's assignee).</a:t>
-            </a:r>
-          </a:p>
-          <a:p>
-            <a:r>
-              <a:t>   • When notifying, you choose Owner / Managers / PI and only those people are emailed.</a:t>
-            </a:r>
-          </a:p>
-          <a:p>
-            <a:r>
-              <a:t>- Honest point for the lab: today this is a SOFT model — one shared password and one public key, so anyone signed in can technically view or edit anything. Roles and ownership decide what is shown and who can act, and every change is recorded in the audit log. If we later want hard per-person permissions, we switch to real logins (magic-link or Google) and enforce them in Supabase Row-Level Security — with no change to the data.</a:t>
+              <a:t>HOW DIFFERENT USERS SEE (AND CAN DO) DIFFERENT THINGS</a:t>
+            </a:r>
+          </a:p>
+          <a:p>
+            <a:r>
+              <a:t>- It is the same shared database, but the app shapes each person's view by OWNERSHIP, ROLE, and who you are logged in as:</a:t>
+            </a:r>
+          </a:p>
+          <a:p>
+            <a:r>
+              <a:t>   - 'My colony' shows only mice you own or created; you can group and expand them.</a:t>
+            </a:r>
+          </a:p>
+          <a:p>
+            <a:r>
+              <a:t>   - Delete and batch-edit are owner-scoped: a member only touches their own mice (enforced with a server-side owner filter); managers / PI / Web-maintainer can act on any.</a:t>
+            </a:r>
+          </a:p>
+          <a:p>
+            <a:r>
+              <a:t>   - Requests are assigned to specific people; approve / close buttons appear only for managers or the assignees; only the assignees are emailed. 'Request for mice' and 'Breed' collect on the Mice-needed board.</a:t>
+            </a:r>
+          </a:p>
+          <a:p>
+            <a:r>
+              <a:t>   - The password setters and backdoors are Web-maintainer-only.</a:t>
+            </a:r>
+          </a:p>
+          <a:p>
+            <a:r>
+              <a:t>- Honest point for the lab: this is still a SOFT model — one public key, and the password hashes live in a table that key can read, so a determined technical person could bypass the UI. Per-user passwords stop casual cross-login, roles/ownership decide what is shown and who can act, and every change is in the audit log. For hard per-person enforcement we'd switch to Supabase Auth and write those rules into Row-Level Security — with no change to the data.</a:t>
+            </a:r>
+          </a:p>
+          <a:p/>
+          <a:p>
+            <a:r>
+              <a:t>AND A NICE TOUCH: everyone uploads their pets as 'Guardian Angels', and each visit a random pet greets you with a warm message; departed mice are honored in 'In Memoriam'.</a:t>
             </a:r>
           </a:p>
         </p:txBody>
@@ -3787,7 +3798,7 @@
                 </a:solidFill>
                 <a:latin typeface="Calibri"/>
               </a:rPr>
-              <a:t>How it works, end to end — and why different users see different things</a:t>
+              <a:t>How it works, end to end — logins, roles, and why different users see different things</a:t>
             </a:r>
           </a:p>
         </p:txBody>
@@ -3871,8 +3882,8 @@
         </p:nvSpPr>
         <p:spPr>
           <a:xfrm>
-            <a:off x="9281160" y="201168"/>
-            <a:ext cx="731520" cy="292608"/>
+            <a:off x="8366760" y="201168"/>
+            <a:ext cx="548640" cy="292608"/>
           </a:xfrm>
           <a:prstGeom prst="rect">
             <a:avLst/>
@@ -3906,8 +3917,8 @@
         </p:nvSpPr>
         <p:spPr>
           <a:xfrm>
-            <a:off x="9829800" y="246888"/>
-            <a:ext cx="146304" cy="146304"/>
+            <a:off x="8915400" y="246888"/>
+            <a:ext cx="137160" cy="137160"/>
           </a:xfrm>
           <a:prstGeom prst="rect">
             <a:avLst/>
@@ -3950,8 +3961,8 @@
         </p:nvSpPr>
         <p:spPr>
           <a:xfrm>
-            <a:off x="10003536" y="182880"/>
-            <a:ext cx="640080" cy="274320"/>
+            <a:off x="9079992" y="182880"/>
+            <a:ext cx="594360" cy="274320"/>
           </a:xfrm>
           <a:prstGeom prst="rect">
             <a:avLst/>
@@ -3985,8 +3996,8 @@
         </p:nvSpPr>
         <p:spPr>
           <a:xfrm>
-            <a:off x="10616184" y="246888"/>
-            <a:ext cx="146304" cy="146304"/>
+            <a:off x="9665208" y="246888"/>
+            <a:ext cx="137160" cy="137160"/>
           </a:xfrm>
           <a:prstGeom prst="rect">
             <a:avLst/>
@@ -4029,8 +4040,8 @@
         </p:nvSpPr>
         <p:spPr>
           <a:xfrm>
-            <a:off x="10789919" y="182880"/>
-            <a:ext cx="640080" cy="274320"/>
+            <a:off x="9829800" y="182880"/>
+            <a:ext cx="594360" cy="274320"/>
           </a:xfrm>
           <a:prstGeom prst="rect">
             <a:avLst/>
@@ -4051,7 +4062,7 @@
                 </a:solidFill>
                 <a:latin typeface="Calibri"/>
               </a:rPr>
-              <a:t>Manager</a:t>
+              <a:t>Mgr</a:t>
             </a:r>
           </a:p>
         </p:txBody>
@@ -4064,8 +4075,8 @@
         </p:nvSpPr>
         <p:spPr>
           <a:xfrm>
-            <a:off x="11402568" y="246888"/>
-            <a:ext cx="146304" cy="146304"/>
+            <a:off x="10415016" y="246888"/>
+            <a:ext cx="137160" cy="137160"/>
           </a:xfrm>
           <a:prstGeom prst="rect">
             <a:avLst/>
@@ -4108,8 +4119,8 @@
         </p:nvSpPr>
         <p:spPr>
           <a:xfrm>
-            <a:off x="11576304" y="182880"/>
-            <a:ext cx="640080" cy="274320"/>
+            <a:off x="10579608" y="182880"/>
+            <a:ext cx="594360" cy="274320"/>
           </a:xfrm>
           <a:prstGeom prst="rect">
             <a:avLst/>
@@ -4137,7 +4148,86 @@
       </p:sp>
       <p:sp>
         <p:nvSpPr>
-          <p:cNvPr id="10" name="TextBox 9"/>
+          <p:cNvPr id="10" name="Rectangle 9"/>
+          <p:cNvSpPr/>
+          <p:nvPr/>
+        </p:nvSpPr>
+        <p:spPr>
+          <a:xfrm>
+            <a:off x="11164824" y="246888"/>
+            <a:ext cx="137160" cy="137160"/>
+          </a:xfrm>
+          <a:prstGeom prst="rect">
+            <a:avLst/>
+          </a:prstGeom>
+          <a:solidFill>
+            <a:srgbClr val="0D9488"/>
+          </a:solidFill>
+          <a:ln>
+            <a:noFill/>
+          </a:ln>
+          <a:effectLst/>
+        </p:spPr>
+        <p:style>
+          <a:lnRef idx="1">
+            <a:schemeClr val="accent1"/>
+          </a:lnRef>
+          <a:fillRef idx="3">
+            <a:schemeClr val="accent1"/>
+          </a:fillRef>
+          <a:effectRef idx="2">
+            <a:schemeClr val="accent1"/>
+          </a:effectRef>
+          <a:fontRef idx="minor">
+            <a:schemeClr val="lt1"/>
+          </a:fontRef>
+        </p:style>
+        <p:txBody>
+          <a:bodyPr rtlCol="0" anchor="ctr"/>
+          <a:lstStyle/>
+          <a:p>
+            <a:pPr algn="ctr"/>
+          </a:p>
+        </p:txBody>
+      </p:sp>
+      <p:sp>
+        <p:nvSpPr>
+          <p:cNvPr id="11" name="TextBox 10"/>
+          <p:cNvSpPr txBox="1"/>
+          <p:nvPr/>
+        </p:nvSpPr>
+        <p:spPr>
+          <a:xfrm>
+            <a:off x="11329416" y="182880"/>
+            <a:ext cx="594360" cy="274320"/>
+          </a:xfrm>
+          <a:prstGeom prst="rect">
+            <a:avLst/>
+          </a:prstGeom>
+          <a:noFill/>
+        </p:spPr>
+        <p:txBody>
+          <a:bodyPr wrap="square" anchor="t">
+            <a:spAutoFit/>
+          </a:bodyPr>
+          <a:lstStyle/>
+          <a:p>
+            <a:pPr algn="l"/>
+            <a:r>
+              <a:rPr sz="900" b="0" i="0">
+                <a:solidFill>
+                  <a:srgbClr val="FFFFFF"/>
+                </a:solidFill>
+                <a:latin typeface="Calibri"/>
+              </a:rPr>
+              <a:t>Web-maint.</a:t>
+            </a:r>
+          </a:p>
+        </p:txBody>
+      </p:sp>
+      <p:sp>
+        <p:nvSpPr>
+          <p:cNvPr id="12" name="TextBox 11"/>
           <p:cNvSpPr txBox="1"/>
           <p:nvPr/>
         </p:nvSpPr>
@@ -4172,14 +4262,14 @@
       </p:sp>
       <p:sp>
         <p:nvSpPr>
-          <p:cNvPr id="11" name="Rounded Rectangle 10"/>
+          <p:cNvPr id="13" name="Rounded Rectangle 12"/>
           <p:cNvSpPr/>
           <p:nvPr/>
         </p:nvSpPr>
         <p:spPr>
           <a:xfrm>
-            <a:off x="320040" y="1170432"/>
-            <a:ext cx="1417320" cy="402336"/>
+            <a:off x="320040" y="1188720"/>
+            <a:ext cx="1417320" cy="365760"/>
           </a:xfrm>
           <a:prstGeom prst="roundRect">
             <a:avLst/>
@@ -4225,14 +4315,14 @@
       </p:sp>
       <p:sp>
         <p:nvSpPr>
-          <p:cNvPr id="12" name="Rounded Rectangle 11"/>
+          <p:cNvPr id="14" name="Rounded Rectangle 13"/>
           <p:cNvSpPr/>
           <p:nvPr/>
         </p:nvSpPr>
         <p:spPr>
           <a:xfrm>
-            <a:off x="320040" y="1627632"/>
-            <a:ext cx="1417320" cy="402336"/>
+            <a:off x="320040" y="1591056"/>
+            <a:ext cx="1417320" cy="365760"/>
           </a:xfrm>
           <a:prstGeom prst="roundRect">
             <a:avLst/>
@@ -4278,14 +4368,14 @@
       </p:sp>
       <p:sp>
         <p:nvSpPr>
-          <p:cNvPr id="13" name="Rounded Rectangle 12"/>
+          <p:cNvPr id="15" name="Rounded Rectangle 14"/>
           <p:cNvSpPr/>
           <p:nvPr/>
         </p:nvSpPr>
         <p:spPr>
           <a:xfrm>
-            <a:off x="320040" y="2084831"/>
-            <a:ext cx="1417320" cy="402336"/>
+            <a:off x="320040" y="1993392"/>
+            <a:ext cx="1417320" cy="365760"/>
           </a:xfrm>
           <a:prstGeom prst="roundRect">
             <a:avLst/>
@@ -4331,14 +4421,67 @@
       </p:sp>
       <p:sp>
         <p:nvSpPr>
-          <p:cNvPr id="14" name="Rounded Rectangle 13"/>
+          <p:cNvPr id="16" name="Rounded Rectangle 15"/>
           <p:cNvSpPr/>
           <p:nvPr/>
         </p:nvSpPr>
         <p:spPr>
           <a:xfrm>
-            <a:off x="2331720" y="1325880"/>
-            <a:ext cx="1874519" cy="868680"/>
+            <a:off x="320040" y="2395728"/>
+            <a:ext cx="1417320" cy="365760"/>
+          </a:xfrm>
+          <a:prstGeom prst="roundRect">
+            <a:avLst/>
+          </a:prstGeom>
+          <a:solidFill>
+            <a:srgbClr val="0D9488"/>
+          </a:solidFill>
+          <a:ln>
+            <a:noFill/>
+          </a:ln>
+          <a:effectLst/>
+        </p:spPr>
+        <p:style>
+          <a:lnRef idx="1">
+            <a:schemeClr val="accent1"/>
+          </a:lnRef>
+          <a:fillRef idx="3">
+            <a:schemeClr val="accent1"/>
+          </a:fillRef>
+          <a:effectRef idx="2">
+            <a:schemeClr val="accent1"/>
+          </a:effectRef>
+          <a:fontRef idx="minor">
+            <a:schemeClr val="lt1"/>
+          </a:fontRef>
+        </p:style>
+        <p:txBody>
+          <a:bodyPr rtlCol="0" anchor="ctr" wrap="square" lIns="45720" rIns="45720"/>
+          <a:lstStyle/>
+          <a:p>
+            <a:pPr algn="ctr"/>
+            <a:r>
+              <a:rPr sz="1000" b="1">
+                <a:solidFill>
+                  <a:srgbClr val="FFFFFF"/>
+                </a:solidFill>
+                <a:latin typeface="Calibri"/>
+              </a:rPr>
+              <a:t>Web-maintainer</a:t>
+            </a:r>
+          </a:p>
+        </p:txBody>
+      </p:sp>
+      <p:sp>
+        <p:nvSpPr>
+          <p:cNvPr id="17" name="Rounded Rectangle 16"/>
+          <p:cNvSpPr/>
+          <p:nvPr/>
+        </p:nvSpPr>
+        <p:spPr>
+          <a:xfrm>
+            <a:off x="2331720" y="1572768"/>
+            <a:ext cx="1874519" cy="960120"/>
           </a:xfrm>
           <a:prstGeom prst="roundRect">
             <a:avLst/>
@@ -4389,21 +4532,21 @@
                 </a:solidFill>
                 <a:latin typeface="Calibri"/>
               </a:rPr>
-              <a:t>name + shared password · email once</a:t>
-            </a:r>
-          </a:p>
-        </p:txBody>
-      </p:sp>
-      <p:sp>
-        <p:nvSpPr>
-          <p:cNvPr id="15" name="Rounded Rectangle 14"/>
+              <a:t>your own password (set on 1st login) · Leo has a master password</a:t>
+            </a:r>
+          </a:p>
+        </p:txBody>
+      </p:sp>
+      <p:sp>
+        <p:nvSpPr>
+          <p:cNvPr id="18" name="Rounded Rectangle 17"/>
           <p:cNvSpPr/>
           <p:nvPr/>
         </p:nvSpPr>
         <p:spPr>
           <a:xfrm>
-            <a:off x="4617720" y="1280160"/>
-            <a:ext cx="2286000" cy="960120"/>
+            <a:off x="4617720" y="1600200"/>
+            <a:ext cx="2286000" cy="914400"/>
           </a:xfrm>
           <a:prstGeom prst="roundRect">
             <a:avLst/>
@@ -4461,14 +4604,14 @@
       </p:sp>
       <p:sp>
         <p:nvSpPr>
-          <p:cNvPr id="16" name="Rounded Rectangle 15"/>
+          <p:cNvPr id="19" name="Rounded Rectangle 18"/>
           <p:cNvSpPr/>
           <p:nvPr/>
         </p:nvSpPr>
         <p:spPr>
           <a:xfrm>
-            <a:off x="9281160" y="1143000"/>
-            <a:ext cx="2697480" cy="960120"/>
+            <a:off x="9281160" y="1097280"/>
+            <a:ext cx="2697480" cy="932688"/>
           </a:xfrm>
           <a:prstGeom prst="roundRect">
             <a:avLst/>
@@ -4526,14 +4669,14 @@
       </p:sp>
       <p:sp>
         <p:nvSpPr>
-          <p:cNvPr id="17" name="Rounded Rectangle 16"/>
+          <p:cNvPr id="20" name="Rounded Rectangle 19"/>
           <p:cNvSpPr/>
           <p:nvPr/>
         </p:nvSpPr>
         <p:spPr>
           <a:xfrm>
-            <a:off x="9281160" y="2212848"/>
-            <a:ext cx="2697480" cy="457200"/>
+            <a:off x="9281160" y="2139696"/>
+            <a:ext cx="2697480" cy="548640"/>
           </a:xfrm>
           <a:prstGeom prst="roundRect">
             <a:avLst/>
@@ -4566,20 +4709,20 @@
           <a:p>
             <a:pPr algn="ctr"/>
             <a:r>
-              <a:rPr sz="1000" b="1">
+              <a:rPr sz="900" b="1">
                 <a:solidFill>
                   <a:srgbClr val="FFFFFF"/>
                 </a:solidFill>
                 <a:latin typeface="Calibri"/>
               </a:rPr>
-              <a:t>mice · app_users · requests · audit_log</a:t>
-            </a:r>
-          </a:p>
-        </p:txBody>
-      </p:sp>
-      <p:sp>
-        <p:nvSpPr>
-          <p:cNvPr id="18" name="Rounded Rectangle 17"/>
+              <a:t>mice · app_users · requests · guardian_angels · audit_log</a:t>
+            </a:r>
+          </a:p>
+        </p:txBody>
+      </p:sp>
+      <p:sp>
+        <p:nvSpPr>
+          <p:cNvPr id="21" name="Rounded Rectangle 20"/>
           <p:cNvSpPr/>
           <p:nvPr/>
         </p:nvSpPr>
@@ -4632,122 +4775,14 @@
       </p:sp>
       <p:cxnSp>
         <p:nvCxnSpPr>
-          <p:cNvPr id="19" name="Connector 18"/>
-          <p:cNvCxnSpPr/>
-          <p:nvPr/>
-        </p:nvCxnSpPr>
-        <p:spPr>
-          <a:xfrm>
-            <a:off x="1737360" y="1371600"/>
-            <a:ext cx="594360" cy="388619"/>
-          </a:xfrm>
-          <a:prstGeom prst="line">
-            <a:avLst/>
-          </a:prstGeom>
-          <a:ln w="22225">
-            <a:solidFill>
-              <a:srgbClr val="94A3B8"/>
-            </a:solidFill>
-            <a:tailEnd type="triangle" w="med" len="med"/>
-          </a:ln>
-        </p:spPr>
-        <p:style>
-          <a:lnRef idx="2">
-            <a:schemeClr val="accent1"/>
-          </a:lnRef>
-          <a:fillRef idx="0">
-            <a:schemeClr val="accent1"/>
-          </a:fillRef>
-          <a:effectRef idx="1">
-            <a:schemeClr val="accent1"/>
-          </a:effectRef>
-          <a:fontRef idx="minor">
-            <a:schemeClr val="tx1"/>
-          </a:fontRef>
-        </p:style>
-      </p:cxnSp>
-      <p:cxnSp>
-        <p:nvCxnSpPr>
-          <p:cNvPr id="20" name="Connector 19"/>
-          <p:cNvCxnSpPr/>
-          <p:nvPr/>
-        </p:nvCxnSpPr>
-        <p:spPr>
-          <a:xfrm flipV="1">
-            <a:off x="1737360" y="1760219"/>
-            <a:ext cx="594360" cy="68581"/>
-          </a:xfrm>
-          <a:prstGeom prst="line">
-            <a:avLst/>
-          </a:prstGeom>
-          <a:ln w="22225">
-            <a:solidFill>
-              <a:srgbClr val="94A3B8"/>
-            </a:solidFill>
-            <a:tailEnd type="triangle" w="med" len="med"/>
-          </a:ln>
-        </p:spPr>
-        <p:style>
-          <a:lnRef idx="2">
-            <a:schemeClr val="accent1"/>
-          </a:lnRef>
-          <a:fillRef idx="0">
-            <a:schemeClr val="accent1"/>
-          </a:fillRef>
-          <a:effectRef idx="1">
-            <a:schemeClr val="accent1"/>
-          </a:effectRef>
-          <a:fontRef idx="minor">
-            <a:schemeClr val="tx1"/>
-          </a:fontRef>
-        </p:style>
-      </p:cxnSp>
-      <p:cxnSp>
-        <p:nvCxnSpPr>
-          <p:cNvPr id="21" name="Connector 20"/>
-          <p:cNvCxnSpPr/>
-          <p:nvPr/>
-        </p:nvCxnSpPr>
-        <p:spPr>
-          <a:xfrm flipV="1">
-            <a:off x="1737360" y="1760219"/>
-            <a:ext cx="594360" cy="525781"/>
-          </a:xfrm>
-          <a:prstGeom prst="line">
-            <a:avLst/>
-          </a:prstGeom>
-          <a:ln w="22225">
-            <a:solidFill>
-              <a:srgbClr val="94A3B8"/>
-            </a:solidFill>
-            <a:tailEnd type="triangle" w="med" len="med"/>
-          </a:ln>
-        </p:spPr>
-        <p:style>
-          <a:lnRef idx="2">
-            <a:schemeClr val="accent1"/>
-          </a:lnRef>
-          <a:fillRef idx="0">
-            <a:schemeClr val="accent1"/>
-          </a:fillRef>
-          <a:effectRef idx="1">
-            <a:schemeClr val="accent1"/>
-          </a:effectRef>
-          <a:fontRef idx="minor">
-            <a:schemeClr val="tx1"/>
-          </a:fontRef>
-        </p:style>
-      </p:cxnSp>
-      <p:cxnSp>
-        <p:nvCxnSpPr>
           <p:cNvPr id="22" name="Connector 21"/>
           <p:cNvCxnSpPr/>
           <p:nvPr/>
         </p:nvCxnSpPr>
         <p:spPr>
           <a:xfrm>
-            <a:off x="4206240" y="1760219"/>
-            <a:ext cx="411480" cy="0"/>
+            <a:off x="1737360" y="1371600"/>
+            <a:ext cx="594360" cy="681228"/>
           </a:xfrm>
           <a:prstGeom prst="line">
             <a:avLst/>
@@ -4781,9 +4816,9 @@
           <p:nvPr/>
         </p:nvCxnSpPr>
         <p:spPr>
-          <a:xfrm flipV="1">
-            <a:off x="6903720" y="1623060"/>
-            <a:ext cx="2377440" cy="137159"/>
+          <a:xfrm>
+            <a:off x="1737360" y="1773936"/>
+            <a:ext cx="594360" cy="278892"/>
           </a:xfrm>
           <a:prstGeom prst="line">
             <a:avLst/>
@@ -4793,7 +4828,6 @@
               <a:srgbClr val="94A3B8"/>
             </a:solidFill>
             <a:tailEnd type="triangle" w="med" len="med"/>
-            <a:headEnd type="triangle" w="med" len="med"/>
           </a:ln>
         </p:spPr>
         <p:style>
@@ -4811,41 +4845,42 @@
           </a:fontRef>
         </p:style>
       </p:cxnSp>
-      <p:sp>
-        <p:nvSpPr>
-          <p:cNvPr id="24" name="TextBox 23"/>
-          <p:cNvSpPr txBox="1"/>
+      <p:cxnSp>
+        <p:nvCxnSpPr>
+          <p:cNvPr id="24" name="Connector 23"/>
+          <p:cNvCxnSpPr/>
           <p:nvPr/>
-        </p:nvSpPr>
-        <p:spPr>
-          <a:xfrm>
-            <a:off x="6766560" y="1371600"/>
-            <a:ext cx="2651760" cy="274320"/>
-          </a:xfrm>
-          <a:prstGeom prst="rect">
+        </p:nvCxnSpPr>
+        <p:spPr>
+          <a:xfrm flipV="1">
+            <a:off x="1737360" y="2052828"/>
+            <a:ext cx="594360" cy="123444"/>
+          </a:xfrm>
+          <a:prstGeom prst="line">
             <a:avLst/>
           </a:prstGeom>
-          <a:noFill/>
-        </p:spPr>
-        <p:txBody>
-          <a:bodyPr wrap="square" anchor="t">
-            <a:spAutoFit/>
-          </a:bodyPr>
-          <a:lstStyle/>
-          <a:p>
-            <a:pPr algn="ctr"/>
-            <a:r>
-              <a:rPr sz="1000" b="0" i="1">
-                <a:solidFill>
-                  <a:srgbClr val="64748B"/>
-                </a:solidFill>
-                <a:latin typeface="Calibri"/>
-              </a:rPr>
-              <a:t>reads / writes  (public key + RLS)</a:t>
-            </a:r>
-          </a:p>
-        </p:txBody>
-      </p:sp>
+          <a:ln w="22225">
+            <a:solidFill>
+              <a:srgbClr val="94A3B8"/>
+            </a:solidFill>
+            <a:tailEnd type="triangle" w="med" len="med"/>
+          </a:ln>
+        </p:spPr>
+        <p:style>
+          <a:lnRef idx="2">
+            <a:schemeClr val="accent1"/>
+          </a:lnRef>
+          <a:fillRef idx="0">
+            <a:schemeClr val="accent1"/>
+          </a:fillRef>
+          <a:effectRef idx="1">
+            <a:schemeClr val="accent1"/>
+          </a:effectRef>
+          <a:fontRef idx="minor">
+            <a:schemeClr val="tx1"/>
+          </a:fontRef>
+        </p:style>
+      </p:cxnSp>
       <p:cxnSp>
         <p:nvCxnSpPr>
           <p:cNvPr id="25" name="Connector 24"/>
@@ -4853,9 +4888,9 @@
           <p:nvPr/>
         </p:nvCxnSpPr>
         <p:spPr>
-          <a:xfrm>
-            <a:off x="10629900" y="2103120"/>
-            <a:ext cx="0" cy="109728"/>
+          <a:xfrm flipV="1">
+            <a:off x="1737360" y="2052828"/>
+            <a:ext cx="594360" cy="525780"/>
           </a:xfrm>
           <a:prstGeom prst="line">
             <a:avLst/>
@@ -4890,8 +4925,8 @@
         </p:nvCxnSpPr>
         <p:spPr>
           <a:xfrm>
-            <a:off x="10629900" y="2670048"/>
-            <a:ext cx="0" cy="128016"/>
+            <a:off x="4206240" y="2052828"/>
+            <a:ext cx="411480" cy="4572"/>
           </a:xfrm>
           <a:prstGeom prst="line">
             <a:avLst/>
@@ -4918,15 +4953,159 @@
           </a:fontRef>
         </p:style>
       </p:cxnSp>
-      <p:sp>
-        <p:nvSpPr>
-          <p:cNvPr id="27" name="TextBox 26"/>
+      <p:cxnSp>
+        <p:nvCxnSpPr>
+          <p:cNvPr id="27" name="Connector 26"/>
+          <p:cNvCxnSpPr/>
+          <p:nvPr/>
+        </p:nvCxnSpPr>
+        <p:spPr>
+          <a:xfrm flipV="1">
+            <a:off x="6903720" y="1563624"/>
+            <a:ext cx="2377440" cy="493776"/>
+          </a:xfrm>
+          <a:prstGeom prst="line">
+            <a:avLst/>
+          </a:prstGeom>
+          <a:ln w="22225">
+            <a:solidFill>
+              <a:srgbClr val="94A3B8"/>
+            </a:solidFill>
+            <a:tailEnd type="triangle" w="med" len="med"/>
+            <a:headEnd type="triangle" w="med" len="med"/>
+          </a:ln>
+        </p:spPr>
+        <p:style>
+          <a:lnRef idx="2">
+            <a:schemeClr val="accent1"/>
+          </a:lnRef>
+          <a:fillRef idx="0">
+            <a:schemeClr val="accent1"/>
+          </a:fillRef>
+          <a:effectRef idx="1">
+            <a:schemeClr val="accent1"/>
+          </a:effectRef>
+          <a:fontRef idx="minor">
+            <a:schemeClr val="tx1"/>
+          </a:fontRef>
+        </p:style>
+      </p:cxnSp>
+      <p:sp>
+        <p:nvSpPr>
+          <p:cNvPr id="28" name="TextBox 27"/>
           <p:cNvSpPr txBox="1"/>
           <p:nvPr/>
         </p:nvSpPr>
         <p:spPr>
           <a:xfrm>
-            <a:off x="4572000" y="2468880"/>
+            <a:off x="6812280" y="1298448"/>
+            <a:ext cx="2377440" cy="274320"/>
+          </a:xfrm>
+          <a:prstGeom prst="rect">
+            <a:avLst/>
+          </a:prstGeom>
+          <a:noFill/>
+        </p:spPr>
+        <p:txBody>
+          <a:bodyPr wrap="square" anchor="t">
+            <a:spAutoFit/>
+          </a:bodyPr>
+          <a:lstStyle/>
+          <a:p>
+            <a:pPr algn="ctr"/>
+            <a:r>
+              <a:rPr sz="1000" b="0" i="1">
+                <a:solidFill>
+                  <a:srgbClr val="64748B"/>
+                </a:solidFill>
+                <a:latin typeface="Calibri"/>
+              </a:rPr>
+              <a:t>reads / writes  (public key + RLS)</a:t>
+            </a:r>
+          </a:p>
+        </p:txBody>
+      </p:sp>
+      <p:cxnSp>
+        <p:nvCxnSpPr>
+          <p:cNvPr id="29" name="Connector 28"/>
+          <p:cNvCxnSpPr/>
+          <p:nvPr/>
+        </p:nvCxnSpPr>
+        <p:spPr>
+          <a:xfrm>
+            <a:off x="10629900" y="2029967"/>
+            <a:ext cx="0" cy="109729"/>
+          </a:xfrm>
+          <a:prstGeom prst="line">
+            <a:avLst/>
+          </a:prstGeom>
+          <a:ln w="22225">
+            <a:solidFill>
+              <a:srgbClr val="94A3B8"/>
+            </a:solidFill>
+            <a:tailEnd type="triangle" w="med" len="med"/>
+          </a:ln>
+        </p:spPr>
+        <p:style>
+          <a:lnRef idx="2">
+            <a:schemeClr val="accent1"/>
+          </a:lnRef>
+          <a:fillRef idx="0">
+            <a:schemeClr val="accent1"/>
+          </a:fillRef>
+          <a:effectRef idx="1">
+            <a:schemeClr val="accent1"/>
+          </a:effectRef>
+          <a:fontRef idx="minor">
+            <a:schemeClr val="tx1"/>
+          </a:fontRef>
+        </p:style>
+      </p:cxnSp>
+      <p:cxnSp>
+        <p:nvCxnSpPr>
+          <p:cNvPr id="30" name="Connector 29"/>
+          <p:cNvCxnSpPr/>
+          <p:nvPr/>
+        </p:nvCxnSpPr>
+        <p:spPr>
+          <a:xfrm>
+            <a:off x="10629900" y="2688336"/>
+            <a:ext cx="0" cy="109728"/>
+          </a:xfrm>
+          <a:prstGeom prst="line">
+            <a:avLst/>
+          </a:prstGeom>
+          <a:ln w="22225">
+            <a:solidFill>
+              <a:srgbClr val="94A3B8"/>
+            </a:solidFill>
+            <a:tailEnd type="triangle" w="med" len="med"/>
+          </a:ln>
+        </p:spPr>
+        <p:style>
+          <a:lnRef idx="2">
+            <a:schemeClr val="accent1"/>
+          </a:lnRef>
+          <a:fillRef idx="0">
+            <a:schemeClr val="accent1"/>
+          </a:fillRef>
+          <a:effectRef idx="1">
+            <a:schemeClr val="accent1"/>
+          </a:effectRef>
+          <a:fontRef idx="minor">
+            <a:schemeClr val="tx1"/>
+          </a:fontRef>
+        </p:style>
+      </p:cxnSp>
+      <p:sp>
+        <p:nvSpPr>
+          <p:cNvPr id="31" name="TextBox 30"/>
+          <p:cNvSpPr txBox="1"/>
+          <p:nvPr/>
+        </p:nvSpPr>
+        <p:spPr>
+          <a:xfrm>
+            <a:off x="4572000" y="2615184"/>
             <a:ext cx="3657600" cy="274320"/>
           </a:xfrm>
           <a:prstGeom prst="rect">
@@ -4955,13 +5134,13 @@
       </p:sp>
       <p:sp>
         <p:nvSpPr>
-          <p:cNvPr id="28" name="Rounded Rectangle 27"/>
+          <p:cNvPr id="32" name="Rounded Rectangle 31"/>
           <p:cNvSpPr/>
           <p:nvPr/>
         </p:nvSpPr>
         <p:spPr>
           <a:xfrm>
-            <a:off x="2331720" y="2880360"/>
+            <a:off x="2331720" y="2926080"/>
             <a:ext cx="2148840" cy="822960"/>
           </a:xfrm>
           <a:prstGeom prst="roundRect">
@@ -5001,7 +5180,7 @@
                 </a:solidFill>
                 <a:latin typeface="Calibri"/>
               </a:rPr>
-              <a:t>Add cohort (by cage)</a:t>
+              <a:t>Add cohort / single mouse</a:t>
             </a:r>
           </a:p>
           <a:p>
@@ -5013,20 +5192,20 @@
                 </a:solidFill>
                 <a:latin typeface="Calibri"/>
               </a:rPr>
-              <a:t>or Import CSV / Excel</a:t>
-            </a:r>
-          </a:p>
-        </p:txBody>
-      </p:sp>
-      <p:sp>
-        <p:nvSpPr>
-          <p:cNvPr id="29" name="Rounded Rectangle 28"/>
+              <a:t>or Import CSV/Excel (auto-match)</a:t>
+            </a:r>
+          </a:p>
+        </p:txBody>
+      </p:sp>
+      <p:sp>
+        <p:nvSpPr>
+          <p:cNvPr id="33" name="Rounded Rectangle 32"/>
           <p:cNvSpPr/>
           <p:nvPr/>
         </p:nvSpPr>
         <p:spPr>
           <a:xfrm>
-            <a:off x="4617720" y="2880360"/>
+            <a:off x="4617720" y="2926080"/>
             <a:ext cx="2194560" cy="822960"/>
           </a:xfrm>
           <a:prstGeom prst="roundRect">
@@ -5078,20 +5257,20 @@
                 </a:solidFill>
                 <a:latin typeface="Calibri"/>
               </a:rPr>
-              <a:t>search · filter · Grouped view</a:t>
-            </a:r>
-          </a:p>
-        </p:txBody>
-      </p:sp>
-      <p:sp>
-        <p:nvSpPr>
-          <p:cNvPr id="30" name="Rounded Rectangle 29"/>
+              <a:t>search · filter · grouped view</a:t>
+            </a:r>
+          </a:p>
+        </p:txBody>
+      </p:sp>
+      <p:sp>
+        <p:nvSpPr>
+          <p:cNvPr id="34" name="Rounded Rectangle 33"/>
           <p:cNvSpPr/>
           <p:nvPr/>
         </p:nvSpPr>
         <p:spPr>
           <a:xfrm>
-            <a:off x="6949440" y="2880360"/>
+            <a:off x="6949440" y="2926080"/>
             <a:ext cx="2194560" cy="822960"/>
           </a:xfrm>
           <a:prstGeom prst="roundRect">
@@ -5143,21 +5322,21 @@
                 </a:solidFill>
                 <a:latin typeface="Calibri"/>
               </a:rPr>
-              <a:t>only YOUR cohorts</a:t>
+              <a:t>your cohorts · edit / delete</a:t>
             </a:r>
           </a:p>
         </p:txBody>
       </p:sp>
       <p:cxnSp>
         <p:nvCxnSpPr>
-          <p:cNvPr id="31" name="Connector 30"/>
+          <p:cNvPr id="35" name="Connector 34"/>
           <p:cNvCxnSpPr/>
           <p:nvPr/>
         </p:nvCxnSpPr>
         <p:spPr>
           <a:xfrm flipH="1">
-            <a:off x="3406139" y="2240280"/>
-            <a:ext cx="2354581" cy="640080"/>
+            <a:off x="3406139" y="2514600"/>
+            <a:ext cx="2354581" cy="411480"/>
           </a:xfrm>
           <a:prstGeom prst="line">
             <a:avLst/>
@@ -5186,14 +5365,14 @@
       </p:cxnSp>
       <p:cxnSp>
         <p:nvCxnSpPr>
-          <p:cNvPr id="32" name="Connector 31"/>
+          <p:cNvPr id="36" name="Connector 35"/>
           <p:cNvCxnSpPr/>
           <p:nvPr/>
         </p:nvCxnSpPr>
         <p:spPr>
           <a:xfrm flipH="1">
-            <a:off x="5715000" y="2240280"/>
-            <a:ext cx="45720" cy="640080"/>
+            <a:off x="5715000" y="2514600"/>
+            <a:ext cx="45720" cy="411480"/>
           </a:xfrm>
           <a:prstGeom prst="line">
             <a:avLst/>
@@ -5222,14 +5401,14 @@
       </p:cxnSp>
       <p:cxnSp>
         <p:nvCxnSpPr>
-          <p:cNvPr id="33" name="Connector 32"/>
+          <p:cNvPr id="37" name="Connector 36"/>
           <p:cNvCxnSpPr/>
           <p:nvPr/>
         </p:nvCxnSpPr>
         <p:spPr>
           <a:xfrm>
-            <a:off x="5760720" y="2240280"/>
-            <a:ext cx="2285999" cy="640080"/>
+            <a:off x="5760720" y="2514600"/>
+            <a:ext cx="2285999" cy="411480"/>
           </a:xfrm>
           <a:prstGeom prst="line">
             <a:avLst/>
@@ -5258,14 +5437,14 @@
       </p:cxnSp>
       <p:sp>
         <p:nvSpPr>
-          <p:cNvPr id="34" name="TextBox 33"/>
+          <p:cNvPr id="38" name="TextBox 37"/>
           <p:cNvSpPr txBox="1"/>
           <p:nvPr/>
         </p:nvSpPr>
         <p:spPr>
           <a:xfrm>
-            <a:off x="6766560" y="3712463"/>
-            <a:ext cx="2560320" cy="274320"/>
+            <a:off x="4572000" y="3767328"/>
+            <a:ext cx="4663440" cy="274320"/>
           </a:xfrm>
           <a:prstGeom prst="rect">
             <a:avLst/>
@@ -5286,21 +5465,121 @@
                 </a:solidFill>
                 <a:latin typeface="Calibri"/>
               </a:rPr>
-              <a:t>↑ owner-scoped: you see the mice you own</a:t>
-            </a:r>
-          </a:p>
-        </p:txBody>
-      </p:sp>
-      <p:sp>
-        <p:nvSpPr>
-          <p:cNvPr id="35" name="TextBox 34"/>
+              <a:t>↑ owner-scoped: you edit / delete only your own mice (managers &amp; Leo: any)</a:t>
+            </a:r>
+          </a:p>
+        </p:txBody>
+      </p:sp>
+      <p:sp>
+        <p:nvSpPr>
+          <p:cNvPr id="39" name="TextBox 38"/>
           <p:cNvSpPr txBox="1"/>
           <p:nvPr/>
         </p:nvSpPr>
         <p:spPr>
           <a:xfrm>
-            <a:off x="320040" y="4160520"/>
-            <a:ext cx="4572000" cy="274320"/>
+            <a:off x="9281160" y="3346704"/>
+            <a:ext cx="2743200" cy="274320"/>
+          </a:xfrm>
+          <a:prstGeom prst="rect">
+            <a:avLst/>
+          </a:prstGeom>
+          <a:noFill/>
+        </p:spPr>
+        <p:txBody>
+          <a:bodyPr wrap="square" anchor="t">
+            <a:spAutoFit/>
+          </a:bodyPr>
+          <a:lstStyle/>
+          <a:p>
+            <a:pPr algn="l"/>
+            <a:r>
+              <a:rPr sz="1000" b="1" i="1">
+                <a:solidFill>
+                  <a:srgbClr val="64748B"/>
+                </a:solidFill>
+                <a:latin typeface="Calibri"/>
+              </a:rPr>
+              <a:t>Also in the app:</a:t>
+            </a:r>
+          </a:p>
+        </p:txBody>
+      </p:sp>
+      <p:sp>
+        <p:nvSpPr>
+          <p:cNvPr id="40" name="Rounded Rectangle 39"/>
+          <p:cNvSpPr/>
+          <p:nvPr/>
+        </p:nvSpPr>
+        <p:spPr>
+          <a:xfrm>
+            <a:off x="9281160" y="3621024"/>
+            <a:ext cx="2697480" cy="566928"/>
+          </a:xfrm>
+          <a:prstGeom prst="roundRect">
+            <a:avLst/>
+          </a:prstGeom>
+          <a:solidFill>
+            <a:srgbClr val="7C3AED"/>
+          </a:solidFill>
+          <a:ln>
+            <a:noFill/>
+          </a:ln>
+          <a:effectLst/>
+        </p:spPr>
+        <p:style>
+          <a:lnRef idx="1">
+            <a:schemeClr val="accent1"/>
+          </a:lnRef>
+          <a:fillRef idx="3">
+            <a:schemeClr val="accent1"/>
+          </a:fillRef>
+          <a:effectRef idx="2">
+            <a:schemeClr val="accent1"/>
+          </a:effectRef>
+          <a:fontRef idx="minor">
+            <a:schemeClr val="lt1"/>
+          </a:fontRef>
+        </p:style>
+        <p:txBody>
+          <a:bodyPr rtlCol="0" anchor="ctr" wrap="square" lIns="45720" rIns="45720"/>
+          <a:lstStyle/>
+          <a:p>
+            <a:pPr algn="ctr"/>
+            <a:r>
+              <a:rPr sz="1000" b="1">
+                <a:solidFill>
+                  <a:srgbClr val="FFFFFF"/>
+                </a:solidFill>
+                <a:latin typeface="Calibri"/>
+              </a:rPr>
+              <a:t>😇 Guardian Angels · 🕯️ In Memoriam</a:t>
+            </a:r>
+          </a:p>
+          <a:p>
+            <a:pPr algn="ctr"/>
+            <a:r>
+              <a:rPr sz="800">
+                <a:solidFill>
+                  <a:srgbClr val="FFFFFF"/>
+                </a:solidFill>
+                <a:latin typeface="Calibri"/>
+              </a:rPr>
+              <a:t>pet photos + a warm daily greeting</a:t>
+            </a:r>
+          </a:p>
+        </p:txBody>
+      </p:sp>
+      <p:sp>
+        <p:nvSpPr>
+          <p:cNvPr id="41" name="TextBox 40"/>
+          <p:cNvSpPr txBox="1"/>
+          <p:nvPr/>
+        </p:nvSpPr>
+        <p:spPr>
+          <a:xfrm>
+            <a:off x="320040" y="4187952"/>
+            <a:ext cx="5486400" cy="274320"/>
           </a:xfrm>
           <a:prstGeom prst="rect">
             <a:avLst/>
@@ -5321,21 +5600,21 @@
                 </a:solidFill>
                 <a:latin typeface="Calibri"/>
               </a:rPr>
-              <a:t>Requests &amp; email notifications:</a:t>
-            </a:r>
-          </a:p>
-        </p:txBody>
-      </p:sp>
-      <p:sp>
-        <p:nvSpPr>
-          <p:cNvPr id="36" name="Rounded Rectangle 35"/>
+              <a:t>Requests, the breeding board &amp; email:</a:t>
+            </a:r>
+          </a:p>
+        </p:txBody>
+      </p:sp>
+      <p:sp>
+        <p:nvSpPr>
+          <p:cNvPr id="42" name="Rounded Rectangle 41"/>
           <p:cNvSpPr/>
           <p:nvPr/>
         </p:nvSpPr>
         <p:spPr>
           <a:xfrm>
-            <a:off x="320040" y="4480560"/>
-            <a:ext cx="2148840" cy="914400"/>
+            <a:off x="320040" y="4526280"/>
+            <a:ext cx="2194560" cy="914400"/>
           </a:xfrm>
           <a:prstGeom prst="roundRect">
             <a:avLst/>
@@ -5386,21 +5665,21 @@
                 </a:solidFill>
                 <a:latin typeface="Calibri"/>
               </a:rPr>
-              <a:t>specific mouse # or by criteria</a:t>
-            </a:r>
-          </a:p>
-        </p:txBody>
-      </p:sp>
-      <p:sp>
-        <p:nvSpPr>
-          <p:cNvPr id="37" name="Rounded Rectangle 36"/>
+              <a:t>task type · which mice / what's needed</a:t>
+            </a:r>
+          </a:p>
+        </p:txBody>
+      </p:sp>
+      <p:sp>
+        <p:nvSpPr>
+          <p:cNvPr id="43" name="Rounded Rectangle 42"/>
           <p:cNvSpPr/>
           <p:nvPr/>
         </p:nvSpPr>
         <p:spPr>
           <a:xfrm>
-            <a:off x="2743200" y="4480560"/>
-            <a:ext cx="2514600" cy="914400"/>
+            <a:off x="2697480" y="4526280"/>
+            <a:ext cx="2148840" cy="914400"/>
           </a:xfrm>
           <a:prstGeom prst="roundRect">
             <a:avLst/>
@@ -5439,7 +5718,7 @@
                 </a:solidFill>
                 <a:latin typeface="Calibri"/>
               </a:rPr>
-              <a:t>Match a live mouse → Owner</a:t>
+              <a:t>Assign to people</a:t>
             </a:r>
           </a:p>
           <a:p>
@@ -5451,21 +5730,21 @@
                 </a:solidFill>
                 <a:latin typeface="Calibri"/>
               </a:rPr>
-              <a:t>none available → Breeding queue</a:t>
-            </a:r>
-          </a:p>
-        </p:txBody>
-      </p:sp>
-      <p:sp>
-        <p:nvSpPr>
-          <p:cNvPr id="38" name="Rounded Rectangle 37"/>
+              <a:t>one or several · picked by role</a:t>
+            </a:r>
+          </a:p>
+        </p:txBody>
+      </p:sp>
+      <p:sp>
+        <p:nvSpPr>
+          <p:cNvPr id="44" name="Rounded Rectangle 43"/>
           <p:cNvSpPr/>
           <p:nvPr/>
         </p:nvSpPr>
         <p:spPr>
           <a:xfrm>
-            <a:off x="5532120" y="4480560"/>
-            <a:ext cx="2331720" cy="914400"/>
+            <a:off x="5029200" y="4526280"/>
+            <a:ext cx="2148840" cy="914400"/>
           </a:xfrm>
           <a:prstGeom prst="roundRect">
             <a:avLst/>
@@ -5504,7 +5783,7 @@
                 </a:solidFill>
                 <a:latin typeface="Calibri"/>
               </a:rPr>
-              <a:t>Approve / transfer / route</a:t>
+              <a:t>Done → close</a:t>
             </a:r>
           </a:p>
           <a:p>
@@ -5516,20 +5795,20 @@
                 </a:solidFill>
                 <a:latin typeface="Calibri"/>
               </a:rPr>
-              <a:t>Manager or PI only</a:t>
-            </a:r>
-          </a:p>
-        </p:txBody>
-      </p:sp>
-      <p:sp>
-        <p:nvSpPr>
-          <p:cNvPr id="39" name="Rounded Rectangle 38"/>
+              <a:t>assignee marks done; manager closes</a:t>
+            </a:r>
+          </a:p>
+        </p:txBody>
+      </p:sp>
+      <p:sp>
+        <p:nvSpPr>
+          <p:cNvPr id="45" name="Rounded Rectangle 44"/>
           <p:cNvSpPr/>
           <p:nvPr/>
         </p:nvSpPr>
         <p:spPr>
           <a:xfrm>
-            <a:off x="8138160" y="4315968"/>
+            <a:off x="8138160" y="4297680"/>
             <a:ext cx="3840480" cy="566928"/>
           </a:xfrm>
           <a:prstGeom prst="roundRect">
@@ -5569,21 +5848,21 @@
                 </a:solidFill>
                 <a:latin typeface="Calibri"/>
               </a:rPr>
-              <a:t>Notify: Owner · Managers · PI</a:t>
-            </a:r>
-          </a:p>
-        </p:txBody>
-      </p:sp>
-      <p:sp>
-        <p:nvSpPr>
-          <p:cNvPr id="40" name="Rounded Rectangle 39"/>
+              <a:t>Notify the assignees</a:t>
+            </a:r>
+          </a:p>
+        </p:txBody>
+      </p:sp>
+      <p:sp>
+        <p:nvSpPr>
+          <p:cNvPr id="46" name="Rounded Rectangle 45"/>
           <p:cNvSpPr/>
           <p:nvPr/>
         </p:nvSpPr>
         <p:spPr>
           <a:xfrm>
-            <a:off x="8138160" y="5029200"/>
-            <a:ext cx="3840480" cy="822960"/>
+            <a:off x="8138160" y="5010912"/>
+            <a:ext cx="3840480" cy="841248"/>
           </a:xfrm>
           <a:prstGeom prst="roundRect">
             <a:avLst/>
@@ -5622,7 +5901,7 @@
                 </a:solidFill>
                 <a:latin typeface="Calibri"/>
               </a:rPr>
-              <a:t>Edge Function → Resend → emails</a:t>
+              <a:t>Edge Function → Resend → email</a:t>
             </a:r>
           </a:p>
           <a:p>
@@ -5634,21 +5913,21 @@
                 </a:solidFill>
                 <a:latin typeface="Calibri"/>
               </a:rPr>
-              <a:t>fallback: pre-filled draft email</a:t>
+              <a:t>with a link back to the app (else draft)</a:t>
             </a:r>
           </a:p>
         </p:txBody>
       </p:sp>
       <p:cxnSp>
         <p:nvCxnSpPr>
-          <p:cNvPr id="41" name="Connector 40"/>
+          <p:cNvPr id="47" name="Connector 46"/>
           <p:cNvCxnSpPr/>
           <p:nvPr/>
         </p:nvCxnSpPr>
         <p:spPr>
           <a:xfrm>
-            <a:off x="1028700" y="2487168"/>
-            <a:ext cx="342900" cy="1993392"/>
+            <a:off x="1028700" y="2359152"/>
+            <a:ext cx="388620" cy="2167128"/>
           </a:xfrm>
           <a:prstGeom prst="line">
             <a:avLst/>
@@ -5678,14 +5957,14 @@
       </p:cxnSp>
       <p:cxnSp>
         <p:nvCxnSpPr>
-          <p:cNvPr id="42" name="Connector 41"/>
+          <p:cNvPr id="48" name="Connector 47"/>
           <p:cNvCxnSpPr/>
           <p:nvPr/>
         </p:nvCxnSpPr>
         <p:spPr>
           <a:xfrm>
-            <a:off x="2468880" y="4937760"/>
-            <a:ext cx="274320" cy="0"/>
+            <a:off x="2514600" y="4983480"/>
+            <a:ext cx="182880" cy="0"/>
           </a:xfrm>
           <a:prstGeom prst="line">
             <a:avLst/>
@@ -5714,14 +5993,14 @@
       </p:cxnSp>
       <p:cxnSp>
         <p:nvCxnSpPr>
-          <p:cNvPr id="43" name="Connector 42"/>
+          <p:cNvPr id="49" name="Connector 48"/>
           <p:cNvCxnSpPr/>
           <p:nvPr/>
         </p:nvCxnSpPr>
         <p:spPr>
           <a:xfrm>
-            <a:off x="5257800" y="4937760"/>
-            <a:ext cx="274320" cy="0"/>
+            <a:off x="4846320" y="4983480"/>
+            <a:ext cx="182880" cy="0"/>
           </a:xfrm>
           <a:prstGeom prst="line">
             <a:avLst/>
@@ -5750,14 +6029,14 @@
       </p:cxnSp>
       <p:cxnSp>
         <p:nvCxnSpPr>
-          <p:cNvPr id="44" name="Connector 43"/>
+          <p:cNvPr id="50" name="Connector 49"/>
           <p:cNvCxnSpPr/>
           <p:nvPr/>
         </p:nvCxnSpPr>
         <p:spPr>
           <a:xfrm flipV="1">
-            <a:off x="7863840" y="4599431"/>
-            <a:ext cx="274320" cy="338329"/>
+            <a:off x="4846320" y="4581144"/>
+            <a:ext cx="3291840" cy="402336"/>
           </a:xfrm>
           <a:prstGeom prst="line">
             <a:avLst/>
@@ -5786,13 +6065,13 @@
       </p:cxnSp>
       <p:cxnSp>
         <p:nvCxnSpPr>
-          <p:cNvPr id="45" name="Connector 44"/>
+          <p:cNvPr id="51" name="Connector 50"/>
           <p:cNvCxnSpPr/>
           <p:nvPr/>
         </p:nvCxnSpPr>
         <p:spPr>
           <a:xfrm>
-            <a:off x="10058400" y="4882896"/>
+            <a:off x="10058400" y="4864608"/>
             <a:ext cx="0" cy="146304"/>
           </a:xfrm>
           <a:prstGeom prst="line">
@@ -5822,14 +6101,14 @@
       </p:cxnSp>
       <p:sp>
         <p:nvSpPr>
-          <p:cNvPr id="46" name="TextBox 45"/>
+          <p:cNvPr id="52" name="TextBox 51"/>
           <p:cNvSpPr txBox="1"/>
           <p:nvPr/>
         </p:nvSpPr>
         <p:spPr>
           <a:xfrm>
-            <a:off x="5394960" y="5440680"/>
-            <a:ext cx="2651760" cy="274320"/>
+            <a:off x="2743200" y="5486400"/>
+            <a:ext cx="4480560" cy="274320"/>
           </a:xfrm>
           <a:prstGeom prst="rect">
             <a:avLst/>
@@ -5850,21 +6129,21 @@
                 </a:solidFill>
                 <a:latin typeface="Calibri"/>
               </a:rPr>
-              <a:t>role decides who approves &amp; who gets emailed</a:t>
-            </a:r>
-          </a:p>
-        </p:txBody>
-      </p:sp>
-      <p:sp>
-        <p:nvSpPr>
-          <p:cNvPr id="47" name="Rounded Rectangle 46"/>
+              <a:t>'Request for mice' / 'Breed' collect on the Mice-needed board</a:t>
+            </a:r>
+          </a:p>
+        </p:txBody>
+      </p:sp>
+      <p:sp>
+        <p:nvSpPr>
+          <p:cNvPr id="53" name="Rounded Rectangle 52"/>
           <p:cNvSpPr/>
           <p:nvPr/>
         </p:nvSpPr>
         <p:spPr>
           <a:xfrm>
-            <a:off x="320040" y="6172200"/>
-            <a:ext cx="11567160" cy="502920"/>
+            <a:off x="320040" y="6199632"/>
+            <a:ext cx="11658600" cy="475488"/>
           </a:xfrm>
           <a:prstGeom prst="roundRect">
             <a:avLst/>
@@ -5905,7 +6184,7 @@
                 </a:solidFill>
                 <a:latin typeface="Calibri"/>
               </a:rPr>
-              <a:t>Same data, different views: everyone browses &amp; adds · 'My colony' is scoped to you · only Managers/PI approve &amp; route to breeding · every change is logged in audit_log</a:t>
+              <a:t>Same data, different views: everyone has their own login · 'My colony' + delete/edit are scoped to you · only Managers/PI/Web-maintainer act on any mouse · every change is logged in audit_log</a:t>
             </a:r>
           </a:p>
         </p:txBody>

</xml_diff>